<commit_message>
feat: upgrade pitch deck to seamlessly flow from Ingress/Egress 4-components to 6-industry matrix and OpenShip Multi-VEP dashboard
</commit_message>
<xml_diff>
--- a/DROS_DEMO.pptx
+++ b/DROS_DEMO.pptx
@@ -12,7 +12,6 @@
     <p:sldId id="260" r:id="rId11"/>
     <p:sldId id="261" r:id="rId12"/>
     <p:sldId id="262" r:id="rId13"/>
-    <p:sldId id="263" r:id="rId14"/>
   </p:sldIdLst>
   <p:sldSz cx="12191695" cy="6858000" type="screen4x3"/>
   <p:notesSz cx="6858000" cy="9144000"/>
@@ -3168,7 +3167,7 @@
               </a:defRPr>
             </a:pPr>
             <a:r>
-              <a:t>TRUSTWORTHY AI HACKATHON 2026  |  TEAM DROS SHOWCASE</a:t>
+              <a:t>TRUSTWORTHY AI HACKATHON 2026  |  FLAGSHIP PRESENTATION</a:t>
             </a:r>
           </a:p>
           <a:p>
@@ -3246,7 +3245,7 @@
               </a:defRPr>
             </a:pPr>
             <a:r>
-              <a:t>🏛️ DROS 雙重治理核心公理（開場核心洞察）</a:t>
+              <a:t>🏛️ DROS 雙重治理公理（開場核心洞察）</a:t>
             </a:r>
           </a:p>
           <a:p>
@@ -3390,7 +3389,7 @@
               </a:defRPr>
             </a:pPr>
             <a:r>
-              <a:t>● PROBLEM INSIGHT</a:t>
+              <a:t>● ARCHITECTURE ABSTRACTION</a:t>
             </a:r>
           </a:p>
           <a:p>
@@ -3402,7 +3401,7 @@
               </a:defRPr>
             </a:pPr>
             <a:r>
-              <a:t>產業致命痛點：企業只做了「核卡」，誰來管 Agent 執行期「刷卡」？</a:t>
+              <a:t>兩大根本治理邊界 ➔ 4 大 DROS 核心微內核部件</a:t>
             </a:r>
           </a:p>
         </p:txBody>
@@ -3415,8 +3414,8 @@
         </p:nvSpPr>
         <p:spPr>
           <a:xfrm>
-            <a:off x="731520" y="1371600"/>
-            <a:ext cx="5212080" cy="4937760"/>
+            <a:off x="731520" y="1280160"/>
+            <a:ext cx="5212080" cy="5029200"/>
           </a:xfrm>
           <a:prstGeom prst="roundRect">
             <a:avLst/>
@@ -3426,7 +3425,7 @@
           </a:solidFill>
           <a:ln w="19050">
             <a:solidFill>
-              <a:srgbClr val="F87171"/>
+              <a:srgbClr val="38BDF8"/>
             </a:solidFill>
           </a:ln>
         </p:spPr>
@@ -3449,110 +3448,110 @@
           <a:lstStyle/>
           <a:p>
             <a:pPr algn="ctr">
-              <a:defRPr sz="1600" b="1">
-                <a:solidFill>
-                  <a:srgbClr val="F87171"/>
-                </a:solidFill>
-              </a:defRPr>
-            </a:pPr>
-            <a:r>
-              <a:t>❌ 現狀：Application-First 治理的死穴</a:t>
-            </a:r>
-          </a:p>
-          <a:p>
-            <a:pPr>
-              <a:defRPr sz="1300" b="1">
+              <a:defRPr sz="1500" b="1">
+                <a:solidFill>
+                  <a:srgbClr val="38BDF8"/>
+                </a:solidFill>
+              </a:defRPr>
+            </a:pPr>
+            <a:r>
+              <a:t>📥 Ingress（輸入治理邊界）：資料最小化</a:t>
+            </a:r>
+          </a:p>
+          <a:p>
+            <a:pPr>
+              <a:defRPr sz="1200" b="1">
                 <a:solidFill>
                   <a:srgbClr val="F8FAFC"/>
                 </a:solidFill>
               </a:defRPr>
             </a:pPr>
             <a:r>
-              <a:t>• 身份核發即放任 (核卡不控刷)：</a:t>
-            </a:r>
-          </a:p>
-          <a:p>
-            <a:pPr>
-              <a:defRPr sz="1150">
+              <a:t>• 🧩 部件 ①：Safe Ingress Data Redactor</a:t>
+            </a:r>
+          </a:p>
+          <a:p>
+            <a:pPr>
+              <a:defRPr sz="1100">
                 <a:solidFill>
                   <a:srgbClr val="94A3B8"/>
                 </a:solidFill>
               </a:defRPr>
             </a:pPr>
             <a:r>
-              <a:t>   給予 Agent API Key 或憑證後，進入執行期完全失去微秒級行為約束。</a:t>
-            </a:r>
-          </a:p>
-          <a:p>
-            <a:pPr>
-              <a:defRPr sz="1300" b="1">
+              <a:t>   動態正則/NER 遮蔽引擎 + ZKP-Lite 零知識證明門閥。</a:t>
+            </a:r>
+          </a:p>
+          <a:p>
+            <a:pPr>
+              <a:defRPr sz="1200" b="1">
                 <a:solidFill>
                   <a:srgbClr val="F8FAFC"/>
                 </a:solidFill>
               </a:defRPr>
             </a:pPr>
             <a:r>
-              <a:t>• Prompt Injection 越獄破壞：</a:t>
-            </a:r>
-          </a:p>
-          <a:p>
-            <a:pPr>
-              <a:defRPr sz="1150">
+              <a:t>• 🛡️ 涵蓋 6P：P4. Policy Gate (隱私與最小化)</a:t>
+            </a:r>
+          </a:p>
+          <a:p>
+            <a:pPr>
+              <a:defRPr sz="1100">
                 <a:solidFill>
                   <a:srgbClr val="94A3B8"/>
                 </a:solidFill>
               </a:defRPr>
             </a:pPr>
             <a:r>
-              <a:t>   黑客透過注入攻擊催眠 Agent，強制其發起未授權 API 呼叫與機密外洩。</a:t>
-            </a:r>
-          </a:p>
-          <a:p>
-            <a:pPr>
-              <a:defRPr sz="1300" b="1">
+              <a:t>   徹底隔離 18 項 PHI、BOM 原料成本、工廠良率與薪資帳密。</a:t>
+            </a:r>
+          </a:p>
+          <a:p>
+            <a:pPr>
+              <a:defRPr sz="1200" b="1">
                 <a:solidFill>
                   <a:srgbClr val="F8FAFC"/>
                 </a:solidFill>
               </a:defRPr>
             </a:pPr>
             <a:r>
-              <a:t>• 事後無法法庭問責：</a:t>
-            </a:r>
-          </a:p>
-          <a:p>
-            <a:pPr>
-              <a:defRPr sz="1150">
+              <a:t>• 🧩 部件 ②：DIT Token Principal Injector</a:t>
+            </a:r>
+          </a:p>
+          <a:p>
+            <a:pPr>
+              <a:defRPr sz="1100">
                 <a:solidFill>
                   <a:srgbClr val="94A3B8"/>
                 </a:solidFill>
               </a:defRPr>
             </a:pPr>
             <a:r>
-              <a:t>   傳統 Log 缺乏密碼學前後哈希鏈結，事後串供偽造難以被法院採信。</a:t>
-            </a:r>
-          </a:p>
-          <a:p>
-            <a:pPr>
-              <a:defRPr sz="1300" b="1">
+              <a:t>   確定性身分憑證注入器，採用 Ed25519 密碼學簽名。</a:t>
+            </a:r>
+          </a:p>
+          <a:p>
+            <a:pPr>
+              <a:defRPr sz="1200" b="1">
                 <a:solidFill>
                   <a:srgbClr val="F8FAFC"/>
                 </a:solidFill>
               </a:defRPr>
             </a:pPr>
             <a:r>
-              <a:t>• 昂貴且脆弱的軟防禦：</a:t>
-            </a:r>
-          </a:p>
-          <a:p>
-            <a:pPr>
-              <a:defRPr sz="1150">
+              <a:t>• 🛡️ 涵蓋 6P：P1. Principal + P2. Authorization</a:t>
+            </a:r>
+          </a:p>
+          <a:p>
+            <a:pPr>
+              <a:defRPr sz="1100">
                 <a:solidFill>
                   <a:srgbClr val="94A3B8"/>
                 </a:solidFill>
               </a:defRPr>
             </a:pPr>
             <a:r>
-              <a:t>   用另一隻 LLM 當裁判，延遲高達 2 秒且吞吐量雪崩，無法應對高頻場景。</a:t>
+              <a:t>   密碼學強綁定法人 vLEI、自然人 MyData 與 1:1:1 移工防偽。</a:t>
             </a:r>
           </a:p>
         </p:txBody>
@@ -3565,8 +3564,8 @@
         </p:nvSpPr>
         <p:spPr>
           <a:xfrm>
-            <a:off x="6248095" y="1371600"/>
-            <a:ext cx="5212080" cy="4937760"/>
+            <a:off x="6248095" y="1280160"/>
+            <a:ext cx="5212080" cy="5029200"/>
           </a:xfrm>
           <a:prstGeom prst="roundRect">
             <a:avLst/>
@@ -3576,7 +3575,7 @@
           </a:solidFill>
           <a:ln w="19050">
             <a:solidFill>
-              <a:srgbClr val="4ADE80"/>
+              <a:srgbClr val="C084FC"/>
             </a:solidFill>
           </a:ln>
         </p:spPr>
@@ -3599,110 +3598,110 @@
           <a:lstStyle/>
           <a:p>
             <a:pPr algn="ctr">
-              <a:defRPr sz="1600" b="1">
-                <a:solidFill>
-                  <a:srgbClr val="4ADE80"/>
-                </a:solidFill>
-              </a:defRPr>
-            </a:pPr>
-            <a:r>
-              <a:t>🛡️ DROS 解法：確定性帶內執行期門閥</a:t>
-            </a:r>
-          </a:p>
-          <a:p>
-            <a:pPr>
-              <a:defRPr sz="1300" b="1">
+              <a:defRPr sz="1500" b="1">
+                <a:solidFill>
+                  <a:srgbClr val="C084FC"/>
+                </a:solidFill>
+              </a:defRPr>
+            </a:pPr>
+            <a:r>
+              <a:t>📤 Egress（輸出執行邊界）：確定性門閥</a:t>
+            </a:r>
+          </a:p>
+          <a:p>
+            <a:pPr>
+              <a:defRPr sz="1200" b="1">
                 <a:solidFill>
                   <a:srgbClr val="F8FAFC"/>
                 </a:solidFill>
               </a:defRPr>
             </a:pPr>
             <a:r>
-              <a:t>• 管在 Execution Sink (刷卡點)：</a:t>
-            </a:r>
-          </a:p>
-          <a:p>
-            <a:pPr>
-              <a:defRPr sz="1150">
+              <a:t>• 🧩 部件 ③：C-ABI In-Band Policy Gate</a:t>
+            </a:r>
+          </a:p>
+          <a:p>
+            <a:pPr>
+              <a:defRPr sz="1100">
                 <a:solidFill>
                   <a:srgbClr val="94A3B8"/>
                 </a:solidFill>
               </a:defRPr>
             </a:pPr>
             <a:r>
-              <a:t>   不猜測 LLM 思考，只在 Agent 呼叫 Tool 的最後物理瞬間實施硬性裁決。</a:t>
-            </a:r>
-          </a:p>
-          <a:p>
-            <a:pPr>
-              <a:defRPr sz="1300" b="1">
+              <a:t>   二進位 C-ABI 帶內閘門，暫存器級 Capability Bitmaps 匹配。</a:t>
+            </a:r>
+          </a:p>
+          <a:p>
+            <a:pPr>
+              <a:defRPr sz="1200" b="1">
                 <a:solidFill>
                   <a:srgbClr val="F8FAFC"/>
                 </a:solidFill>
               </a:defRPr>
             </a:pPr>
             <a:r>
-              <a:t>• 26.1 μs C-ABI 帶內硬熔斷：</a:t>
-            </a:r>
-          </a:p>
-          <a:p>
-            <a:pPr>
-              <a:defRPr sz="1150">
+              <a:t>• 🛡️ 涵蓋 6P：P2. Scope 授權 + P3. Tool Bound 攔截</a:t>
+            </a:r>
+          </a:p>
+          <a:p>
+            <a:pPr>
+              <a:defRPr sz="1100">
                 <a:solidFill>
                   <a:srgbClr val="94A3B8"/>
                 </a:solidFill>
               </a:defRPr>
             </a:pPr>
             <a:r>
-              <a:t>   以二進位 ABI 嵌入函式鏈，未授權呼叫瞬間拋出 HTTP 403，AI 物理無法繞過。</a:t>
-            </a:r>
-          </a:p>
-          <a:p>
-            <a:pPr>
-              <a:defRPr sz="1300" b="1">
+              <a:t>   26.1 μs 內硬性熔斷 (HTTP 403)，AI 物理無法繞過。</a:t>
+            </a:r>
+          </a:p>
+          <a:p>
+            <a:pPr>
+              <a:defRPr sz="1200" b="1">
                 <a:solidFill>
                   <a:srgbClr val="F8FAFC"/>
                 </a:solidFill>
               </a:defRPr>
             </a:pPr>
             <a:r>
-              <a:t>• SHA-256 Merkle 證據鏈：</a:t>
-            </a:r>
-          </a:p>
-          <a:p>
-            <a:pPr>
-              <a:defRPr sz="1150">
+              <a:t>• 🧩 部件 ④：Merkle Chain &amp; RCU Revocation</a:t>
+            </a:r>
+          </a:p>
+          <a:p>
+            <a:pPr>
+              <a:defRPr sz="1100">
                 <a:solidFill>
                   <a:srgbClr val="94A3B8"/>
                 </a:solidFill>
               </a:defRPr>
             </a:pPr>
             <a:r>
-              <a:t>   每次放行、熔斷、掛起即時產出防篡改收據，具備不可否認性法庭效力。</a:t>
-            </a:r>
-          </a:p>
-          <a:p>
-            <a:pPr>
-              <a:defRPr sz="1300" b="1">
+              <a:t>   SHA-256 密碼學防篡改存證鏈 + O(1) 原子指針秒級撤銷。</a:t>
+            </a:r>
+          </a:p>
+          <a:p>
+            <a:pPr>
+              <a:defRPr sz="1200" b="1">
                 <a:solidFill>
                   <a:srgbClr val="F8FAFC"/>
                 </a:solidFill>
               </a:defRPr>
             </a:pPr>
             <a:r>
-              <a:t>• Zero-Heap 高頻極速架構：</a:t>
-            </a:r>
-          </a:p>
-          <a:p>
-            <a:pPr>
-              <a:defRPr sz="1150">
+              <a:t>• 🛡️ 涵蓋 6P：P5. Audit Log + P6. Revocation</a:t>
+            </a:r>
+          </a:p>
+          <a:p>
+            <a:pPr>
+              <a:defRPr sz="1100">
                 <a:solidFill>
                   <a:srgbClr val="94A3B8"/>
                 </a:solidFill>
               </a:defRPr>
             </a:pPr>
             <a:r>
-              <a:t>   暫存器級位元圖匹配，無 GC 停頓，每秒吞吐十萬級 Tool Call 穩健存活。</a:t>
+              <a:t>   產出法庭採信收據；管理員一鍵凍結權限秒級生效。</a:t>
             </a:r>
           </a:p>
         </p:txBody>
@@ -3798,7 +3797,7 @@
               </a:defRPr>
             </a:pPr>
             <a:r>
-              <a:t>● SYSTEMS PHILOSOPHY</a:t>
+              <a:t>● CROSS-INDUSTRY MAPPING</a:t>
             </a:r>
           </a:p>
           <a:p>
@@ -3810,7 +3809,583 @@
               </a:defRPr>
             </a:pPr>
             <a:r>
-              <a:t>抽象哲學：POSIX 與 DROS 在系統治理上的數學收斂</a:t>
+              <a:t>一底兜六業：六大產業痛點的 Ingress / Egress 統一機制對照</a:t>
+            </a:r>
+          </a:p>
+        </p:txBody>
+      </p:sp>
+      <p:sp>
+        <p:nvSpPr>
+          <p:cNvPr id="4" name="Rounded Rectangle 3"/>
+          <p:cNvSpPr/>
+          <p:nvPr/>
+        </p:nvSpPr>
+        <p:spPr>
+          <a:xfrm>
+            <a:off x="731520" y="1280160"/>
+            <a:ext cx="5212080" cy="1554480"/>
+          </a:xfrm>
+          <a:prstGeom prst="roundRect">
+            <a:avLst/>
+          </a:prstGeom>
+          <a:solidFill>
+            <a:srgbClr val="0F172A"/>
+          </a:solidFill>
+          <a:ln w="19050">
+            <a:solidFill>
+              <a:srgbClr val="38BDF8"/>
+            </a:solidFill>
+          </a:ln>
+        </p:spPr>
+        <p:style>
+          <a:lnRef idx="1">
+            <a:schemeClr val="accent1"/>
+          </a:lnRef>
+          <a:fillRef idx="3">
+            <a:schemeClr val="accent1"/>
+          </a:fillRef>
+          <a:effectRef idx="2">
+            <a:schemeClr val="accent1"/>
+          </a:effectRef>
+          <a:fontRef idx="minor">
+            <a:schemeClr val="lt1"/>
+          </a:fontRef>
+        </p:style>
+        <p:txBody>
+          <a:bodyPr rtlCol="0" anchor="ctr" wrap="square" lIns="274320" rIns="274320" tIns="228600" bIns="182880"/>
+          <a:lstStyle/>
+          <a:p>
+            <a:pPr algn="ctr">
+              <a:defRPr sz="1200" b="1">
+                <a:solidFill>
+                  <a:srgbClr val="38BDF8"/>
+                </a:solidFill>
+              </a:defRPr>
+            </a:pPr>
+            <a:r>
+              <a:t>🏭 Track 01 製造碳護照</a:t>
+            </a:r>
+          </a:p>
+          <a:p>
+            <a:pPr>
+              <a:defRPr sz="950">
+                <a:solidFill>
+                  <a:srgbClr val="F8FAFC"/>
+                </a:solidFill>
+              </a:defRPr>
+            </a:pPr>
+            <a:r>
+              <a:t>📥 Ingress: 動態 Redact：隔離 BOM 原料成本/良率，僅輸入碳排係數。</a:t>
+            </a:r>
+          </a:p>
+          <a:p>
+            <a:pPr>
+              <a:defRPr sz="950">
+                <a:solidFill>
+                  <a:srgbClr val="94A3B8"/>
+                </a:solidFill>
+              </a:defRPr>
+            </a:pPr>
+            <a:r>
+              <a:t>📤 Egress: CBAM 門閥：輸出機密瞬間熔斷，僅放行 ZKP 碳排憑證。</a:t>
+            </a:r>
+          </a:p>
+        </p:txBody>
+      </p:sp>
+      <p:sp>
+        <p:nvSpPr>
+          <p:cNvPr id="5" name="Rounded Rectangle 4"/>
+          <p:cNvSpPr/>
+          <p:nvPr/>
+        </p:nvSpPr>
+        <p:spPr>
+          <a:xfrm>
+            <a:off x="6248095" y="1280160"/>
+            <a:ext cx="5212080" cy="1554480"/>
+          </a:xfrm>
+          <a:prstGeom prst="roundRect">
+            <a:avLst/>
+          </a:prstGeom>
+          <a:solidFill>
+            <a:srgbClr val="0F172A"/>
+          </a:solidFill>
+          <a:ln w="19050">
+            <a:solidFill>
+              <a:srgbClr val="4ADE80"/>
+            </a:solidFill>
+          </a:ln>
+        </p:spPr>
+        <p:style>
+          <a:lnRef idx="1">
+            <a:schemeClr val="accent1"/>
+          </a:lnRef>
+          <a:fillRef idx="3">
+            <a:schemeClr val="accent1"/>
+          </a:fillRef>
+          <a:effectRef idx="2">
+            <a:schemeClr val="accent1"/>
+          </a:effectRef>
+          <a:fontRef idx="minor">
+            <a:schemeClr val="lt1"/>
+          </a:fontRef>
+        </p:style>
+        <p:txBody>
+          <a:bodyPr rtlCol="0" anchor="ctr" wrap="square" lIns="274320" rIns="274320" tIns="228600" bIns="182880"/>
+          <a:lstStyle/>
+          <a:p>
+            <a:pPr algn="ctr">
+              <a:defRPr sz="1200" b="1">
+                <a:solidFill>
+                  <a:srgbClr val="4ADE80"/>
+                </a:solidFill>
+              </a:defRPr>
+            </a:pPr>
+            <a:r>
+              <a:t>🏭 Track 02 電支 AML 風控</a:t>
+            </a:r>
+          </a:p>
+          <a:p>
+            <a:pPr>
+              <a:defRPr sz="950">
+                <a:solidFill>
+                  <a:srgbClr val="F8FAFC"/>
+                </a:solidFill>
+              </a:defRPr>
+            </a:pPr>
+            <a:r>
+              <a:t>📥 Ingress: 去識別化密態特徵：遮蔽姓名/身分證/帳戶明細，提供圖向量。</a:t>
+            </a:r>
+          </a:p>
+          <a:p>
+            <a:pPr>
+              <a:defRPr sz="950">
+                <a:solidFill>
+                  <a:srgbClr val="94A3B8"/>
+                </a:solidFill>
+              </a:defRPr>
+            </a:pPr>
+            <a:r>
+              <a:t>📤 Egress: 微秒支付阻斷：洗錢特徵瞬間 C-ABI 懸停，觸發雙簽。</a:t>
+            </a:r>
+          </a:p>
+        </p:txBody>
+      </p:sp>
+      <p:sp>
+        <p:nvSpPr>
+          <p:cNvPr id="6" name="Rounded Rectangle 5"/>
+          <p:cNvSpPr/>
+          <p:nvPr/>
+        </p:nvSpPr>
+        <p:spPr>
+          <a:xfrm>
+            <a:off x="731520" y="2971800"/>
+            <a:ext cx="5212080" cy="1554480"/>
+          </a:xfrm>
+          <a:prstGeom prst="roundRect">
+            <a:avLst/>
+          </a:prstGeom>
+          <a:solidFill>
+            <a:srgbClr val="0F172A"/>
+          </a:solidFill>
+          <a:ln w="19050">
+            <a:solidFill>
+              <a:srgbClr val="F87171"/>
+            </a:solidFill>
+          </a:ln>
+        </p:spPr>
+        <p:style>
+          <a:lnRef idx="1">
+            <a:schemeClr val="accent1"/>
+          </a:lnRef>
+          <a:fillRef idx="3">
+            <a:schemeClr val="accent1"/>
+          </a:fillRef>
+          <a:effectRef idx="2">
+            <a:schemeClr val="accent1"/>
+          </a:effectRef>
+          <a:fontRef idx="minor">
+            <a:schemeClr val="lt1"/>
+          </a:fontRef>
+        </p:style>
+        <p:txBody>
+          <a:bodyPr rtlCol="0" anchor="ctr" wrap="square" lIns="274320" rIns="274320" tIns="228600" bIns="182880"/>
+          <a:lstStyle/>
+          <a:p>
+            <a:pPr algn="ctr">
+              <a:defRPr sz="1200" b="1">
+                <a:solidFill>
+                  <a:srgbClr val="F87171"/>
+                </a:solidFill>
+              </a:defRPr>
+            </a:pPr>
+            <a:r>
+              <a:t>🏭 Track 03 醫療保險理賠</a:t>
+            </a:r>
+          </a:p>
+          <a:p>
+            <a:pPr>
+              <a:defRPr sz="950">
+                <a:solidFill>
+                  <a:srgbClr val="F8FAFC"/>
+                </a:solidFill>
+              </a:defRPr>
+            </a:pPr>
+            <a:r>
+              <a:t>📥 Ingress: 18項 PHI 自動遮蔽：病歷與基因嚴密隔離，輸入診斷碼/金額。</a:t>
+            </a:r>
+          </a:p>
+          <a:p>
+            <a:pPr>
+              <a:defRPr sz="950">
+                <a:solidFill>
+                  <a:srgbClr val="94A3B8"/>
+                </a:solidFill>
+              </a:defRPr>
+            </a:pPr>
+            <a:r>
+              <a:t>📤 Egress: 保險聯盟鏈對接：越權調閱 26.1μs 硬熔斷，放行出具 Merkle。</a:t>
+            </a:r>
+          </a:p>
+        </p:txBody>
+      </p:sp>
+      <p:sp>
+        <p:nvSpPr>
+          <p:cNvPr id="7" name="Rounded Rectangle 6"/>
+          <p:cNvSpPr/>
+          <p:nvPr/>
+        </p:nvSpPr>
+        <p:spPr>
+          <a:xfrm>
+            <a:off x="6248095" y="2971800"/>
+            <a:ext cx="5212080" cy="1554480"/>
+          </a:xfrm>
+          <a:prstGeom prst="roundRect">
+            <a:avLst/>
+          </a:prstGeom>
+          <a:solidFill>
+            <a:srgbClr val="0F172A"/>
+          </a:solidFill>
+          <a:ln w="19050">
+            <a:solidFill>
+              <a:srgbClr val="FBBF24"/>
+            </a:solidFill>
+          </a:ln>
+        </p:spPr>
+        <p:style>
+          <a:lnRef idx="1">
+            <a:schemeClr val="accent1"/>
+          </a:lnRef>
+          <a:fillRef idx="3">
+            <a:schemeClr val="accent1"/>
+          </a:fillRef>
+          <a:effectRef idx="2">
+            <a:schemeClr val="accent1"/>
+          </a:effectRef>
+          <a:fontRef idx="minor">
+            <a:schemeClr val="lt1"/>
+          </a:fontRef>
+        </p:style>
+        <p:txBody>
+          <a:bodyPr rtlCol="0" anchor="ctr" wrap="square" lIns="274320" rIns="274320" tIns="228600" bIns="182880"/>
+          <a:lstStyle/>
+          <a:p>
+            <a:pPr algn="ctr">
+              <a:defRPr sz="1200" b="1">
+                <a:solidFill>
+                  <a:srgbClr val="FBBF24"/>
+                </a:solidFill>
+              </a:defRPr>
+            </a:pPr>
+            <a:r>
+              <a:t>🏭 Track 04 政府跨機關代辦</a:t>
+            </a:r>
+          </a:p>
+          <a:p>
+            <a:pPr>
+              <a:defRPr sz="950">
+                <a:solidFill>
+                  <a:srgbClr val="F8FAFC"/>
+                </a:solidFill>
+              </a:defRPr>
+            </a:pPr>
+            <a:r>
+              <a:t>📥 Ingress: 三層代理過濾：事務所 vLEI 僅取所得級距，隔離完整稅籍。</a:t>
+            </a:r>
+          </a:p>
+          <a:p>
+            <a:pPr>
+              <a:defRPr sz="950">
+                <a:solidFill>
+                  <a:srgbClr val="94A3B8"/>
+                </a:solidFill>
+              </a:defRPr>
+            </a:pPr>
+            <a:r>
+              <a:t>📤 Egress: 代送件越權阻斷：越權調閱戶政瞬間攔截，出具 W3C VC 收據。</a:t>
+            </a:r>
+          </a:p>
+        </p:txBody>
+      </p:sp>
+      <p:sp>
+        <p:nvSpPr>
+          <p:cNvPr id="8" name="Rounded Rectangle 7"/>
+          <p:cNvSpPr/>
+          <p:nvPr/>
+        </p:nvSpPr>
+        <p:spPr>
+          <a:xfrm>
+            <a:off x="731520" y="4663440"/>
+            <a:ext cx="5212080" cy="1554480"/>
+          </a:xfrm>
+          <a:prstGeom prst="roundRect">
+            <a:avLst/>
+          </a:prstGeom>
+          <a:solidFill>
+            <a:srgbClr val="0F172A"/>
+          </a:solidFill>
+          <a:ln w="19050">
+            <a:solidFill>
+              <a:srgbClr val="C084FC"/>
+            </a:solidFill>
+          </a:ln>
+        </p:spPr>
+        <p:style>
+          <a:lnRef idx="1">
+            <a:schemeClr val="accent1"/>
+          </a:lnRef>
+          <a:fillRef idx="3">
+            <a:schemeClr val="accent1"/>
+          </a:fillRef>
+          <a:effectRef idx="2">
+            <a:schemeClr val="accent1"/>
+          </a:effectRef>
+          <a:fontRef idx="minor">
+            <a:schemeClr val="lt1"/>
+          </a:fontRef>
+        </p:style>
+        <p:txBody>
+          <a:bodyPr rtlCol="0" anchor="ctr" wrap="square" lIns="274320" rIns="274320" tIns="228600" bIns="182880"/>
+          <a:lstStyle/>
+          <a:p>
+            <a:pPr algn="ctr">
+              <a:defRPr sz="1200" b="1">
+                <a:solidFill>
+                  <a:srgbClr val="C084FC"/>
+                </a:solidFill>
+              </a:defRPr>
+            </a:pPr>
+            <a:r>
+              <a:t>🏭 Track 05 移工普惠金融</a:t>
+            </a:r>
+          </a:p>
+          <a:p>
+            <a:pPr>
+              <a:defRPr sz="950">
+                <a:solidFill>
+                  <a:srgbClr val="F8FAFC"/>
+                </a:solidFill>
+              </a:defRPr>
+            </a:pPr>
+            <a:r>
+              <a:t>📥 Ingress: 1:1:1 複合身分綁定：護照+居留證+門號為 DIT，隱匿密碼。</a:t>
+            </a:r>
+          </a:p>
+          <a:p>
+            <a:pPr>
+              <a:defRPr sz="950">
+                <a:solidFill>
+                  <a:srgbClr val="94A3B8"/>
+                </a:solidFill>
+              </a:defRPr>
+            </a:pPr>
+            <a:r>
+              <a:t>📤 Egress: SIM Swap 連鎖凍結：換卡/異常轉帳 O(1) 原子指針秒凍結。</a:t>
+            </a:r>
+          </a:p>
+        </p:txBody>
+      </p:sp>
+      <p:sp>
+        <p:nvSpPr>
+          <p:cNvPr id="9" name="Rounded Rectangle 8"/>
+          <p:cNvSpPr/>
+          <p:nvPr/>
+        </p:nvSpPr>
+        <p:spPr>
+          <a:xfrm>
+            <a:off x="6248095" y="4663440"/>
+            <a:ext cx="5212080" cy="1554480"/>
+          </a:xfrm>
+          <a:prstGeom prst="roundRect">
+            <a:avLst/>
+          </a:prstGeom>
+          <a:solidFill>
+            <a:srgbClr val="0F172A"/>
+          </a:solidFill>
+          <a:ln w="19050">
+            <a:solidFill>
+              <a:srgbClr val="38BDF8"/>
+            </a:solidFill>
+          </a:ln>
+        </p:spPr>
+        <p:style>
+          <a:lnRef idx="1">
+            <a:schemeClr val="accent1"/>
+          </a:lnRef>
+          <a:fillRef idx="3">
+            <a:schemeClr val="accent1"/>
+          </a:fillRef>
+          <a:effectRef idx="2">
+            <a:schemeClr val="accent1"/>
+          </a:effectRef>
+          <a:fontRef idx="minor">
+            <a:schemeClr val="lt1"/>
+          </a:fontRef>
+        </p:style>
+        <p:txBody>
+          <a:bodyPr rtlCol="0" anchor="ctr" wrap="square" lIns="274320" rIns="274320" tIns="228600" bIns="182880"/>
+          <a:lstStyle/>
+          <a:p>
+            <a:pPr algn="ctr">
+              <a:defRPr sz="1200" b="1">
+                <a:solidFill>
+                  <a:srgbClr val="38BDF8"/>
+                </a:solidFill>
+              </a:defRPr>
+            </a:pPr>
+            <a:r>
+              <a:t>🏭 Track 06 供應鏈 RBA 稽核</a:t>
+            </a:r>
+          </a:p>
+          <a:p>
+            <a:pPr>
+              <a:defRPr sz="950">
+                <a:solidFill>
+                  <a:srgbClr val="F8FAFC"/>
+                </a:solidFill>
+              </a:defRPr>
+            </a:pPr>
+            <a:r>
+              <a:t>📥 Ingress: 選擇性揭露 ZKP-Lite：採購 AI 僅讀合規 TRUE，無法讀薪資。</a:t>
+            </a:r>
+          </a:p>
+          <a:p>
+            <a:pPr>
+              <a:defRPr sz="950">
+                <a:solidFill>
+                  <a:srgbClr val="94A3B8"/>
+                </a:solidFill>
+              </a:defRPr>
+            </a:pPr>
+            <a:r>
+              <a:t>📤 Egress: 雇主付費存證：物理鎖定採購 Tool，越權即熔斷產出收據。</a:t>
+            </a:r>
+          </a:p>
+        </p:txBody>
+      </p:sp>
+    </p:spTree>
+  </p:cSld>
+  <p:clrMapOvr>
+    <a:masterClrMapping/>
+  </p:clrMapOvr>
+</p:sld>
+</file>
+
+<file path=ppt/slides/slide4.xml><?xml version="1.0" encoding="utf-8"?>
+<p:sld xmlns:a="http://schemas.openxmlformats.org/drawingml/2006/main" xmlns:p="http://schemas.openxmlformats.org/presentationml/2006/main" xmlns:r="http://schemas.openxmlformats.org/officeDocument/2006/relationships">
+  <p:cSld>
+    <p:spTree>
+      <p:nvGrpSpPr>
+        <p:cNvPr id="1" name=""/>
+        <p:cNvGrpSpPr/>
+        <p:nvPr/>
+      </p:nvGrpSpPr>
+      <p:grpSpPr/>
+      <p:sp>
+        <p:nvSpPr>
+          <p:cNvPr id="2" name="Rectangle 1"/>
+          <p:cNvSpPr/>
+          <p:nvPr/>
+        </p:nvSpPr>
+        <p:spPr>
+          <a:xfrm>
+            <a:off x="0" y="0"/>
+            <a:ext cx="12191695" cy="6858000"/>
+          </a:xfrm>
+          <a:prstGeom prst="rect">
+            <a:avLst/>
+          </a:prstGeom>
+          <a:solidFill>
+            <a:srgbClr val="070A12"/>
+          </a:solidFill>
+          <a:ln>
+            <a:noFill/>
+          </a:ln>
+        </p:spPr>
+        <p:style>
+          <a:lnRef idx="1">
+            <a:schemeClr val="accent1"/>
+          </a:lnRef>
+          <a:fillRef idx="3">
+            <a:schemeClr val="accent1"/>
+          </a:fillRef>
+          <a:effectRef idx="2">
+            <a:schemeClr val="accent1"/>
+          </a:effectRef>
+          <a:fontRef idx="minor">
+            <a:schemeClr val="lt1"/>
+          </a:fontRef>
+        </p:style>
+        <p:txBody>
+          <a:bodyPr rtlCol="0" anchor="ctr"/>
+          <a:lstStyle/>
+          <a:p>
+            <a:pPr algn="ctr"/>
+          </a:p>
+        </p:txBody>
+      </p:sp>
+      <p:sp>
+        <p:nvSpPr>
+          <p:cNvPr id="3" name="TextBox 2"/>
+          <p:cNvSpPr txBox="1"/>
+          <p:nvPr/>
+        </p:nvSpPr>
+        <p:spPr>
+          <a:xfrm>
+            <a:off x="731520" y="365760"/>
+            <a:ext cx="10728655" cy="822960"/>
+          </a:xfrm>
+          <a:prstGeom prst="rect">
+            <a:avLst/>
+          </a:prstGeom>
+          <a:noFill/>
+        </p:spPr>
+        <p:txBody>
+          <a:bodyPr wrap="square" lIns="0" rIns="0" tIns="0" bIns="0">
+            <a:spAutoFit/>
+          </a:bodyPr>
+          <a:lstStyle/>
+          <a:p>
+            <a:pPr>
+              <a:defRPr sz="1100" b="1">
+                <a:solidFill>
+                  <a:srgbClr val="38BDF8"/>
+                </a:solidFill>
+              </a:defRPr>
+            </a:pPr>
+            <a:r>
+              <a:t>● ARCHITECTURE MAP</a:t>
+            </a:r>
+          </a:p>
+          <a:p>
+            <a:pPr>
+              <a:defRPr sz="2200" b="1">
+                <a:solidFill>
+                  <a:srgbClr val="F8FAFC"/>
+                </a:solidFill>
+              </a:defRPr>
+            </a:pPr>
+            <a:r>
+              <a:t>OpenShip × Multi-VEP 全景技術架構與現實信任接軌</a:t>
             </a:r>
           </a:p>
         </p:txBody>
@@ -3857,26 +4432,34 @@
           <a:lstStyle/>
           <a:p>
             <a:pPr algn="ctr">
-              <a:defRPr sz="1300" i="1">
+              <a:defRPr sz="1400" b="1">
                 <a:solidFill>
                   <a:srgbClr val="38BDF8"/>
                 </a:solidFill>
               </a:defRPr>
             </a:pPr>
             <a:r>
-              <a:t>💡 POSIX did not eliminate application complexity; it eliminated the need for every application to reinvent the underlying operating-system interface.</a:t>
-            </a:r>
-          </a:p>
-          <a:p>
-            <a:pPr>
-              <a:defRPr sz="1350" b="1">
+              <a:t>🌐 現實世界三大信任錨點 (Real-World Trust Anchors)</a:t>
+            </a:r>
+          </a:p>
+          <a:p>
+            <a:pPr>
+              <a:defRPr sz="1150">
                 <a:solidFill>
                   <a:srgbClr val="F8FAFC"/>
                 </a:solidFill>
               </a:defRPr>
             </a:pPr>
             <a:r>
-              <a:t>DROS 將治理下沉為共享基礎設施：治理複雜度不再隨應用程式數量增長 (Governance complexity stops scaling with application count)！</a:t>
+              <a:t>• 法人端：GLEIF 國際組織 vLEI 憑證與法定代理人授權鏈 (Mandates)</a:t>
+            </a:r>
+            <a:br/>
+            <a:r>
+              <a:t>• 個人端：W3C DID / 數位身分皮夾與使用者自主宣告簽署</a:t>
+            </a:r>
+            <a:br/>
+            <a:r>
+              <a:t>• 國家端：數位發展部 MyData / FIDO 雙軌整合與法庭可採信證據邊界</a:t>
             </a:r>
           </a:p>
         </p:txBody>
@@ -3890,315 +4473,7 @@
         <p:spPr>
           <a:xfrm>
             <a:off x="731520" y="2834640"/>
-            <a:ext cx="10728655" cy="3474720"/>
-          </a:xfrm>
-          <a:prstGeom prst="roundRect">
-            <a:avLst/>
-          </a:prstGeom>
-          <a:solidFill>
-            <a:srgbClr val="0F172A"/>
-          </a:solidFill>
-          <a:ln w="19050">
-            <a:solidFill>
-              <a:srgbClr val="C084FC"/>
-            </a:solidFill>
-          </a:ln>
-        </p:spPr>
-        <p:style>
-          <a:lnRef idx="1">
-            <a:schemeClr val="accent1"/>
-          </a:lnRef>
-          <a:fillRef idx="3">
-            <a:schemeClr val="accent1"/>
-          </a:fillRef>
-          <a:effectRef idx="2">
-            <a:schemeClr val="accent1"/>
-          </a:effectRef>
-          <a:fontRef idx="minor">
-            <a:schemeClr val="lt1"/>
-          </a:fontRef>
-        </p:style>
-        <p:txBody>
-          <a:bodyPr rtlCol="0" anchor="ctr" wrap="square" lIns="274320" rIns="274320" tIns="228600" bIns="182880"/>
-          <a:lstStyle/>
-          <a:p>
-            <a:pPr algn="ctr">
-              <a:defRPr sz="1400" b="1">
-                <a:solidFill>
-                  <a:srgbClr val="C084FC"/>
-                </a:solidFill>
-              </a:defRPr>
-            </a:pPr>
-            <a:r>
-              <a:t>📊 傳統 OS (POSIX) vs. DROS 確定性 AI Agent 治理作業系統</a:t>
-            </a:r>
-          </a:p>
-          <a:p>
-            <a:pPr>
-              <a:defRPr sz="1100">
-                <a:solidFill>
-                  <a:srgbClr val="F8FAFC"/>
-                </a:solidFill>
-              </a:defRPr>
-            </a:pPr>
-            <a:r>
-              <a:t>• 1. 執行主體 (Subject) │ POSIX: Process PID / User UID ➔ DROS: DIT Token (強綁定法人 vLEI / 自然人 MyData)</a:t>
-            </a:r>
-          </a:p>
-          <a:p>
-            <a:pPr>
-              <a:defRPr sz="1100">
-                <a:solidFill>
-                  <a:srgbClr val="F8FAFC"/>
-                </a:solidFill>
-              </a:defRPr>
-            </a:pPr>
-            <a:r>
-              <a:t>• 2. 權限邊界 (Permission) │ POSIX: File Permissions / POSIX ACL (rwx) ➔ DROS: Zero-Heap Capability Bitmaps (暫存器級位元圖)</a:t>
-            </a:r>
-          </a:p>
-          <a:p>
-            <a:pPr>
-              <a:defRPr sz="1100">
-                <a:solidFill>
-                  <a:srgbClr val="F8FAFC"/>
-                </a:solidFill>
-              </a:defRPr>
-            </a:pPr>
-            <a:r>
-              <a:t>• 3. 系統調用保護 (Syscall) │ POSIX: Ring 0 / Kernel Mode 記憶體隔離 ➔ DROS: C-ABI 帶內攔截閘門 (In-Band VEP Gate)</a:t>
-            </a:r>
-          </a:p>
-          <a:p>
-            <a:pPr>
-              <a:defRPr sz="1100">
-                <a:solidFill>
-                  <a:srgbClr val="F8FAFC"/>
-                </a:solidFill>
-              </a:defRPr>
-            </a:pPr>
-            <a:r>
-              <a:t>• 4. 異常處理 (Fault Handling) │ POSIX: SIGSEGV / SIGKILL 核心崩潰保護 ➔ DROS: 26.1 μs 帶內硬熔斷 (HTTP 403 Hard Circuit-Break)</a:t>
-            </a:r>
-          </a:p>
-          <a:p>
-            <a:pPr>
-              <a:defRPr sz="1100">
-                <a:solidFill>
-                  <a:srgbClr val="F8FAFC"/>
-                </a:solidFill>
-              </a:defRPr>
-            </a:pPr>
-            <a:r>
-              <a:t>• 5. 存取稽核 (Auditing) │ POSIX: auditd / Linux Journal 日誌 ➔ DROS: SHA-256 Merkle Hash 密碼學法庭存證鏈</a:t>
-            </a:r>
-          </a:p>
-          <a:p>
-            <a:pPr>
-              <a:defRPr sz="1100">
-                <a:solidFill>
-                  <a:srgbClr val="F8FAFC"/>
-                </a:solidFill>
-              </a:defRPr>
-            </a:pPr>
-            <a:r>
-              <a:t>• 6. 資源回收 (Revocation) │ POSIX: kill -9 / Process Terminate ➔ DROS: O(1) RCU 原子指針常數時間秒級動態撤銷</a:t>
-            </a:r>
-          </a:p>
-        </p:txBody>
-      </p:sp>
-    </p:spTree>
-  </p:cSld>
-  <p:clrMapOvr>
-    <a:masterClrMapping/>
-  </p:clrMapOvr>
-</p:sld>
-</file>
-
-<file path=ppt/slides/slide4.xml><?xml version="1.0" encoding="utf-8"?>
-<p:sld xmlns:a="http://schemas.openxmlformats.org/drawingml/2006/main" xmlns:p="http://schemas.openxmlformats.org/presentationml/2006/main" xmlns:r="http://schemas.openxmlformats.org/officeDocument/2006/relationships">
-  <p:cSld>
-    <p:spTree>
-      <p:nvGrpSpPr>
-        <p:cNvPr id="1" name=""/>
-        <p:cNvGrpSpPr/>
-        <p:nvPr/>
-      </p:nvGrpSpPr>
-      <p:grpSpPr/>
-      <p:sp>
-        <p:nvSpPr>
-          <p:cNvPr id="2" name="Rectangle 1"/>
-          <p:cNvSpPr/>
-          <p:nvPr/>
-        </p:nvSpPr>
-        <p:spPr>
-          <a:xfrm>
-            <a:off x="0" y="0"/>
-            <a:ext cx="12191695" cy="6858000"/>
-          </a:xfrm>
-          <a:prstGeom prst="rect">
-            <a:avLst/>
-          </a:prstGeom>
-          <a:solidFill>
-            <a:srgbClr val="070A12"/>
-          </a:solidFill>
-          <a:ln>
-            <a:noFill/>
-          </a:ln>
-        </p:spPr>
-        <p:style>
-          <a:lnRef idx="1">
-            <a:schemeClr val="accent1"/>
-          </a:lnRef>
-          <a:fillRef idx="3">
-            <a:schemeClr val="accent1"/>
-          </a:fillRef>
-          <a:effectRef idx="2">
-            <a:schemeClr val="accent1"/>
-          </a:effectRef>
-          <a:fontRef idx="minor">
-            <a:schemeClr val="lt1"/>
-          </a:fontRef>
-        </p:style>
-        <p:txBody>
-          <a:bodyPr rtlCol="0" anchor="ctr"/>
-          <a:lstStyle/>
-          <a:p>
-            <a:pPr algn="ctr"/>
-          </a:p>
-        </p:txBody>
-      </p:sp>
-      <p:sp>
-        <p:nvSpPr>
-          <p:cNvPr id="3" name="TextBox 2"/>
-          <p:cNvSpPr txBox="1"/>
-          <p:nvPr/>
-        </p:nvSpPr>
-        <p:spPr>
-          <a:xfrm>
-            <a:off x="731520" y="365760"/>
-            <a:ext cx="10728655" cy="822960"/>
-          </a:xfrm>
-          <a:prstGeom prst="rect">
-            <a:avLst/>
-          </a:prstGeom>
-          <a:noFill/>
-        </p:spPr>
-        <p:txBody>
-          <a:bodyPr wrap="square" lIns="0" rIns="0" tIns="0" bIns="0">
-            <a:spAutoFit/>
-          </a:bodyPr>
-          <a:lstStyle/>
-          <a:p>
-            <a:pPr>
-              <a:defRPr sz="1100" b="1">
-                <a:solidFill>
-                  <a:srgbClr val="38BDF8"/>
-                </a:solidFill>
-              </a:defRPr>
-            </a:pPr>
-            <a:r>
-              <a:t>● ARCHITECTURE MAP</a:t>
-            </a:r>
-          </a:p>
-          <a:p>
-            <a:pPr>
-              <a:defRPr sz="2200" b="1">
-                <a:solidFill>
-                  <a:srgbClr val="F8FAFC"/>
-                </a:solidFill>
-              </a:defRPr>
-            </a:pPr>
-            <a:r>
-              <a:t>OpenShip × Multi-VEP 全景技術架構與現實信任接軌</a:t>
-            </a:r>
-          </a:p>
-        </p:txBody>
-      </p:sp>
-      <p:sp>
-        <p:nvSpPr>
-          <p:cNvPr id="4" name="Rounded Rectangle 3"/>
-          <p:cNvSpPr/>
-          <p:nvPr/>
-        </p:nvSpPr>
-        <p:spPr>
-          <a:xfrm>
-            <a:off x="731520" y="1280160"/>
-            <a:ext cx="10728655" cy="1463040"/>
-          </a:xfrm>
-          <a:prstGeom prst="roundRect">
-            <a:avLst/>
-          </a:prstGeom>
-          <a:solidFill>
-            <a:srgbClr val="0F172A"/>
-          </a:solidFill>
-          <a:ln w="19050">
-            <a:solidFill>
-              <a:srgbClr val="38BDF8"/>
-            </a:solidFill>
-          </a:ln>
-        </p:spPr>
-        <p:style>
-          <a:lnRef idx="1">
-            <a:schemeClr val="accent1"/>
-          </a:lnRef>
-          <a:fillRef idx="3">
-            <a:schemeClr val="accent1"/>
-          </a:fillRef>
-          <a:effectRef idx="2">
-            <a:schemeClr val="accent1"/>
-          </a:effectRef>
-          <a:fontRef idx="minor">
-            <a:schemeClr val="lt1"/>
-          </a:fontRef>
-        </p:style>
-        <p:txBody>
-          <a:bodyPr rtlCol="0" anchor="ctr" wrap="square" lIns="274320" rIns="274320" tIns="228600" bIns="182880"/>
-          <a:lstStyle/>
-          <a:p>
-            <a:pPr algn="ctr">
-              <a:defRPr sz="1400" b="1">
-                <a:solidFill>
-                  <a:srgbClr val="38BDF8"/>
-                </a:solidFill>
-              </a:defRPr>
-            </a:pPr>
-            <a:r>
-              <a:t>🌐 頂層：現實世界三大信任錨點 (Real-World Trust Anchors)</a:t>
-            </a:r>
-          </a:p>
-          <a:p>
-            <a:pPr>
-              <a:defRPr sz="1200">
-                <a:solidFill>
-                  <a:srgbClr val="F8FAFC"/>
-                </a:solidFill>
-              </a:defRPr>
-            </a:pPr>
-            <a:r>
-              <a:t>• 法人信任：GLEIF 國際組織 vLEI 憑證與法定代理人授權鏈 (Mandates)</a:t>
-            </a:r>
-            <a:br/>
-            <a:r>
-              <a:t>• 個人信任：W3C DID / 數位身分皮夾與使用者自主宣告簽署</a:t>
-            </a:r>
-            <a:br/>
-            <a:r>
-              <a:t>• 國家法規：數位發展部 MyData / FIDO 雙軌整合與法庭可採信證據邊界</a:t>
-            </a:r>
-          </a:p>
-        </p:txBody>
-      </p:sp>
-      <p:sp>
-        <p:nvSpPr>
-          <p:cNvPr id="5" name="Rounded Rectangle 4"/>
-          <p:cNvSpPr/>
-          <p:nvPr/>
-        </p:nvSpPr>
-        <p:spPr>
-          <a:xfrm>
-            <a:off x="731520" y="2926080"/>
-            <a:ext cx="5212080" cy="3383280"/>
+            <a:ext cx="5212080" cy="3474720"/>
           </a:xfrm>
           <a:prstGeom prst="roundRect">
             <a:avLst/>
@@ -4275,8 +4550,8 @@
         </p:nvSpPr>
         <p:spPr>
           <a:xfrm>
-            <a:off x="6248095" y="2926080"/>
-            <a:ext cx="5212080" cy="3383280"/>
+            <a:off x="6248095" y="2834640"/>
+            <a:ext cx="5212080" cy="3474720"/>
           </a:xfrm>
           <a:prstGeom prst="roundRect">
             <a:avLst/>
@@ -4514,7 +4789,7 @@
               </a:defRPr>
             </a:pPr>
             <a:r>
-              <a:t>▶ [00:00 - 00:15] OpenShip 主控頁遙測</a:t>
+              <a:t>▶ [00:00 - 00:15] OpenShip 主控發射台遙測</a:t>
             </a:r>
           </a:p>
           <a:p>
@@ -4612,534 +4887,6 @@
 </file>
 
 <file path=ppt/slides/slide6.xml><?xml version="1.0" encoding="utf-8"?>
-<p:sld xmlns:a="http://schemas.openxmlformats.org/drawingml/2006/main" xmlns:p="http://schemas.openxmlformats.org/presentationml/2006/main" xmlns:r="http://schemas.openxmlformats.org/officeDocument/2006/relationships">
-  <p:cSld>
-    <p:spTree>
-      <p:nvGrpSpPr>
-        <p:cNvPr id="1" name=""/>
-        <p:cNvGrpSpPr/>
-        <p:nvPr/>
-      </p:nvGrpSpPr>
-      <p:grpSpPr/>
-      <p:sp>
-        <p:nvSpPr>
-          <p:cNvPr id="2" name="Rectangle 1"/>
-          <p:cNvSpPr/>
-          <p:nvPr/>
-        </p:nvSpPr>
-        <p:spPr>
-          <a:xfrm>
-            <a:off x="0" y="0"/>
-            <a:ext cx="12191695" cy="6858000"/>
-          </a:xfrm>
-          <a:prstGeom prst="rect">
-            <a:avLst/>
-          </a:prstGeom>
-          <a:solidFill>
-            <a:srgbClr val="070A12"/>
-          </a:solidFill>
-          <a:ln>
-            <a:noFill/>
-          </a:ln>
-        </p:spPr>
-        <p:style>
-          <a:lnRef idx="1">
-            <a:schemeClr val="accent1"/>
-          </a:lnRef>
-          <a:fillRef idx="3">
-            <a:schemeClr val="accent1"/>
-          </a:fillRef>
-          <a:effectRef idx="2">
-            <a:schemeClr val="accent1"/>
-          </a:effectRef>
-          <a:fontRef idx="minor">
-            <a:schemeClr val="lt1"/>
-          </a:fontRef>
-        </p:style>
-        <p:txBody>
-          <a:bodyPr rtlCol="0" anchor="ctr"/>
-          <a:lstStyle/>
-          <a:p>
-            <a:pPr algn="ctr"/>
-          </a:p>
-        </p:txBody>
-      </p:sp>
-      <p:sp>
-        <p:nvSpPr>
-          <p:cNvPr id="3" name="TextBox 2"/>
-          <p:cNvSpPr txBox="1"/>
-          <p:nvPr/>
-        </p:nvSpPr>
-        <p:spPr>
-          <a:xfrm>
-            <a:off x="731520" y="365760"/>
-            <a:ext cx="10728655" cy="822960"/>
-          </a:xfrm>
-          <a:prstGeom prst="rect">
-            <a:avLst/>
-          </a:prstGeom>
-          <a:noFill/>
-        </p:spPr>
-        <p:txBody>
-          <a:bodyPr wrap="square" lIns="0" rIns="0" tIns="0" bIns="0">
-            <a:spAutoFit/>
-          </a:bodyPr>
-          <a:lstStyle/>
-          <a:p>
-            <a:pPr>
-              <a:defRPr sz="1100" b="1">
-                <a:solidFill>
-                  <a:srgbClr val="38BDF8"/>
-                </a:solidFill>
-              </a:defRPr>
-            </a:pPr>
-            <a:r>
-              <a:t>● CROSS-INDUSTRY SUBSTRATE</a:t>
-            </a:r>
-          </a:p>
-          <a:p>
-            <a:pPr>
-              <a:defRPr sz="2200" b="1">
-                <a:solidFill>
-                  <a:srgbClr val="F8FAFC"/>
-                </a:solidFill>
-              </a:defRPr>
-            </a:pPr>
-            <a:r>
-              <a:t>六大產業異質場景：共用同一套確定性治理核心</a:t>
-            </a:r>
-          </a:p>
-        </p:txBody>
-      </p:sp>
-      <p:sp>
-        <p:nvSpPr>
-          <p:cNvPr id="4" name="Rounded Rectangle 3"/>
-          <p:cNvSpPr/>
-          <p:nvPr/>
-        </p:nvSpPr>
-        <p:spPr>
-          <a:xfrm>
-            <a:off x="731520" y="1280160"/>
-            <a:ext cx="3328416" cy="2377440"/>
-          </a:xfrm>
-          <a:prstGeom prst="roundRect">
-            <a:avLst/>
-          </a:prstGeom>
-          <a:solidFill>
-            <a:srgbClr val="0F172A"/>
-          </a:solidFill>
-          <a:ln w="19050">
-            <a:solidFill>
-              <a:srgbClr val="38BDF8"/>
-            </a:solidFill>
-          </a:ln>
-        </p:spPr>
-        <p:style>
-          <a:lnRef idx="1">
-            <a:schemeClr val="accent1"/>
-          </a:lnRef>
-          <a:fillRef idx="3">
-            <a:schemeClr val="accent1"/>
-          </a:fillRef>
-          <a:effectRef idx="2">
-            <a:schemeClr val="accent1"/>
-          </a:effectRef>
-          <a:fontRef idx="minor">
-            <a:schemeClr val="lt1"/>
-          </a:fontRef>
-        </p:style>
-        <p:txBody>
-          <a:bodyPr rtlCol="0" anchor="ctr" wrap="square" lIns="274320" rIns="274320" tIns="228600" bIns="182880"/>
-          <a:lstStyle/>
-          <a:p>
-            <a:pPr algn="ctr">
-              <a:defRPr sz="1300" b="1">
-                <a:solidFill>
-                  <a:srgbClr val="38BDF8"/>
-                </a:solidFill>
-              </a:defRPr>
-            </a:pPr>
-            <a:r>
-              <a:t>🏭 Track 01 製造碳護照</a:t>
-            </a:r>
-          </a:p>
-          <a:p>
-            <a:pPr>
-              <a:defRPr sz="1100">
-                <a:solidFill>
-                  <a:srgbClr val="F8FAFC"/>
-                </a:solidFill>
-              </a:defRPr>
-            </a:pPr>
-            <a:r>
-              <a:t>• 遮蔽 BOM 原料與良率</a:t>
-            </a:r>
-            <a:br/>
-            <a:r>
-              <a:t>• 僅放行歐盟 CBAM 碳足跡 ZKP</a:t>
-            </a:r>
-          </a:p>
-        </p:txBody>
-      </p:sp>
-      <p:sp>
-        <p:nvSpPr>
-          <p:cNvPr id="5" name="Rounded Rectangle 4"/>
-          <p:cNvSpPr/>
-          <p:nvPr/>
-        </p:nvSpPr>
-        <p:spPr>
-          <a:xfrm>
-            <a:off x="4425696" y="1280160"/>
-            <a:ext cx="3328416" cy="2377440"/>
-          </a:xfrm>
-          <a:prstGeom prst="roundRect">
-            <a:avLst/>
-          </a:prstGeom>
-          <a:solidFill>
-            <a:srgbClr val="0F172A"/>
-          </a:solidFill>
-          <a:ln w="19050">
-            <a:solidFill>
-              <a:srgbClr val="4ADE80"/>
-            </a:solidFill>
-          </a:ln>
-        </p:spPr>
-        <p:style>
-          <a:lnRef idx="1">
-            <a:schemeClr val="accent1"/>
-          </a:lnRef>
-          <a:fillRef idx="3">
-            <a:schemeClr val="accent1"/>
-          </a:fillRef>
-          <a:effectRef idx="2">
-            <a:schemeClr val="accent1"/>
-          </a:effectRef>
-          <a:fontRef idx="minor">
-            <a:schemeClr val="lt1"/>
-          </a:fontRef>
-        </p:style>
-        <p:txBody>
-          <a:bodyPr rtlCol="0" anchor="ctr" wrap="square" lIns="274320" rIns="274320" tIns="228600" bIns="182880"/>
-          <a:lstStyle/>
-          <a:p>
-            <a:pPr algn="ctr">
-              <a:defRPr sz="1300" b="1">
-                <a:solidFill>
-                  <a:srgbClr val="4ADE80"/>
-                </a:solidFill>
-              </a:defRPr>
-            </a:pPr>
-            <a:r>
-              <a:t>💳 Track 02 電支 AML 風控</a:t>
-            </a:r>
-          </a:p>
-          <a:p>
-            <a:pPr>
-              <a:defRPr sz="1100">
-                <a:solidFill>
-                  <a:srgbClr val="F8FAFC"/>
-                </a:solidFill>
-              </a:defRPr>
-            </a:pPr>
-            <a:r>
-              <a:t>• 去識別化密態行為特徵圖</a:t>
-            </a:r>
-            <a:br/>
-            <a:r>
-              <a:t>• 異常支付微秒阻斷 + 雙簽</a:t>
-            </a:r>
-          </a:p>
-        </p:txBody>
-      </p:sp>
-      <p:sp>
-        <p:nvSpPr>
-          <p:cNvPr id="6" name="Rounded Rectangle 5"/>
-          <p:cNvSpPr/>
-          <p:nvPr/>
-        </p:nvSpPr>
-        <p:spPr>
-          <a:xfrm>
-            <a:off x="8119872" y="1280160"/>
-            <a:ext cx="3328416" cy="2377440"/>
-          </a:xfrm>
-          <a:prstGeom prst="roundRect">
-            <a:avLst/>
-          </a:prstGeom>
-          <a:solidFill>
-            <a:srgbClr val="0F172A"/>
-          </a:solidFill>
-          <a:ln w="19050">
-            <a:solidFill>
-              <a:srgbClr val="F87171"/>
-            </a:solidFill>
-          </a:ln>
-        </p:spPr>
-        <p:style>
-          <a:lnRef idx="1">
-            <a:schemeClr val="accent1"/>
-          </a:lnRef>
-          <a:fillRef idx="3">
-            <a:schemeClr val="accent1"/>
-          </a:fillRef>
-          <a:effectRef idx="2">
-            <a:schemeClr val="accent1"/>
-          </a:effectRef>
-          <a:fontRef idx="minor">
-            <a:schemeClr val="lt1"/>
-          </a:fontRef>
-        </p:style>
-        <p:txBody>
-          <a:bodyPr rtlCol="0" anchor="ctr" wrap="square" lIns="274320" rIns="274320" tIns="228600" bIns="182880"/>
-          <a:lstStyle/>
-          <a:p>
-            <a:pPr algn="ctr">
-              <a:defRPr sz="1300" b="1">
-                <a:solidFill>
-                  <a:srgbClr val="F87171"/>
-                </a:solidFill>
-              </a:defRPr>
-            </a:pPr>
-            <a:r>
-              <a:t>🏥 Track 03 醫療保險理賠</a:t>
-            </a:r>
-          </a:p>
-          <a:p>
-            <a:pPr>
-              <a:defRPr sz="1100">
-                <a:solidFill>
-                  <a:srgbClr val="F8FAFC"/>
-                </a:solidFill>
-              </a:defRPr>
-            </a:pPr>
-            <a:r>
-              <a:t>• 18項 PHI 敏感個資動態遮蔽</a:t>
-            </a:r>
-            <a:br/>
-            <a:r>
-              <a:t>• 對接壽險公會理賠聯盟鏈</a:t>
-            </a:r>
-          </a:p>
-        </p:txBody>
-      </p:sp>
-      <p:sp>
-        <p:nvSpPr>
-          <p:cNvPr id="7" name="Rounded Rectangle 6"/>
-          <p:cNvSpPr/>
-          <p:nvPr/>
-        </p:nvSpPr>
-        <p:spPr>
-          <a:xfrm>
-            <a:off x="731520" y="3931920"/>
-            <a:ext cx="3328416" cy="2377440"/>
-          </a:xfrm>
-          <a:prstGeom prst="roundRect">
-            <a:avLst/>
-          </a:prstGeom>
-          <a:solidFill>
-            <a:srgbClr val="0F172A"/>
-          </a:solidFill>
-          <a:ln w="19050">
-            <a:solidFill>
-              <a:srgbClr val="FBBF24"/>
-            </a:solidFill>
-          </a:ln>
-        </p:spPr>
-        <p:style>
-          <a:lnRef idx="1">
-            <a:schemeClr val="accent1"/>
-          </a:lnRef>
-          <a:fillRef idx="3">
-            <a:schemeClr val="accent1"/>
-          </a:fillRef>
-          <a:effectRef idx="2">
-            <a:schemeClr val="accent1"/>
-          </a:effectRef>
-          <a:fontRef idx="minor">
-            <a:schemeClr val="lt1"/>
-          </a:fontRef>
-        </p:style>
-        <p:txBody>
-          <a:bodyPr rtlCol="0" anchor="ctr" wrap="square" lIns="274320" rIns="274320" tIns="228600" bIns="182880"/>
-          <a:lstStyle/>
-          <a:p>
-            <a:pPr algn="ctr">
-              <a:defRPr sz="1300" b="1">
-                <a:solidFill>
-                  <a:srgbClr val="FBBF24"/>
-                </a:solidFill>
-              </a:defRPr>
-            </a:pPr>
-            <a:r>
-              <a:t>🏛️ Track 04 政府跨機關代辦</a:t>
-            </a:r>
-          </a:p>
-          <a:p>
-            <a:pPr>
-              <a:defRPr sz="1100">
-                <a:solidFill>
-                  <a:srgbClr val="F8FAFC"/>
-                </a:solidFill>
-              </a:defRPr>
-            </a:pPr>
-            <a:r>
-              <a:t>• MyData + vLEI 雙軌授權</a:t>
-            </a:r>
-            <a:br/>
-            <a:r>
-              <a:t>• 代查/代送/本人三層邊界</a:t>
-            </a:r>
-          </a:p>
-        </p:txBody>
-      </p:sp>
-      <p:sp>
-        <p:nvSpPr>
-          <p:cNvPr id="8" name="Rounded Rectangle 7"/>
-          <p:cNvSpPr/>
-          <p:nvPr/>
-        </p:nvSpPr>
-        <p:spPr>
-          <a:xfrm>
-            <a:off x="4425696" y="3931920"/>
-            <a:ext cx="3328416" cy="2377440"/>
-          </a:xfrm>
-          <a:prstGeom prst="roundRect">
-            <a:avLst/>
-          </a:prstGeom>
-          <a:solidFill>
-            <a:srgbClr val="0F172A"/>
-          </a:solidFill>
-          <a:ln w="19050">
-            <a:solidFill>
-              <a:srgbClr val="C084FC"/>
-            </a:solidFill>
-          </a:ln>
-        </p:spPr>
-        <p:style>
-          <a:lnRef idx="1">
-            <a:schemeClr val="accent1"/>
-          </a:lnRef>
-          <a:fillRef idx="3">
-            <a:schemeClr val="accent1"/>
-          </a:fillRef>
-          <a:effectRef idx="2">
-            <a:schemeClr val="accent1"/>
-          </a:effectRef>
-          <a:fontRef idx="minor">
-            <a:schemeClr val="lt1"/>
-          </a:fontRef>
-        </p:style>
-        <p:txBody>
-          <a:bodyPr rtlCol="0" anchor="ctr" wrap="square" lIns="274320" rIns="274320" tIns="228600" bIns="182880"/>
-          <a:lstStyle/>
-          <a:p>
-            <a:pPr algn="ctr">
-              <a:defRPr sz="1300" b="1">
-                <a:solidFill>
-                  <a:srgbClr val="C084FC"/>
-                </a:solidFill>
-              </a:defRPr>
-            </a:pPr>
-            <a:r>
-              <a:t>🌏 Track 05 移工普惠金融</a:t>
-            </a:r>
-          </a:p>
-          <a:p>
-            <a:pPr>
-              <a:defRPr sz="1100">
-                <a:solidFill>
-                  <a:srgbClr val="F8FAFC"/>
-                </a:solidFill>
-              </a:defRPr>
-            </a:pPr>
-            <a:r>
-              <a:t>• 87萬移工 1:1:1 複合綁定</a:t>
-            </a:r>
-            <a:br/>
-            <a:r>
-              <a:t>• SIM Swap 異常連鎖凍結</a:t>
-            </a:r>
-          </a:p>
-        </p:txBody>
-      </p:sp>
-      <p:sp>
-        <p:nvSpPr>
-          <p:cNvPr id="9" name="Rounded Rectangle 8"/>
-          <p:cNvSpPr/>
-          <p:nvPr/>
-        </p:nvSpPr>
-        <p:spPr>
-          <a:xfrm>
-            <a:off x="8119872" y="3931920"/>
-            <a:ext cx="3328416" cy="2377440"/>
-          </a:xfrm>
-          <a:prstGeom prst="roundRect">
-            <a:avLst/>
-          </a:prstGeom>
-          <a:solidFill>
-            <a:srgbClr val="0F172A"/>
-          </a:solidFill>
-          <a:ln w="19050">
-            <a:solidFill>
-              <a:srgbClr val="38BDF8"/>
-            </a:solidFill>
-          </a:ln>
-        </p:spPr>
-        <p:style>
-          <a:lnRef idx="1">
-            <a:schemeClr val="accent1"/>
-          </a:lnRef>
-          <a:fillRef idx="3">
-            <a:schemeClr val="accent1"/>
-          </a:fillRef>
-          <a:effectRef idx="2">
-            <a:schemeClr val="accent1"/>
-          </a:effectRef>
-          <a:fontRef idx="minor">
-            <a:schemeClr val="lt1"/>
-          </a:fontRef>
-        </p:style>
-        <p:txBody>
-          <a:bodyPr rtlCol="0" anchor="ctr" wrap="square" lIns="274320" rIns="274320" tIns="228600" bIns="182880"/>
-          <a:lstStyle/>
-          <a:p>
-            <a:pPr algn="ctr">
-              <a:defRPr sz="1300" b="1">
-                <a:solidFill>
-                  <a:srgbClr val="38BDF8"/>
-                </a:solidFill>
-              </a:defRPr>
-            </a:pPr>
-            <a:r>
-              <a:t>📦 Track 06 供應鏈 RBA 稽核</a:t>
-            </a:r>
-          </a:p>
-          <a:p>
-            <a:pPr>
-              <a:defRPr sz="1100">
-                <a:solidFill>
-                  <a:srgbClr val="F8FAFC"/>
-                </a:solidFill>
-              </a:defRPr>
-            </a:pPr>
-            <a:r>
-              <a:t>• 雇主付費 Merkle 存證</a:t>
-            </a:r>
-            <a:br/>
-            <a:r>
-              <a:t>• 採購越權零容忍物理攔截</a:t>
-            </a:r>
-          </a:p>
-        </p:txBody>
-      </p:sp>
-    </p:spTree>
-  </p:cSld>
-  <p:clrMapOvr>
-    <a:masterClrMapping/>
-  </p:clrMapOvr>
-</p:sld>
-</file>
-
-<file path=ppt/slides/slide7.xml><?xml version="1.0" encoding="utf-8"?>
 <p:sld xmlns:a="http://schemas.openxmlformats.org/drawingml/2006/main" xmlns:p="http://schemas.openxmlformats.org/presentationml/2006/main" xmlns:r="http://schemas.openxmlformats.org/officeDocument/2006/relationships">
   <p:cSld>
     <p:spTree>
@@ -5571,7 +5318,7 @@
 </p:sld>
 </file>
 
-<file path=ppt/slides/slide8.xml><?xml version="1.0" encoding="utf-8"?>
+<file path=ppt/slides/slide7.xml><?xml version="1.0" encoding="utf-8"?>
 <p:sld xmlns:a="http://schemas.openxmlformats.org/drawingml/2006/main" xmlns:p="http://schemas.openxmlformats.org/presentationml/2006/main" xmlns:r="http://schemas.openxmlformats.org/officeDocument/2006/relationships">
   <p:cSld>
     <p:spTree>

</xml_diff>

<commit_message>
feat: insert dedicated 6-Pillars governance closed-loop slide before Ingress/Egress mapping for perfect structural symmetry
</commit_message>
<xml_diff>
--- a/DROS_DEMO.pptx
+++ b/DROS_DEMO.pptx
@@ -12,6 +12,7 @@
     <p:sldId id="260" r:id="rId11"/>
     <p:sldId id="261" r:id="rId12"/>
     <p:sldId id="262" r:id="rId13"/>
+    <p:sldId id="263" r:id="rId14"/>
   </p:sldIdLst>
   <p:sldSz cx="12191695" cy="6858000" type="screen4x3"/>
   <p:notesSz cx="6858000" cy="9144000"/>
@@ -3234,7 +3235,7 @@
           </a:fontRef>
         </p:style>
         <p:txBody>
-          <a:bodyPr rtlCol="0" anchor="ctr" wrap="square" lIns="274320" rIns="274320" tIns="228600" bIns="182880"/>
+          <a:bodyPr rtlCol="0" anchor="ctr" wrap="square" lIns="228600" rIns="228600" tIns="182880" bIns="137160"/>
           <a:lstStyle/>
           <a:p>
             <a:pPr algn="ctr">
@@ -3389,6 +3390,510 @@
               </a:defRPr>
             </a:pPr>
             <a:r>
+              <a:t>● 6-PILLARS FRAMEWORK</a:t>
+            </a:r>
+          </a:p>
+          <a:p>
+            <a:pPr>
+              <a:defRPr sz="2200" b="1">
+                <a:solidFill>
+                  <a:srgbClr val="F8FAFC"/>
+                </a:solidFill>
+              </a:defRPr>
+            </a:pPr>
+            <a:r>
+              <a:t>DROS 確定性 6P 治理閉環：從身分注入到動態撤銷的全生命週期</a:t>
+            </a:r>
+          </a:p>
+        </p:txBody>
+      </p:sp>
+      <p:sp>
+        <p:nvSpPr>
+          <p:cNvPr id="4" name="Rounded Rectangle 3"/>
+          <p:cNvSpPr/>
+          <p:nvPr/>
+        </p:nvSpPr>
+        <p:spPr>
+          <a:xfrm>
+            <a:off x="731520" y="1280160"/>
+            <a:ext cx="3413455" cy="2240280"/>
+          </a:xfrm>
+          <a:prstGeom prst="roundRect">
+            <a:avLst/>
+          </a:prstGeom>
+          <a:solidFill>
+            <a:srgbClr val="0F172A"/>
+          </a:solidFill>
+          <a:ln w="19050">
+            <a:solidFill>
+              <a:srgbClr val="38BDF8"/>
+            </a:solidFill>
+          </a:ln>
+        </p:spPr>
+        <p:style>
+          <a:lnRef idx="1">
+            <a:schemeClr val="accent1"/>
+          </a:lnRef>
+          <a:fillRef idx="3">
+            <a:schemeClr val="accent1"/>
+          </a:fillRef>
+          <a:effectRef idx="2">
+            <a:schemeClr val="accent1"/>
+          </a:effectRef>
+          <a:fontRef idx="minor">
+            <a:schemeClr val="lt1"/>
+          </a:fontRef>
+        </p:style>
+        <p:txBody>
+          <a:bodyPr rtlCol="0" anchor="ctr" wrap="square" lIns="228600" rIns="228600" tIns="182880" bIns="137160"/>
+          <a:lstStyle/>
+          <a:p>
+            <a:pPr algn="ctr">
+              <a:defRPr sz="1400" b="1">
+                <a:solidFill>
+                  <a:srgbClr val="38BDF8"/>
+                </a:solidFill>
+              </a:defRPr>
+            </a:pPr>
+            <a:r>
+              <a:t>P1. Principal (執行主體)</a:t>
+            </a:r>
+          </a:p>
+          <a:p>
+            <a:pPr>
+              <a:defRPr sz="1150">
+                <a:solidFill>
+                  <a:srgbClr val="F8FAFC"/>
+                </a:solidFill>
+              </a:defRPr>
+            </a:pPr>
+            <a:r>
+              <a:t>DIT Token 加密身分注入，強綁定法人 vLEI 與自然人 MyData。</a:t>
+            </a:r>
+          </a:p>
+        </p:txBody>
+      </p:sp>
+      <p:sp>
+        <p:nvSpPr>
+          <p:cNvPr id="5" name="Rounded Rectangle 4"/>
+          <p:cNvSpPr/>
+          <p:nvPr/>
+        </p:nvSpPr>
+        <p:spPr>
+          <a:xfrm>
+            <a:off x="4389120" y="1280160"/>
+            <a:ext cx="3413455" cy="2240280"/>
+          </a:xfrm>
+          <a:prstGeom prst="roundRect">
+            <a:avLst/>
+          </a:prstGeom>
+          <a:solidFill>
+            <a:srgbClr val="0F172A"/>
+          </a:solidFill>
+          <a:ln w="19050">
+            <a:solidFill>
+              <a:srgbClr val="4ADE80"/>
+            </a:solidFill>
+          </a:ln>
+        </p:spPr>
+        <p:style>
+          <a:lnRef idx="1">
+            <a:schemeClr val="accent1"/>
+          </a:lnRef>
+          <a:fillRef idx="3">
+            <a:schemeClr val="accent1"/>
+          </a:fillRef>
+          <a:effectRef idx="2">
+            <a:schemeClr val="accent1"/>
+          </a:effectRef>
+          <a:fontRef idx="minor">
+            <a:schemeClr val="lt1"/>
+          </a:fontRef>
+        </p:style>
+        <p:txBody>
+          <a:bodyPr rtlCol="0" anchor="ctr" wrap="square" lIns="228600" rIns="228600" tIns="182880" bIns="137160"/>
+          <a:lstStyle/>
+          <a:p>
+            <a:pPr algn="ctr">
+              <a:defRPr sz="1400" b="1">
+                <a:solidFill>
+                  <a:srgbClr val="4ADE80"/>
+                </a:solidFill>
+              </a:defRPr>
+            </a:pPr>
+            <a:r>
+              <a:t>P2. Authorization (權限邊界)</a:t>
+            </a:r>
+          </a:p>
+          <a:p>
+            <a:pPr>
+              <a:defRPr sz="1150">
+                <a:solidFill>
+                  <a:srgbClr val="F8FAFC"/>
+                </a:solidFill>
+              </a:defRPr>
+            </a:pPr>
+            <a:r>
+              <a:t>Zero-Heap Capability Bitmaps 暫存器權限位元圖，嚴格鎖定 Scope。</a:t>
+            </a:r>
+          </a:p>
+        </p:txBody>
+      </p:sp>
+      <p:sp>
+        <p:nvSpPr>
+          <p:cNvPr id="6" name="Rounded Rectangle 5"/>
+          <p:cNvSpPr/>
+          <p:nvPr/>
+        </p:nvSpPr>
+        <p:spPr>
+          <a:xfrm>
+            <a:off x="8046720" y="1280160"/>
+            <a:ext cx="3413455" cy="2240280"/>
+          </a:xfrm>
+          <a:prstGeom prst="roundRect">
+            <a:avLst/>
+          </a:prstGeom>
+          <a:solidFill>
+            <a:srgbClr val="0F172A"/>
+          </a:solidFill>
+          <a:ln w="19050">
+            <a:solidFill>
+              <a:srgbClr val="F87171"/>
+            </a:solidFill>
+          </a:ln>
+        </p:spPr>
+        <p:style>
+          <a:lnRef idx="1">
+            <a:schemeClr val="accent1"/>
+          </a:lnRef>
+          <a:fillRef idx="3">
+            <a:schemeClr val="accent1"/>
+          </a:fillRef>
+          <a:effectRef idx="2">
+            <a:schemeClr val="accent1"/>
+          </a:effectRef>
+          <a:fontRef idx="minor">
+            <a:schemeClr val="lt1"/>
+          </a:fontRef>
+        </p:style>
+        <p:txBody>
+          <a:bodyPr rtlCol="0" anchor="ctr" wrap="square" lIns="228600" rIns="228600" tIns="182880" bIns="137160"/>
+          <a:lstStyle/>
+          <a:p>
+            <a:pPr algn="ctr">
+              <a:defRPr sz="1400" b="1">
+                <a:solidFill>
+                  <a:srgbClr val="F87171"/>
+                </a:solidFill>
+              </a:defRPr>
+            </a:pPr>
+            <a:r>
+              <a:t>P3. Tool Bound (工具邊界)</a:t>
+            </a:r>
+          </a:p>
+          <a:p>
+            <a:pPr>
+              <a:defRPr sz="1150">
+                <a:solidFill>
+                  <a:srgbClr val="F8FAFC"/>
+                </a:solidFill>
+              </a:defRPr>
+            </a:pPr>
+            <a:r>
+              <a:t>C-ABI 二進位帶內閘門，未授權 Tool Call 物理阻斷無法繞過。</a:t>
+            </a:r>
+          </a:p>
+        </p:txBody>
+      </p:sp>
+      <p:sp>
+        <p:nvSpPr>
+          <p:cNvPr id="7" name="Rounded Rectangle 6"/>
+          <p:cNvSpPr/>
+          <p:nvPr/>
+        </p:nvSpPr>
+        <p:spPr>
+          <a:xfrm>
+            <a:off x="731520" y="3749039"/>
+            <a:ext cx="3413455" cy="2240280"/>
+          </a:xfrm>
+          <a:prstGeom prst="roundRect">
+            <a:avLst/>
+          </a:prstGeom>
+          <a:solidFill>
+            <a:srgbClr val="0F172A"/>
+          </a:solidFill>
+          <a:ln w="19050">
+            <a:solidFill>
+              <a:srgbClr val="FBBF24"/>
+            </a:solidFill>
+          </a:ln>
+        </p:spPr>
+        <p:style>
+          <a:lnRef idx="1">
+            <a:schemeClr val="accent1"/>
+          </a:lnRef>
+          <a:fillRef idx="3">
+            <a:schemeClr val="accent1"/>
+          </a:fillRef>
+          <a:effectRef idx="2">
+            <a:schemeClr val="accent1"/>
+          </a:effectRef>
+          <a:fontRef idx="minor">
+            <a:schemeClr val="lt1"/>
+          </a:fontRef>
+        </p:style>
+        <p:txBody>
+          <a:bodyPr rtlCol="0" anchor="ctr" wrap="square" lIns="228600" rIns="228600" tIns="182880" bIns="137160"/>
+          <a:lstStyle/>
+          <a:p>
+            <a:pPr algn="ctr">
+              <a:defRPr sz="1400" b="1">
+                <a:solidFill>
+                  <a:srgbClr val="FBBF24"/>
+                </a:solidFill>
+              </a:defRPr>
+            </a:pPr>
+            <a:r>
+              <a:t>P4. Policy Gate (執行門閥)</a:t>
+            </a:r>
+          </a:p>
+          <a:p>
+            <a:pPr>
+              <a:defRPr sz="1150">
+                <a:solidFill>
+                  <a:srgbClr val="F8FAFC"/>
+                </a:solidFill>
+              </a:defRPr>
+            </a:pPr>
+            <a:r>
+              <a:t>26.1 μs 帶內硬熔斷 + 機密 Redact 遮蔽 + 高風險 HITL 雙簽懸停。</a:t>
+            </a:r>
+          </a:p>
+        </p:txBody>
+      </p:sp>
+      <p:sp>
+        <p:nvSpPr>
+          <p:cNvPr id="8" name="Rounded Rectangle 7"/>
+          <p:cNvSpPr/>
+          <p:nvPr/>
+        </p:nvSpPr>
+        <p:spPr>
+          <a:xfrm>
+            <a:off x="4389120" y="3749039"/>
+            <a:ext cx="3413455" cy="2240280"/>
+          </a:xfrm>
+          <a:prstGeom prst="roundRect">
+            <a:avLst/>
+          </a:prstGeom>
+          <a:solidFill>
+            <a:srgbClr val="0F172A"/>
+          </a:solidFill>
+          <a:ln w="19050">
+            <a:solidFill>
+              <a:srgbClr val="C084FC"/>
+            </a:solidFill>
+          </a:ln>
+        </p:spPr>
+        <p:style>
+          <a:lnRef idx="1">
+            <a:schemeClr val="accent1"/>
+          </a:lnRef>
+          <a:fillRef idx="3">
+            <a:schemeClr val="accent1"/>
+          </a:fillRef>
+          <a:effectRef idx="2">
+            <a:schemeClr val="accent1"/>
+          </a:effectRef>
+          <a:fontRef idx="minor">
+            <a:schemeClr val="lt1"/>
+          </a:fontRef>
+        </p:style>
+        <p:txBody>
+          <a:bodyPr rtlCol="0" anchor="ctr" wrap="square" lIns="228600" rIns="228600" tIns="182880" bIns="137160"/>
+          <a:lstStyle/>
+          <a:p>
+            <a:pPr algn="ctr">
+              <a:defRPr sz="1400" b="1">
+                <a:solidFill>
+                  <a:srgbClr val="C084FC"/>
+                </a:solidFill>
+              </a:defRPr>
+            </a:pPr>
+            <a:r>
+              <a:t>P5. Audit Log (密碼學存證)</a:t>
+            </a:r>
+          </a:p>
+          <a:p>
+            <a:pPr>
+              <a:defRPr sz="1150">
+                <a:solidFill>
+                  <a:srgbClr val="F8FAFC"/>
+                </a:solidFill>
+              </a:defRPr>
+            </a:pPr>
+            <a:r>
+              <a:t>SHA-256 Merkle 鏈結防篡改收據，具備不可否認性法庭證據力。</a:t>
+            </a:r>
+          </a:p>
+        </p:txBody>
+      </p:sp>
+      <p:sp>
+        <p:nvSpPr>
+          <p:cNvPr id="9" name="Rounded Rectangle 8"/>
+          <p:cNvSpPr/>
+          <p:nvPr/>
+        </p:nvSpPr>
+        <p:spPr>
+          <a:xfrm>
+            <a:off x="8046720" y="3749039"/>
+            <a:ext cx="3413455" cy="2240280"/>
+          </a:xfrm>
+          <a:prstGeom prst="roundRect">
+            <a:avLst/>
+          </a:prstGeom>
+          <a:solidFill>
+            <a:srgbClr val="0F172A"/>
+          </a:solidFill>
+          <a:ln w="19050">
+            <a:solidFill>
+              <a:srgbClr val="38BDF8"/>
+            </a:solidFill>
+          </a:ln>
+        </p:spPr>
+        <p:style>
+          <a:lnRef idx="1">
+            <a:schemeClr val="accent1"/>
+          </a:lnRef>
+          <a:fillRef idx="3">
+            <a:schemeClr val="accent1"/>
+          </a:fillRef>
+          <a:effectRef idx="2">
+            <a:schemeClr val="accent1"/>
+          </a:effectRef>
+          <a:fontRef idx="minor">
+            <a:schemeClr val="lt1"/>
+          </a:fontRef>
+        </p:style>
+        <p:txBody>
+          <a:bodyPr rtlCol="0" anchor="ctr" wrap="square" lIns="228600" rIns="228600" tIns="182880" bIns="137160"/>
+          <a:lstStyle/>
+          <a:p>
+            <a:pPr algn="ctr">
+              <a:defRPr sz="1400" b="1">
+                <a:solidFill>
+                  <a:srgbClr val="38BDF8"/>
+                </a:solidFill>
+              </a:defRPr>
+            </a:pPr>
+            <a:r>
+              <a:t>P6. Revocation (動態撤銷)</a:t>
+            </a:r>
+          </a:p>
+          <a:p>
+            <a:pPr>
+              <a:defRPr sz="1150">
+                <a:solidFill>
+                  <a:srgbClr val="F8FAFC"/>
+                </a:solidFill>
+              </a:defRPr>
+            </a:pPr>
+            <a:r>
+              <a:t>O(1) RCU 原子指針常數時間秒級切換，權限凍結立即生效。</a:t>
+            </a:r>
+          </a:p>
+        </p:txBody>
+      </p:sp>
+    </p:spTree>
+  </p:cSld>
+  <p:clrMapOvr>
+    <a:masterClrMapping/>
+  </p:clrMapOvr>
+</p:sld>
+</file>
+
+<file path=ppt/slides/slide3.xml><?xml version="1.0" encoding="utf-8"?>
+<p:sld xmlns:a="http://schemas.openxmlformats.org/drawingml/2006/main" xmlns:p="http://schemas.openxmlformats.org/presentationml/2006/main" xmlns:r="http://schemas.openxmlformats.org/officeDocument/2006/relationships">
+  <p:cSld>
+    <p:spTree>
+      <p:nvGrpSpPr>
+        <p:cNvPr id="1" name=""/>
+        <p:cNvGrpSpPr/>
+        <p:nvPr/>
+      </p:nvGrpSpPr>
+      <p:grpSpPr/>
+      <p:sp>
+        <p:nvSpPr>
+          <p:cNvPr id="2" name="Rectangle 1"/>
+          <p:cNvSpPr/>
+          <p:nvPr/>
+        </p:nvSpPr>
+        <p:spPr>
+          <a:xfrm>
+            <a:off x="0" y="0"/>
+            <a:ext cx="12191695" cy="6858000"/>
+          </a:xfrm>
+          <a:prstGeom prst="rect">
+            <a:avLst/>
+          </a:prstGeom>
+          <a:solidFill>
+            <a:srgbClr val="070A12"/>
+          </a:solidFill>
+          <a:ln>
+            <a:noFill/>
+          </a:ln>
+        </p:spPr>
+        <p:style>
+          <a:lnRef idx="1">
+            <a:schemeClr val="accent1"/>
+          </a:lnRef>
+          <a:fillRef idx="3">
+            <a:schemeClr val="accent1"/>
+          </a:fillRef>
+          <a:effectRef idx="2">
+            <a:schemeClr val="accent1"/>
+          </a:effectRef>
+          <a:fontRef idx="minor">
+            <a:schemeClr val="lt1"/>
+          </a:fontRef>
+        </p:style>
+        <p:txBody>
+          <a:bodyPr rtlCol="0" anchor="ctr"/>
+          <a:lstStyle/>
+          <a:p>
+            <a:pPr algn="ctr"/>
+          </a:p>
+        </p:txBody>
+      </p:sp>
+      <p:sp>
+        <p:nvSpPr>
+          <p:cNvPr id="3" name="TextBox 2"/>
+          <p:cNvSpPr txBox="1"/>
+          <p:nvPr/>
+        </p:nvSpPr>
+        <p:spPr>
+          <a:xfrm>
+            <a:off x="731520" y="365760"/>
+            <a:ext cx="10728655" cy="822960"/>
+          </a:xfrm>
+          <a:prstGeom prst="rect">
+            <a:avLst/>
+          </a:prstGeom>
+          <a:noFill/>
+        </p:spPr>
+        <p:txBody>
+          <a:bodyPr wrap="square" lIns="0" rIns="0" tIns="0" bIns="0">
+            <a:spAutoFit/>
+          </a:bodyPr>
+          <a:lstStyle/>
+          <a:p>
+            <a:pPr>
+              <a:defRPr sz="1100" b="1">
+                <a:solidFill>
+                  <a:srgbClr val="38BDF8"/>
+                </a:solidFill>
+              </a:defRPr>
+            </a:pPr>
+            <a:r>
               <a:t>● ARCHITECTURE ABSTRACTION</a:t>
             </a:r>
           </a:p>
@@ -3401,7 +3906,7 @@
               </a:defRPr>
             </a:pPr>
             <a:r>
-              <a:t>兩大根本治理邊界 ➔ 4 大 DROS 核心微內核部件</a:t>
+              <a:t>6P 閉環收斂為兩大根本邊界 ➔ 4 大 DROS 核心微內核部件</a:t>
             </a:r>
           </a:p>
         </p:txBody>
@@ -3444,7 +3949,7 @@
           </a:fontRef>
         </p:style>
         <p:txBody>
-          <a:bodyPr rtlCol="0" anchor="ctr" wrap="square" lIns="274320" rIns="274320" tIns="228600" bIns="182880"/>
+          <a:bodyPr rtlCol="0" anchor="ctr" wrap="square" lIns="228600" rIns="228600" tIns="182880" bIns="137160"/>
           <a:lstStyle/>
           <a:p>
             <a:pPr algn="ctr">
@@ -3594,7 +4099,7 @@
           </a:fontRef>
         </p:style>
         <p:txBody>
-          <a:bodyPr rtlCol="0" anchor="ctr" wrap="square" lIns="274320" rIns="274320" tIns="228600" bIns="182880"/>
+          <a:bodyPr rtlCol="0" anchor="ctr" wrap="square" lIns="228600" rIns="228600" tIns="182880" bIns="137160"/>
           <a:lstStyle/>
           <a:p>
             <a:pPr algn="ctr">
@@ -3714,7 +4219,7 @@
 </p:sld>
 </file>
 
-<file path=ppt/slides/slide3.xml><?xml version="1.0" encoding="utf-8"?>
+<file path=ppt/slides/slide4.xml><?xml version="1.0" encoding="utf-8"?>
 <p:sld xmlns:a="http://schemas.openxmlformats.org/drawingml/2006/main" xmlns:p="http://schemas.openxmlformats.org/presentationml/2006/main" xmlns:r="http://schemas.openxmlformats.org/officeDocument/2006/relationships">
   <p:cSld>
     <p:spTree>
@@ -3852,7 +4357,7 @@
           </a:fontRef>
         </p:style>
         <p:txBody>
-          <a:bodyPr rtlCol="0" anchor="ctr" wrap="square" lIns="274320" rIns="274320" tIns="228600" bIns="182880"/>
+          <a:bodyPr rtlCol="0" anchor="ctr" wrap="square" lIns="228600" rIns="228600" tIns="182880" bIns="137160"/>
           <a:lstStyle/>
           <a:p>
             <a:pPr algn="ctr">
@@ -3930,7 +4435,7 @@
           </a:fontRef>
         </p:style>
         <p:txBody>
-          <a:bodyPr rtlCol="0" anchor="ctr" wrap="square" lIns="274320" rIns="274320" tIns="228600" bIns="182880"/>
+          <a:bodyPr rtlCol="0" anchor="ctr" wrap="square" lIns="228600" rIns="228600" tIns="182880" bIns="137160"/>
           <a:lstStyle/>
           <a:p>
             <a:pPr algn="ctr">
@@ -4008,7 +4513,7 @@
           </a:fontRef>
         </p:style>
         <p:txBody>
-          <a:bodyPr rtlCol="0" anchor="ctr" wrap="square" lIns="274320" rIns="274320" tIns="228600" bIns="182880"/>
+          <a:bodyPr rtlCol="0" anchor="ctr" wrap="square" lIns="228600" rIns="228600" tIns="182880" bIns="137160"/>
           <a:lstStyle/>
           <a:p>
             <a:pPr algn="ctr">
@@ -4086,7 +4591,7 @@
           </a:fontRef>
         </p:style>
         <p:txBody>
-          <a:bodyPr rtlCol="0" anchor="ctr" wrap="square" lIns="274320" rIns="274320" tIns="228600" bIns="182880"/>
+          <a:bodyPr rtlCol="0" anchor="ctr" wrap="square" lIns="228600" rIns="228600" tIns="182880" bIns="137160"/>
           <a:lstStyle/>
           <a:p>
             <a:pPr algn="ctr">
@@ -4164,7 +4669,7 @@
           </a:fontRef>
         </p:style>
         <p:txBody>
-          <a:bodyPr rtlCol="0" anchor="ctr" wrap="square" lIns="274320" rIns="274320" tIns="228600" bIns="182880"/>
+          <a:bodyPr rtlCol="0" anchor="ctr" wrap="square" lIns="228600" rIns="228600" tIns="182880" bIns="137160"/>
           <a:lstStyle/>
           <a:p>
             <a:pPr algn="ctr">
@@ -4242,7 +4747,7 @@
           </a:fontRef>
         </p:style>
         <p:txBody>
-          <a:bodyPr rtlCol="0" anchor="ctr" wrap="square" lIns="274320" rIns="274320" tIns="228600" bIns="182880"/>
+          <a:bodyPr rtlCol="0" anchor="ctr" wrap="square" lIns="228600" rIns="228600" tIns="182880" bIns="137160"/>
           <a:lstStyle/>
           <a:p>
             <a:pPr algn="ctr">
@@ -4290,7 +4795,7 @@
 </p:sld>
 </file>
 
-<file path=ppt/slides/slide4.xml><?xml version="1.0" encoding="utf-8"?>
+<file path=ppt/slides/slide5.xml><?xml version="1.0" encoding="utf-8"?>
 <p:sld xmlns:a="http://schemas.openxmlformats.org/drawingml/2006/main" xmlns:p="http://schemas.openxmlformats.org/presentationml/2006/main" xmlns:r="http://schemas.openxmlformats.org/officeDocument/2006/relationships">
   <p:cSld>
     <p:spTree>
@@ -4428,7 +4933,7 @@
           </a:fontRef>
         </p:style>
         <p:txBody>
-          <a:bodyPr rtlCol="0" anchor="ctr" wrap="square" lIns="274320" rIns="274320" tIns="228600" bIns="182880"/>
+          <a:bodyPr rtlCol="0" anchor="ctr" wrap="square" lIns="228600" rIns="228600" tIns="182880" bIns="137160"/>
           <a:lstStyle/>
           <a:p>
             <a:pPr algn="ctr">
@@ -4502,7 +5007,7 @@
           </a:fontRef>
         </p:style>
         <p:txBody>
-          <a:bodyPr rtlCol="0" anchor="ctr" wrap="square" lIns="274320" rIns="274320" tIns="228600" bIns="182880"/>
+          <a:bodyPr rtlCol="0" anchor="ctr" wrap="square" lIns="228600" rIns="228600" tIns="182880" bIns="137160"/>
           <a:lstStyle/>
           <a:p>
             <a:pPr algn="ctr">
@@ -4580,7 +5085,7 @@
           </a:fontRef>
         </p:style>
         <p:txBody>
-          <a:bodyPr rtlCol="0" anchor="ctr" wrap="square" lIns="274320" rIns="274320" tIns="228600" bIns="182880"/>
+          <a:bodyPr rtlCol="0" anchor="ctr" wrap="square" lIns="228600" rIns="228600" tIns="182880" bIns="137160"/>
           <a:lstStyle/>
           <a:p>
             <a:pPr algn="ctr">
@@ -4628,7 +5133,7 @@
 </p:sld>
 </file>
 
-<file path=ppt/slides/slide5.xml><?xml version="1.0" encoding="utf-8"?>
+<file path=ppt/slides/slide6.xml><?xml version="1.0" encoding="utf-8"?>
 <p:sld xmlns:a="http://schemas.openxmlformats.org/drawingml/2006/main" xmlns:p="http://schemas.openxmlformats.org/presentationml/2006/main" xmlns:r="http://schemas.openxmlformats.org/officeDocument/2006/relationships">
   <p:cSld>
     <p:spTree>
@@ -4766,7 +5271,7 @@
           </a:fontRef>
         </p:style>
         <p:txBody>
-          <a:bodyPr rtlCol="0" anchor="ctr" wrap="square" lIns="274320" rIns="274320" tIns="228600" bIns="182880"/>
+          <a:bodyPr rtlCol="0" anchor="ctr" wrap="square" lIns="228600" rIns="228600" tIns="182880" bIns="137160"/>
           <a:lstStyle/>
           <a:p>
             <a:pPr algn="ctr">
@@ -4886,7 +5391,7 @@
 </p:sld>
 </file>
 
-<file path=ppt/slides/slide6.xml><?xml version="1.0" encoding="utf-8"?>
+<file path=ppt/slides/slide7.xml><?xml version="1.0" encoding="utf-8"?>
 <p:sld xmlns:a="http://schemas.openxmlformats.org/drawingml/2006/main" xmlns:p="http://schemas.openxmlformats.org/presentationml/2006/main" xmlns:r="http://schemas.openxmlformats.org/officeDocument/2006/relationships">
   <p:cSld>
     <p:spTree>
@@ -5024,7 +5529,7 @@
           </a:fontRef>
         </p:style>
         <p:txBody>
-          <a:bodyPr rtlCol="0" anchor="ctr" wrap="square" lIns="274320" rIns="274320" tIns="228600" bIns="182880"/>
+          <a:bodyPr rtlCol="0" anchor="ctr" wrap="square" lIns="228600" rIns="228600" tIns="182880" bIns="137160"/>
           <a:lstStyle/>
           <a:p>
             <a:pPr algn="ctr">
@@ -5174,7 +5679,7 @@
           </a:fontRef>
         </p:style>
         <p:txBody>
-          <a:bodyPr rtlCol="0" anchor="ctr" wrap="square" lIns="274320" rIns="274320" tIns="228600" bIns="182880"/>
+          <a:bodyPr rtlCol="0" anchor="ctr" wrap="square" lIns="228600" rIns="228600" tIns="182880" bIns="137160"/>
           <a:lstStyle/>
           <a:p>
             <a:pPr algn="ctr">
@@ -5318,7 +5823,7 @@
 </p:sld>
 </file>
 
-<file path=ppt/slides/slide7.xml><?xml version="1.0" encoding="utf-8"?>
+<file path=ppt/slides/slide8.xml><?xml version="1.0" encoding="utf-8"?>
 <p:sld xmlns:a="http://schemas.openxmlformats.org/drawingml/2006/main" xmlns:p="http://schemas.openxmlformats.org/presentationml/2006/main" xmlns:r="http://schemas.openxmlformats.org/officeDocument/2006/relationships">
   <p:cSld>
     <p:spTree>
@@ -5456,7 +5961,7 @@
           </a:fontRef>
         </p:style>
         <p:txBody>
-          <a:bodyPr rtlCol="0" anchor="ctr" wrap="square" lIns="274320" rIns="274320" tIns="228600" bIns="182880"/>
+          <a:bodyPr rtlCol="0" anchor="ctr" wrap="square" lIns="228600" rIns="228600" tIns="182880" bIns="137160"/>
           <a:lstStyle/>
           <a:p>
             <a:pPr algn="ctr">

</xml_diff>

<commit_message>
feat: embed full Zenodo trilogy papers with DOIs and GitHub open-source verification repositories in slide 7
</commit_message>
<xml_diff>
--- a/DROS_DEMO.pptx
+++ b/DROS_DEMO.pptx
@@ -5474,7 +5474,7 @@
               </a:defRPr>
             </a:pPr>
             <a:r>
-              <a:t>● VERIFICATION &amp; PATENT</a:t>
+              <a:t>● ACADEMIC &amp; VERIFICATION</a:t>
             </a:r>
           </a:p>
           <a:p>
@@ -5486,7 +5486,7 @@
               </a:defRPr>
             </a:pPr>
             <a:r>
-              <a:t>客觀工程指標、官方生態整合與學術三部曲背書</a:t>
+              <a:t>權威學術三部曲、GitHub 100% 驗證開源倉與專利佈局</a:t>
             </a:r>
           </a:p>
         </p:txBody>
@@ -5500,6 +5500,172 @@
         <p:spPr>
           <a:xfrm>
             <a:off x="731520" y="1280160"/>
+            <a:ext cx="5212080" cy="5029200"/>
+          </a:xfrm>
+          <a:prstGeom prst="roundRect">
+            <a:avLst/>
+          </a:prstGeom>
+          <a:solidFill>
+            <a:srgbClr val="0F172A"/>
+          </a:solidFill>
+          <a:ln w="19050">
+            <a:solidFill>
+              <a:srgbClr val="38BDF8"/>
+            </a:solidFill>
+          </a:ln>
+        </p:spPr>
+        <p:style>
+          <a:lnRef idx="1">
+            <a:schemeClr val="accent1"/>
+          </a:lnRef>
+          <a:fillRef idx="3">
+            <a:schemeClr val="accent1"/>
+          </a:fillRef>
+          <a:effectRef idx="2">
+            <a:schemeClr val="accent1"/>
+          </a:effectRef>
+          <a:fontRef idx="minor">
+            <a:schemeClr val="lt1"/>
+          </a:fontRef>
+        </p:style>
+        <p:txBody>
+          <a:bodyPr rtlCol="0" anchor="ctr" wrap="square" lIns="228600" rIns="228600" tIns="182880" bIns="137160"/>
+          <a:lstStyle/>
+          <a:p>
+            <a:pPr algn="ctr">
+              <a:defRPr sz="1500" b="1">
+                <a:solidFill>
+                  <a:srgbClr val="38BDF8"/>
+                </a:solidFill>
+              </a:defRPr>
+            </a:pPr>
+            <a:r>
+              <a:t>🏛️ Zenodo 國際權威學術三部曲</a:t>
+            </a:r>
+          </a:p>
+          <a:p>
+            <a:pPr>
+              <a:defRPr sz="1200" b="1">
+                <a:solidFill>
+                  <a:srgbClr val="F8FAFC"/>
+                </a:solidFill>
+              </a:defRPr>
+            </a:pPr>
+            <a:r>
+              <a:t>• 📖 學術導讀指南 (Guide Note)</a:t>
+            </a:r>
+          </a:p>
+          <a:p>
+            <a:pPr>
+              <a:defRPr sz="1050">
+                <a:solidFill>
+                  <a:srgbClr val="94A3B8"/>
+                </a:solidFill>
+              </a:defRPr>
+            </a:pPr>
+            <a:r>
+              <a:t>   DOI: 10.5281/zenodo.22114036</a:t>
+            </a:r>
+            <a:br/>
+            <a:r>
+              <a:t>面向自主 AI 工作負載的確定性執行期作業基板。</a:t>
+            </a:r>
+          </a:p>
+          <a:p>
+            <a:pPr>
+              <a:defRPr sz="1200" b="1">
+                <a:solidFill>
+                  <a:srgbClr val="F8FAFC"/>
+                </a:solidFill>
+              </a:defRPr>
+            </a:pPr>
+            <a:r>
+              <a:t>• 🏛️ Paper 1: DROS-6P 閉環架構</a:t>
+            </a:r>
+          </a:p>
+          <a:p>
+            <a:pPr>
+              <a:defRPr sz="1050">
+                <a:solidFill>
+                  <a:srgbClr val="94A3B8"/>
+                </a:solidFill>
+              </a:defRPr>
+            </a:pPr>
+            <a:r>
+              <a:t>   DOI: 10.5281/zenodo.21833970</a:t>
+            </a:r>
+            <a:br/>
+            <a:r>
+              <a:t>企業級 AI Agent 六大信任邊界之確定性治理。</a:t>
+            </a:r>
+          </a:p>
+          <a:p>
+            <a:pPr>
+              <a:defRPr sz="1200" b="1">
+                <a:solidFill>
+                  <a:srgbClr val="F8FAFC"/>
+                </a:solidFill>
+              </a:defRPr>
+            </a:pPr>
+            <a:r>
+              <a:t>• 🏛️ Paper 2: DROS 四層操作系統</a:t>
+            </a:r>
+          </a:p>
+          <a:p>
+            <a:pPr>
+              <a:defRPr sz="1050">
+                <a:solidFill>
+                  <a:srgbClr val="94A3B8"/>
+                </a:solidFill>
+              </a:defRPr>
+            </a:pPr>
+            <a:r>
+              <a:t>   DOI: 10.5281/zenodo.22092008</a:t>
+            </a:r>
+            <a:br/>
+            <a:r>
+              <a:t>彌合代理人至執行歸因鴻溝之四層架構。</a:t>
+            </a:r>
+          </a:p>
+          <a:p>
+            <a:pPr>
+              <a:defRPr sz="1200" b="1">
+                <a:solidFill>
+                  <a:srgbClr val="F8FAFC"/>
+                </a:solidFill>
+              </a:defRPr>
+            </a:pPr>
+            <a:r>
+              <a:t>• 🏛️ Paper 3: DROS-PGM 控制平面</a:t>
+            </a:r>
+          </a:p>
+          <a:p>
+            <a:pPr>
+              <a:defRPr sz="1050">
+                <a:solidFill>
+                  <a:srgbClr val="94A3B8"/>
+                </a:solidFill>
+              </a:defRPr>
+            </a:pPr>
+            <a:r>
+              <a:t>   DOI: 10.5281/zenodo.21903687</a:t>
+            </a:r>
+            <a:br/>
+            <a:r>
+              <a:t>內核級運行期安全與微秒硬熔斷控制平面。</a:t>
+            </a:r>
+          </a:p>
+        </p:txBody>
+      </p:sp>
+      <p:sp>
+        <p:nvSpPr>
+          <p:cNvPr id="5" name="Rounded Rectangle 4"/>
+          <p:cNvSpPr/>
+          <p:nvPr/>
+        </p:nvSpPr>
+        <p:spPr>
+          <a:xfrm>
+            <a:off x="6248095" y="1280160"/>
             <a:ext cx="5212080" cy="5029200"/>
           </a:xfrm>
           <a:prstGeom prst="roundRect">
@@ -5540,277 +5706,119 @@
               </a:defRPr>
             </a:pPr>
             <a:r>
-              <a:t>⚡ 100% 可重現之硬核工程指標</a:t>
-            </a:r>
-          </a:p>
-          <a:p>
-            <a:pPr>
-              <a:defRPr sz="1300" b="1">
+              <a:t>💻 100% 可重現 GitHub 開源倉與專利</a:t>
+            </a:r>
+          </a:p>
+          <a:p>
+            <a:pPr>
+              <a:defRPr sz="1200" b="1">
                 <a:solidFill>
                   <a:srgbClr val="F8FAFC"/>
                 </a:solidFill>
               </a:defRPr>
             </a:pPr>
             <a:r>
-              <a:t>• 0.001 秒極速測試：</a:t>
-            </a:r>
-          </a:p>
-          <a:p>
-            <a:pPr>
-              <a:defRPr sz="1150">
+              <a:t>• 🌐 Hackathon Showcase 展演倉</a:t>
+            </a:r>
+          </a:p>
+          <a:p>
+            <a:pPr>
+              <a:defRPr sz="1050">
                 <a:solidFill>
                   <a:srgbClr val="94A3B8"/>
                 </a:solidFill>
               </a:defRPr>
             </a:pPr>
             <a:r>
-              <a:t>   自動化驗證套件 5/5 斷言全數通過 (100% Verifiable)。</a:t>
-            </a:r>
-          </a:p>
-          <a:p>
-            <a:pPr>
-              <a:defRPr sz="1300" b="1">
+              <a:t>   github.com/Top-Celestial-Company-Ltd/DROS-Hackathon-Showcase</a:t>
+            </a:r>
+            <a:br/>
+            <a:r>
+              <a:t>內含多軌互動發射台、REST API 與 6 大賽道對照。</a:t>
+            </a:r>
+          </a:p>
+          <a:p>
+            <a:pPr>
+              <a:defRPr sz="1200" b="1">
                 <a:solidFill>
                   <a:srgbClr val="F8FAFC"/>
                 </a:solidFill>
               </a:defRPr>
             </a:pPr>
             <a:r>
-              <a:t>• 26.1 μs 執行期延遲：</a:t>
-            </a:r>
-          </a:p>
-          <a:p>
-            <a:pPr>
-              <a:defRPr sz="1150">
+              <a:t>• 🛡️ DROS-VEP Lite 核心評測倉</a:t>
+            </a:r>
+          </a:p>
+          <a:p>
+            <a:pPr>
+              <a:defRPr sz="1050">
                 <a:solidFill>
                   <a:srgbClr val="94A3B8"/>
                 </a:solidFill>
               </a:defRPr>
             </a:pPr>
             <a:r>
-              <a:t>   微秒級二進位 C-ABI 門閥，零網路往返開銷。</a:t>
-            </a:r>
-          </a:p>
-          <a:p>
-            <a:pPr>
-              <a:defRPr sz="1300" b="1">
+              <a:t>   github.com/Top-Celestial-Company-Ltd/DROS-VEP-lite</a:t>
+            </a:r>
+            <a:br/>
+            <a:r>
+              <a:t>零依賴 TDD 測試套件 (0.001s ALL 5 PASSED)。</a:t>
+            </a:r>
+          </a:p>
+          <a:p>
+            <a:pPr>
+              <a:defRPr sz="1200" b="1">
                 <a:solidFill>
                   <a:srgbClr val="F8FAFC"/>
                 </a:solidFill>
               </a:defRPr>
             </a:pPr>
             <a:r>
-              <a:t>• Zero-Heap 記憶體架構：</a:t>
-            </a:r>
-          </a:p>
-          <a:p>
-            <a:pPr>
-              <a:defRPr sz="1150">
+              <a:t>• 📦 NPM 開源外掛生態</a:t>
+            </a:r>
+          </a:p>
+          <a:p>
+            <a:pPr>
+              <a:defRPr sz="1050">
                 <a:solidFill>
                   <a:srgbClr val="94A3B8"/>
                 </a:solidFill>
               </a:defRPr>
             </a:pPr>
             <a:r>
-              <a:t>   暫存器級 Capability Bitmaps，無 GC 停頓，高頻穩健存活。</a:t>
-            </a:r>
-          </a:p>
-          <a:p>
-            <a:pPr>
-              <a:defRPr sz="1300" b="1">
+              <a:t>   npm install dsh-plugin-vajraclaw</a:t>
+            </a:r>
+            <a:br/>
+            <a:r>
+              <a:t>為社群開發者提供零依賴 1 微秒硬熔斷外掛。</a:t>
+            </a:r>
+          </a:p>
+          <a:p>
+            <a:pPr>
+              <a:defRPr sz="1200" b="1">
                 <a:solidFill>
                   <a:srgbClr val="F8FAFC"/>
                 </a:solidFill>
               </a:defRPr>
             </a:pPr>
             <a:r>
-              <a:t>• O(1) 常數時間動態撤銷：</a:t>
-            </a:r>
-          </a:p>
-          <a:p>
-            <a:pPr>
-              <a:defRPr sz="1150">
+              <a:t>• 🔒 美國臨時專利保護 (Patent Pending)</a:t>
+            </a:r>
+          </a:p>
+          <a:p>
+            <a:pPr>
+              <a:defRPr sz="1050">
                 <a:solidFill>
                   <a:srgbClr val="94A3B8"/>
                 </a:solidFill>
               </a:defRPr>
             </a:pPr>
             <a:r>
-              <a:t>   RCU 原子指針秒級切換，授權作廢立即生效。</a:t>
-            </a:r>
-          </a:p>
-        </p:txBody>
-      </p:sp>
-      <p:sp>
-        <p:nvSpPr>
-          <p:cNvPr id="5" name="Rounded Rectangle 4"/>
-          <p:cNvSpPr/>
-          <p:nvPr/>
-        </p:nvSpPr>
-        <p:spPr>
-          <a:xfrm>
-            <a:off x="6248095" y="1280160"/>
-            <a:ext cx="5212080" cy="5029200"/>
-          </a:xfrm>
-          <a:prstGeom prst="roundRect">
-            <a:avLst/>
-          </a:prstGeom>
-          <a:solidFill>
-            <a:srgbClr val="0F172A"/>
-          </a:solidFill>
-          <a:ln w="19050">
-            <a:solidFill>
-              <a:srgbClr val="38BDF8"/>
-            </a:solidFill>
-          </a:ln>
-        </p:spPr>
-        <p:style>
-          <a:lnRef idx="1">
-            <a:schemeClr val="accent1"/>
-          </a:lnRef>
-          <a:fillRef idx="3">
-            <a:schemeClr val="accent1"/>
-          </a:fillRef>
-          <a:effectRef idx="2">
-            <a:schemeClr val="accent1"/>
-          </a:effectRef>
-          <a:fontRef idx="minor">
-            <a:schemeClr val="lt1"/>
-          </a:fontRef>
-        </p:style>
-        <p:txBody>
-          <a:bodyPr rtlCol="0" anchor="ctr" wrap="square" lIns="228600" rIns="228600" tIns="182880" bIns="137160"/>
-          <a:lstStyle/>
-          <a:p>
-            <a:pPr algn="ctr">
-              <a:defRPr sz="1500" b="1">
-                <a:solidFill>
-                  <a:srgbClr val="38BDF8"/>
-                </a:solidFill>
-              </a:defRPr>
-            </a:pPr>
-            <a:r>
-              <a:t>📜 官方生態對齊與學術專利背書</a:t>
-            </a:r>
-          </a:p>
-          <a:p>
-            <a:pPr>
-              <a:defRPr sz="1300" b="1">
-                <a:solidFill>
-                  <a:srgbClr val="F8FAFC"/>
-                </a:solidFill>
-              </a:defRPr>
-            </a:pPr>
-            <a:r>
-              <a:t>• GLEIF vLEI 官方沙盒：</a:t>
-            </a:r>
-          </a:p>
-          <a:p>
-            <a:pPr>
-              <a:defRPr sz="1150">
-                <a:solidFill>
-                  <a:srgbClr val="94A3B8"/>
-                </a:solidFill>
-              </a:defRPr>
-            </a:pPr>
-            <a:r>
-              <a:t>   原生對接 ISO 17442-1/-2/-3 法人身分與角色憑證。</a:t>
-            </a:r>
-          </a:p>
-          <a:p>
-            <a:pPr>
-              <a:defRPr sz="1300" b="1">
-                <a:solidFill>
-                  <a:srgbClr val="F8FAFC"/>
-                </a:solidFill>
-              </a:defRPr>
-            </a:pPr>
-            <a:r>
-              <a:t>• moda MyData 模組：</a:t>
-            </a:r>
-          </a:p>
-          <a:p>
-            <a:pPr>
-              <a:defRPr sz="1150">
-                <a:solidFill>
-                  <a:srgbClr val="94A3B8"/>
-                </a:solidFill>
-              </a:defRPr>
-            </a:pPr>
-            <a:r>
-              <a:t>   符合數位發展部公民自主授權架構。</a:t>
-            </a:r>
-          </a:p>
-          <a:p>
-            <a:pPr>
-              <a:defRPr sz="1300" b="1">
-                <a:solidFill>
-                  <a:srgbClr val="F8FAFC"/>
-                </a:solidFill>
-              </a:defRPr>
-            </a:pPr>
-            <a:r>
-              <a:t>• 壽險公會理賠聯盟鏈：</a:t>
-            </a:r>
-          </a:p>
-          <a:p>
-            <a:pPr>
-              <a:defRPr sz="1150">
-                <a:solidFill>
-                  <a:srgbClr val="94A3B8"/>
-                </a:solidFill>
-              </a:defRPr>
-            </a:pPr>
-            <a:r>
-              <a:t>   跨產業 EHR 18 項 PHI 動態遮蔽與 ZKP 條款合規。</a:t>
-            </a:r>
-          </a:p>
-          <a:p>
-            <a:pPr>
-              <a:defRPr sz="1300" b="1">
-                <a:solidFill>
-                  <a:srgbClr val="F8FAFC"/>
-                </a:solidFill>
-              </a:defRPr>
-            </a:pPr>
-            <a:r>
-              <a:t>• Zenodo 權威論文三部曲：</a:t>
-            </a:r>
-          </a:p>
-          <a:p>
-            <a:pPr>
-              <a:defRPr sz="1150">
-                <a:solidFill>
-                  <a:srgbClr val="94A3B8"/>
-                </a:solidFill>
-              </a:defRPr>
-            </a:pPr>
-            <a:r>
-              <a:t>   DOI: 10.5281/zenodo.21833970, 22092008, 21903687。</a:t>
-            </a:r>
-          </a:p>
-          <a:p>
-            <a:pPr>
-              <a:defRPr sz="1300" b="1">
-                <a:solidFill>
-                  <a:srgbClr val="F8FAFC"/>
-                </a:solidFill>
-              </a:defRPr>
-            </a:pPr>
-            <a:r>
-              <a:t>• 美國臨時專利保護：</a:t>
-            </a:r>
-          </a:p>
-          <a:p>
-            <a:pPr>
-              <a:defRPr sz="1150">
-                <a:solidFill>
-                  <a:srgbClr val="94A3B8"/>
-                </a:solidFill>
-              </a:defRPr>
-            </a:pPr>
-            <a:r>
-              <a:t>   U.S. PPA No. 64/111,973 (Patent Pending)。</a:t>
+              <a:t>   U.S. Provisional Patent Application No. 64/111,973</a:t>
+            </a:r>
+            <a:br/>
+            <a:r>
+              <a:t>保護執行期帶內確定性治理與微秒熔斷核心架構。</a:t>
             </a:r>
           </a:p>
         </p:txBody>

</xml_diff>

<commit_message>
feat: place technical foundation (Zenodo trilogy DOIs, GitHub repos, patents) directly after technical architecture intro (Slide 4) for maximum credibility
</commit_message>
<xml_diff>
--- a/DROS_DEMO.pptx
+++ b/DROS_DEMO.pptx
@@ -4302,6 +4302,446 @@
               </a:defRPr>
             </a:pPr>
             <a:r>
+              <a:t>● ACADEMIC &amp; ENGINEERING BASE</a:t>
+            </a:r>
+          </a:p>
+          <a:p>
+            <a:pPr>
+              <a:defRPr sz="2200" b="1">
+                <a:solidFill>
+                  <a:srgbClr val="F8FAFC"/>
+                </a:solidFill>
+              </a:defRPr>
+            </a:pPr>
+            <a:r>
+              <a:t>技術底座背書：Zenodo 學術三部曲、GitHub 100% 驗證倉與專利佈局</a:t>
+            </a:r>
+          </a:p>
+        </p:txBody>
+      </p:sp>
+      <p:sp>
+        <p:nvSpPr>
+          <p:cNvPr id="4" name="Rounded Rectangle 3"/>
+          <p:cNvSpPr/>
+          <p:nvPr/>
+        </p:nvSpPr>
+        <p:spPr>
+          <a:xfrm>
+            <a:off x="731520" y="1280160"/>
+            <a:ext cx="5212080" cy="5029200"/>
+          </a:xfrm>
+          <a:prstGeom prst="roundRect">
+            <a:avLst/>
+          </a:prstGeom>
+          <a:solidFill>
+            <a:srgbClr val="0F172A"/>
+          </a:solidFill>
+          <a:ln w="19050">
+            <a:solidFill>
+              <a:srgbClr val="38BDF8"/>
+            </a:solidFill>
+          </a:ln>
+        </p:spPr>
+        <p:style>
+          <a:lnRef idx="1">
+            <a:schemeClr val="accent1"/>
+          </a:lnRef>
+          <a:fillRef idx="3">
+            <a:schemeClr val="accent1"/>
+          </a:fillRef>
+          <a:effectRef idx="2">
+            <a:schemeClr val="accent1"/>
+          </a:effectRef>
+          <a:fontRef idx="minor">
+            <a:schemeClr val="lt1"/>
+          </a:fontRef>
+        </p:style>
+        <p:txBody>
+          <a:bodyPr rtlCol="0" anchor="ctr" wrap="square" lIns="228600" rIns="228600" tIns="182880" bIns="137160"/>
+          <a:lstStyle/>
+          <a:p>
+            <a:pPr algn="ctr">
+              <a:defRPr sz="1500" b="1">
+                <a:solidFill>
+                  <a:srgbClr val="38BDF8"/>
+                </a:solidFill>
+              </a:defRPr>
+            </a:pPr>
+            <a:r>
+              <a:t>🏛️ Zenodo 國際權威學術論文三部曲</a:t>
+            </a:r>
+          </a:p>
+          <a:p>
+            <a:pPr>
+              <a:defRPr sz="1200" b="1">
+                <a:solidFill>
+                  <a:srgbClr val="F8FAFC"/>
+                </a:solidFill>
+              </a:defRPr>
+            </a:pPr>
+            <a:r>
+              <a:t>• 📖 學術導讀指南 (Guide Note)</a:t>
+            </a:r>
+          </a:p>
+          <a:p>
+            <a:pPr>
+              <a:defRPr sz="1050">
+                <a:solidFill>
+                  <a:srgbClr val="94A3B8"/>
+                </a:solidFill>
+              </a:defRPr>
+            </a:pPr>
+            <a:r>
+              <a:t>   DOI: 10.5281/zenodo.22114036</a:t>
+            </a:r>
+            <a:br/>
+            <a:r>
+              <a:t>面向自主 AI 工作負載的確定性執行期作業基板。</a:t>
+            </a:r>
+          </a:p>
+          <a:p>
+            <a:pPr>
+              <a:defRPr sz="1200" b="1">
+                <a:solidFill>
+                  <a:srgbClr val="F8FAFC"/>
+                </a:solidFill>
+              </a:defRPr>
+            </a:pPr>
+            <a:r>
+              <a:t>• 🏛️ Paper 1: DROS-6P 閉環架構</a:t>
+            </a:r>
+          </a:p>
+          <a:p>
+            <a:pPr>
+              <a:defRPr sz="1050">
+                <a:solidFill>
+                  <a:srgbClr val="94A3B8"/>
+                </a:solidFill>
+              </a:defRPr>
+            </a:pPr>
+            <a:r>
+              <a:t>   DOI: 10.5281/zenodo.21833970</a:t>
+            </a:r>
+            <a:br/>
+            <a:r>
+              <a:t>企業級 AI Agent 六大信任邊界之確定性治理。</a:t>
+            </a:r>
+          </a:p>
+          <a:p>
+            <a:pPr>
+              <a:defRPr sz="1200" b="1">
+                <a:solidFill>
+                  <a:srgbClr val="F8FAFC"/>
+                </a:solidFill>
+              </a:defRPr>
+            </a:pPr>
+            <a:r>
+              <a:t>• 🏛️ Paper 2: DROS 四層操作系統</a:t>
+            </a:r>
+          </a:p>
+          <a:p>
+            <a:pPr>
+              <a:defRPr sz="1050">
+                <a:solidFill>
+                  <a:srgbClr val="94A3B8"/>
+                </a:solidFill>
+              </a:defRPr>
+            </a:pPr>
+            <a:r>
+              <a:t>   DOI: 10.5281/zenodo.22092008</a:t>
+            </a:r>
+            <a:br/>
+            <a:r>
+              <a:t>彌合代理人至執行歸因鴻溝之四層架構。</a:t>
+            </a:r>
+          </a:p>
+          <a:p>
+            <a:pPr>
+              <a:defRPr sz="1200" b="1">
+                <a:solidFill>
+                  <a:srgbClr val="F8FAFC"/>
+                </a:solidFill>
+              </a:defRPr>
+            </a:pPr>
+            <a:r>
+              <a:t>• 🏛️ Paper 3: DROS-PGM 控制平面</a:t>
+            </a:r>
+          </a:p>
+          <a:p>
+            <a:pPr>
+              <a:defRPr sz="1050">
+                <a:solidFill>
+                  <a:srgbClr val="94A3B8"/>
+                </a:solidFill>
+              </a:defRPr>
+            </a:pPr>
+            <a:r>
+              <a:t>   DOI: 10.5281/zenodo.21903687</a:t>
+            </a:r>
+            <a:br/>
+            <a:r>
+              <a:t>內核級運行期安全與微秒硬熔斷控制平面。</a:t>
+            </a:r>
+          </a:p>
+        </p:txBody>
+      </p:sp>
+      <p:sp>
+        <p:nvSpPr>
+          <p:cNvPr id="5" name="Rounded Rectangle 4"/>
+          <p:cNvSpPr/>
+          <p:nvPr/>
+        </p:nvSpPr>
+        <p:spPr>
+          <a:xfrm>
+            <a:off x="6248095" y="1280160"/>
+            <a:ext cx="5212080" cy="5029200"/>
+          </a:xfrm>
+          <a:prstGeom prst="roundRect">
+            <a:avLst/>
+          </a:prstGeom>
+          <a:solidFill>
+            <a:srgbClr val="0F172A"/>
+          </a:solidFill>
+          <a:ln w="19050">
+            <a:solidFill>
+              <a:srgbClr val="4ADE80"/>
+            </a:solidFill>
+          </a:ln>
+        </p:spPr>
+        <p:style>
+          <a:lnRef idx="1">
+            <a:schemeClr val="accent1"/>
+          </a:lnRef>
+          <a:fillRef idx="3">
+            <a:schemeClr val="accent1"/>
+          </a:fillRef>
+          <a:effectRef idx="2">
+            <a:schemeClr val="accent1"/>
+          </a:effectRef>
+          <a:fontRef idx="minor">
+            <a:schemeClr val="lt1"/>
+          </a:fontRef>
+        </p:style>
+        <p:txBody>
+          <a:bodyPr rtlCol="0" anchor="ctr" wrap="square" lIns="228600" rIns="228600" tIns="182880" bIns="137160"/>
+          <a:lstStyle/>
+          <a:p>
+            <a:pPr algn="ctr">
+              <a:defRPr sz="1500" b="1">
+                <a:solidFill>
+                  <a:srgbClr val="4ADE80"/>
+                </a:solidFill>
+              </a:defRPr>
+            </a:pPr>
+            <a:r>
+              <a:t>💻 GitHub 100% 驗證開源倉與專利</a:t>
+            </a:r>
+          </a:p>
+          <a:p>
+            <a:pPr>
+              <a:defRPr sz="1200" b="1">
+                <a:solidFill>
+                  <a:srgbClr val="F8FAFC"/>
+                </a:solidFill>
+              </a:defRPr>
+            </a:pPr>
+            <a:r>
+              <a:t>• 🌐 Hackathon Showcase 展演倉</a:t>
+            </a:r>
+          </a:p>
+          <a:p>
+            <a:pPr>
+              <a:defRPr sz="1050">
+                <a:solidFill>
+                  <a:srgbClr val="94A3B8"/>
+                </a:solidFill>
+              </a:defRPr>
+            </a:pPr>
+            <a:r>
+              <a:t>   github.com/Top-Celestial-Company-Ltd/DROS-Hackathon-Showcase</a:t>
+            </a:r>
+            <a:br/>
+            <a:r>
+              <a:t>內含多軌互動發射台、REST API 與 6 大賽道對照。</a:t>
+            </a:r>
+          </a:p>
+          <a:p>
+            <a:pPr>
+              <a:defRPr sz="1200" b="1">
+                <a:solidFill>
+                  <a:srgbClr val="F8FAFC"/>
+                </a:solidFill>
+              </a:defRPr>
+            </a:pPr>
+            <a:r>
+              <a:t>• 🛡️ DROS-VEP Lite 核心評測倉</a:t>
+            </a:r>
+          </a:p>
+          <a:p>
+            <a:pPr>
+              <a:defRPr sz="1050">
+                <a:solidFill>
+                  <a:srgbClr val="94A3B8"/>
+                </a:solidFill>
+              </a:defRPr>
+            </a:pPr>
+            <a:r>
+              <a:t>   github.com/Top-Celestial-Company-Ltd/DROS-VEP-lite</a:t>
+            </a:r>
+            <a:br/>
+            <a:r>
+              <a:t>零依賴 TDD 測試套件 (0.001s ALL 5 PASSED)。</a:t>
+            </a:r>
+          </a:p>
+          <a:p>
+            <a:pPr>
+              <a:defRPr sz="1200" b="1">
+                <a:solidFill>
+                  <a:srgbClr val="F8FAFC"/>
+                </a:solidFill>
+              </a:defRPr>
+            </a:pPr>
+            <a:r>
+              <a:t>• 📦 NPM 開源外掛生態</a:t>
+            </a:r>
+          </a:p>
+          <a:p>
+            <a:pPr>
+              <a:defRPr sz="1050">
+                <a:solidFill>
+                  <a:srgbClr val="94A3B8"/>
+                </a:solidFill>
+              </a:defRPr>
+            </a:pPr>
+            <a:r>
+              <a:t>   npm install dsh-plugin-vajraclaw</a:t>
+            </a:r>
+            <a:br/>
+            <a:r>
+              <a:t>為社群開發者提供零依賴 1 微秒硬熔斷外掛。</a:t>
+            </a:r>
+          </a:p>
+          <a:p>
+            <a:pPr>
+              <a:defRPr sz="1200" b="1">
+                <a:solidFill>
+                  <a:srgbClr val="F8FAFC"/>
+                </a:solidFill>
+              </a:defRPr>
+            </a:pPr>
+            <a:r>
+              <a:t>• 🔒 美國臨時專利保護 (Patent Pending)</a:t>
+            </a:r>
+          </a:p>
+          <a:p>
+            <a:pPr>
+              <a:defRPr sz="1050">
+                <a:solidFill>
+                  <a:srgbClr val="94A3B8"/>
+                </a:solidFill>
+              </a:defRPr>
+            </a:pPr>
+            <a:r>
+              <a:t>   U.S. Provisional Patent Application No. 64/111,973</a:t>
+            </a:r>
+            <a:br/>
+            <a:r>
+              <a:t>保護執行期帶內確定性治理與微秒熔斷核心架構。</a:t>
+            </a:r>
+          </a:p>
+        </p:txBody>
+      </p:sp>
+    </p:spTree>
+  </p:cSld>
+  <p:clrMapOvr>
+    <a:masterClrMapping/>
+  </p:clrMapOvr>
+</p:sld>
+</file>
+
+<file path=ppt/slides/slide5.xml><?xml version="1.0" encoding="utf-8"?>
+<p:sld xmlns:a="http://schemas.openxmlformats.org/drawingml/2006/main" xmlns:p="http://schemas.openxmlformats.org/presentationml/2006/main" xmlns:r="http://schemas.openxmlformats.org/officeDocument/2006/relationships">
+  <p:cSld>
+    <p:spTree>
+      <p:nvGrpSpPr>
+        <p:cNvPr id="1" name=""/>
+        <p:cNvGrpSpPr/>
+        <p:nvPr/>
+      </p:nvGrpSpPr>
+      <p:grpSpPr/>
+      <p:sp>
+        <p:nvSpPr>
+          <p:cNvPr id="2" name="Rectangle 1"/>
+          <p:cNvSpPr/>
+          <p:nvPr/>
+        </p:nvSpPr>
+        <p:spPr>
+          <a:xfrm>
+            <a:off x="0" y="0"/>
+            <a:ext cx="12191695" cy="6858000"/>
+          </a:xfrm>
+          <a:prstGeom prst="rect">
+            <a:avLst/>
+          </a:prstGeom>
+          <a:solidFill>
+            <a:srgbClr val="070A12"/>
+          </a:solidFill>
+          <a:ln>
+            <a:noFill/>
+          </a:ln>
+        </p:spPr>
+        <p:style>
+          <a:lnRef idx="1">
+            <a:schemeClr val="accent1"/>
+          </a:lnRef>
+          <a:fillRef idx="3">
+            <a:schemeClr val="accent1"/>
+          </a:fillRef>
+          <a:effectRef idx="2">
+            <a:schemeClr val="accent1"/>
+          </a:effectRef>
+          <a:fontRef idx="minor">
+            <a:schemeClr val="lt1"/>
+          </a:fontRef>
+        </p:style>
+        <p:txBody>
+          <a:bodyPr rtlCol="0" anchor="ctr"/>
+          <a:lstStyle/>
+          <a:p>
+            <a:pPr algn="ctr"/>
+          </a:p>
+        </p:txBody>
+      </p:sp>
+      <p:sp>
+        <p:nvSpPr>
+          <p:cNvPr id="3" name="TextBox 2"/>
+          <p:cNvSpPr txBox="1"/>
+          <p:nvPr/>
+        </p:nvSpPr>
+        <p:spPr>
+          <a:xfrm>
+            <a:off x="731520" y="365760"/>
+            <a:ext cx="10728655" cy="822960"/>
+          </a:xfrm>
+          <a:prstGeom prst="rect">
+            <a:avLst/>
+          </a:prstGeom>
+          <a:noFill/>
+        </p:spPr>
+        <p:txBody>
+          <a:bodyPr wrap="square" lIns="0" rIns="0" tIns="0" bIns="0">
+            <a:spAutoFit/>
+          </a:bodyPr>
+          <a:lstStyle/>
+          <a:p>
+            <a:pPr>
+              <a:defRPr sz="1100" b="1">
+                <a:solidFill>
+                  <a:srgbClr val="38BDF8"/>
+                </a:solidFill>
+              </a:defRPr>
+            </a:pPr>
+            <a:r>
               <a:t>● CROSS-INDUSTRY MAPPING</a:t>
             </a:r>
           </a:p>
@@ -4795,7 +5235,7 @@
 </p:sld>
 </file>
 
-<file path=ppt/slides/slide5.xml><?xml version="1.0" encoding="utf-8"?>
+<file path=ppt/slides/slide6.xml><?xml version="1.0" encoding="utf-8"?>
 <p:sld xmlns:a="http://schemas.openxmlformats.org/drawingml/2006/main" xmlns:p="http://schemas.openxmlformats.org/presentationml/2006/main" xmlns:r="http://schemas.openxmlformats.org/officeDocument/2006/relationships">
   <p:cSld>
     <p:spTree>
@@ -5133,7 +5573,7 @@
 </p:sld>
 </file>
 
-<file path=ppt/slides/slide6.xml><?xml version="1.0" encoding="utf-8"?>
+<file path=ppt/slides/slide7.xml><?xml version="1.0" encoding="utf-8"?>
 <p:sld xmlns:a="http://schemas.openxmlformats.org/drawingml/2006/main" xmlns:p="http://schemas.openxmlformats.org/presentationml/2006/main" xmlns:r="http://schemas.openxmlformats.org/officeDocument/2006/relationships">
   <p:cSld>
     <p:spTree>
@@ -5379,446 +5819,6 @@
             </a:pPr>
             <a:r>
               <a:t>   執行 python test_verification_suite.py ➔ 0.001 秒 5/5 斷言全數通過！</a:t>
-            </a:r>
-          </a:p>
-        </p:txBody>
-      </p:sp>
-    </p:spTree>
-  </p:cSld>
-  <p:clrMapOvr>
-    <a:masterClrMapping/>
-  </p:clrMapOvr>
-</p:sld>
-</file>
-
-<file path=ppt/slides/slide7.xml><?xml version="1.0" encoding="utf-8"?>
-<p:sld xmlns:a="http://schemas.openxmlformats.org/drawingml/2006/main" xmlns:p="http://schemas.openxmlformats.org/presentationml/2006/main" xmlns:r="http://schemas.openxmlformats.org/officeDocument/2006/relationships">
-  <p:cSld>
-    <p:spTree>
-      <p:nvGrpSpPr>
-        <p:cNvPr id="1" name=""/>
-        <p:cNvGrpSpPr/>
-        <p:nvPr/>
-      </p:nvGrpSpPr>
-      <p:grpSpPr/>
-      <p:sp>
-        <p:nvSpPr>
-          <p:cNvPr id="2" name="Rectangle 1"/>
-          <p:cNvSpPr/>
-          <p:nvPr/>
-        </p:nvSpPr>
-        <p:spPr>
-          <a:xfrm>
-            <a:off x="0" y="0"/>
-            <a:ext cx="12191695" cy="6858000"/>
-          </a:xfrm>
-          <a:prstGeom prst="rect">
-            <a:avLst/>
-          </a:prstGeom>
-          <a:solidFill>
-            <a:srgbClr val="070A12"/>
-          </a:solidFill>
-          <a:ln>
-            <a:noFill/>
-          </a:ln>
-        </p:spPr>
-        <p:style>
-          <a:lnRef idx="1">
-            <a:schemeClr val="accent1"/>
-          </a:lnRef>
-          <a:fillRef idx="3">
-            <a:schemeClr val="accent1"/>
-          </a:fillRef>
-          <a:effectRef idx="2">
-            <a:schemeClr val="accent1"/>
-          </a:effectRef>
-          <a:fontRef idx="minor">
-            <a:schemeClr val="lt1"/>
-          </a:fontRef>
-        </p:style>
-        <p:txBody>
-          <a:bodyPr rtlCol="0" anchor="ctr"/>
-          <a:lstStyle/>
-          <a:p>
-            <a:pPr algn="ctr"/>
-          </a:p>
-        </p:txBody>
-      </p:sp>
-      <p:sp>
-        <p:nvSpPr>
-          <p:cNvPr id="3" name="TextBox 2"/>
-          <p:cNvSpPr txBox="1"/>
-          <p:nvPr/>
-        </p:nvSpPr>
-        <p:spPr>
-          <a:xfrm>
-            <a:off x="731520" y="365760"/>
-            <a:ext cx="10728655" cy="822960"/>
-          </a:xfrm>
-          <a:prstGeom prst="rect">
-            <a:avLst/>
-          </a:prstGeom>
-          <a:noFill/>
-        </p:spPr>
-        <p:txBody>
-          <a:bodyPr wrap="square" lIns="0" rIns="0" tIns="0" bIns="0">
-            <a:spAutoFit/>
-          </a:bodyPr>
-          <a:lstStyle/>
-          <a:p>
-            <a:pPr>
-              <a:defRPr sz="1100" b="1">
-                <a:solidFill>
-                  <a:srgbClr val="38BDF8"/>
-                </a:solidFill>
-              </a:defRPr>
-            </a:pPr>
-            <a:r>
-              <a:t>● ACADEMIC &amp; VERIFICATION</a:t>
-            </a:r>
-          </a:p>
-          <a:p>
-            <a:pPr>
-              <a:defRPr sz="2200" b="1">
-                <a:solidFill>
-                  <a:srgbClr val="F8FAFC"/>
-                </a:solidFill>
-              </a:defRPr>
-            </a:pPr>
-            <a:r>
-              <a:t>權威學術三部曲、GitHub 100% 驗證開源倉與專利佈局</a:t>
-            </a:r>
-          </a:p>
-        </p:txBody>
-      </p:sp>
-      <p:sp>
-        <p:nvSpPr>
-          <p:cNvPr id="4" name="Rounded Rectangle 3"/>
-          <p:cNvSpPr/>
-          <p:nvPr/>
-        </p:nvSpPr>
-        <p:spPr>
-          <a:xfrm>
-            <a:off x="731520" y="1280160"/>
-            <a:ext cx="5212080" cy="5029200"/>
-          </a:xfrm>
-          <a:prstGeom prst="roundRect">
-            <a:avLst/>
-          </a:prstGeom>
-          <a:solidFill>
-            <a:srgbClr val="0F172A"/>
-          </a:solidFill>
-          <a:ln w="19050">
-            <a:solidFill>
-              <a:srgbClr val="38BDF8"/>
-            </a:solidFill>
-          </a:ln>
-        </p:spPr>
-        <p:style>
-          <a:lnRef idx="1">
-            <a:schemeClr val="accent1"/>
-          </a:lnRef>
-          <a:fillRef idx="3">
-            <a:schemeClr val="accent1"/>
-          </a:fillRef>
-          <a:effectRef idx="2">
-            <a:schemeClr val="accent1"/>
-          </a:effectRef>
-          <a:fontRef idx="minor">
-            <a:schemeClr val="lt1"/>
-          </a:fontRef>
-        </p:style>
-        <p:txBody>
-          <a:bodyPr rtlCol="0" anchor="ctr" wrap="square" lIns="228600" rIns="228600" tIns="182880" bIns="137160"/>
-          <a:lstStyle/>
-          <a:p>
-            <a:pPr algn="ctr">
-              <a:defRPr sz="1500" b="1">
-                <a:solidFill>
-                  <a:srgbClr val="38BDF8"/>
-                </a:solidFill>
-              </a:defRPr>
-            </a:pPr>
-            <a:r>
-              <a:t>🏛️ Zenodo 國際權威學術三部曲</a:t>
-            </a:r>
-          </a:p>
-          <a:p>
-            <a:pPr>
-              <a:defRPr sz="1200" b="1">
-                <a:solidFill>
-                  <a:srgbClr val="F8FAFC"/>
-                </a:solidFill>
-              </a:defRPr>
-            </a:pPr>
-            <a:r>
-              <a:t>• 📖 學術導讀指南 (Guide Note)</a:t>
-            </a:r>
-          </a:p>
-          <a:p>
-            <a:pPr>
-              <a:defRPr sz="1050">
-                <a:solidFill>
-                  <a:srgbClr val="94A3B8"/>
-                </a:solidFill>
-              </a:defRPr>
-            </a:pPr>
-            <a:r>
-              <a:t>   DOI: 10.5281/zenodo.22114036</a:t>
-            </a:r>
-            <a:br/>
-            <a:r>
-              <a:t>面向自主 AI 工作負載的確定性執行期作業基板。</a:t>
-            </a:r>
-          </a:p>
-          <a:p>
-            <a:pPr>
-              <a:defRPr sz="1200" b="1">
-                <a:solidFill>
-                  <a:srgbClr val="F8FAFC"/>
-                </a:solidFill>
-              </a:defRPr>
-            </a:pPr>
-            <a:r>
-              <a:t>• 🏛️ Paper 1: DROS-6P 閉環架構</a:t>
-            </a:r>
-          </a:p>
-          <a:p>
-            <a:pPr>
-              <a:defRPr sz="1050">
-                <a:solidFill>
-                  <a:srgbClr val="94A3B8"/>
-                </a:solidFill>
-              </a:defRPr>
-            </a:pPr>
-            <a:r>
-              <a:t>   DOI: 10.5281/zenodo.21833970</a:t>
-            </a:r>
-            <a:br/>
-            <a:r>
-              <a:t>企業級 AI Agent 六大信任邊界之確定性治理。</a:t>
-            </a:r>
-          </a:p>
-          <a:p>
-            <a:pPr>
-              <a:defRPr sz="1200" b="1">
-                <a:solidFill>
-                  <a:srgbClr val="F8FAFC"/>
-                </a:solidFill>
-              </a:defRPr>
-            </a:pPr>
-            <a:r>
-              <a:t>• 🏛️ Paper 2: DROS 四層操作系統</a:t>
-            </a:r>
-          </a:p>
-          <a:p>
-            <a:pPr>
-              <a:defRPr sz="1050">
-                <a:solidFill>
-                  <a:srgbClr val="94A3B8"/>
-                </a:solidFill>
-              </a:defRPr>
-            </a:pPr>
-            <a:r>
-              <a:t>   DOI: 10.5281/zenodo.22092008</a:t>
-            </a:r>
-            <a:br/>
-            <a:r>
-              <a:t>彌合代理人至執行歸因鴻溝之四層架構。</a:t>
-            </a:r>
-          </a:p>
-          <a:p>
-            <a:pPr>
-              <a:defRPr sz="1200" b="1">
-                <a:solidFill>
-                  <a:srgbClr val="F8FAFC"/>
-                </a:solidFill>
-              </a:defRPr>
-            </a:pPr>
-            <a:r>
-              <a:t>• 🏛️ Paper 3: DROS-PGM 控制平面</a:t>
-            </a:r>
-          </a:p>
-          <a:p>
-            <a:pPr>
-              <a:defRPr sz="1050">
-                <a:solidFill>
-                  <a:srgbClr val="94A3B8"/>
-                </a:solidFill>
-              </a:defRPr>
-            </a:pPr>
-            <a:r>
-              <a:t>   DOI: 10.5281/zenodo.21903687</a:t>
-            </a:r>
-            <a:br/>
-            <a:r>
-              <a:t>內核級運行期安全與微秒硬熔斷控制平面。</a:t>
-            </a:r>
-          </a:p>
-        </p:txBody>
-      </p:sp>
-      <p:sp>
-        <p:nvSpPr>
-          <p:cNvPr id="5" name="Rounded Rectangle 4"/>
-          <p:cNvSpPr/>
-          <p:nvPr/>
-        </p:nvSpPr>
-        <p:spPr>
-          <a:xfrm>
-            <a:off x="6248095" y="1280160"/>
-            <a:ext cx="5212080" cy="5029200"/>
-          </a:xfrm>
-          <a:prstGeom prst="roundRect">
-            <a:avLst/>
-          </a:prstGeom>
-          <a:solidFill>
-            <a:srgbClr val="0F172A"/>
-          </a:solidFill>
-          <a:ln w="19050">
-            <a:solidFill>
-              <a:srgbClr val="4ADE80"/>
-            </a:solidFill>
-          </a:ln>
-        </p:spPr>
-        <p:style>
-          <a:lnRef idx="1">
-            <a:schemeClr val="accent1"/>
-          </a:lnRef>
-          <a:fillRef idx="3">
-            <a:schemeClr val="accent1"/>
-          </a:fillRef>
-          <a:effectRef idx="2">
-            <a:schemeClr val="accent1"/>
-          </a:effectRef>
-          <a:fontRef idx="minor">
-            <a:schemeClr val="lt1"/>
-          </a:fontRef>
-        </p:style>
-        <p:txBody>
-          <a:bodyPr rtlCol="0" anchor="ctr" wrap="square" lIns="228600" rIns="228600" tIns="182880" bIns="137160"/>
-          <a:lstStyle/>
-          <a:p>
-            <a:pPr algn="ctr">
-              <a:defRPr sz="1500" b="1">
-                <a:solidFill>
-                  <a:srgbClr val="4ADE80"/>
-                </a:solidFill>
-              </a:defRPr>
-            </a:pPr>
-            <a:r>
-              <a:t>💻 100% 可重現 GitHub 開源倉與專利</a:t>
-            </a:r>
-          </a:p>
-          <a:p>
-            <a:pPr>
-              <a:defRPr sz="1200" b="1">
-                <a:solidFill>
-                  <a:srgbClr val="F8FAFC"/>
-                </a:solidFill>
-              </a:defRPr>
-            </a:pPr>
-            <a:r>
-              <a:t>• 🌐 Hackathon Showcase 展演倉</a:t>
-            </a:r>
-          </a:p>
-          <a:p>
-            <a:pPr>
-              <a:defRPr sz="1050">
-                <a:solidFill>
-                  <a:srgbClr val="94A3B8"/>
-                </a:solidFill>
-              </a:defRPr>
-            </a:pPr>
-            <a:r>
-              <a:t>   github.com/Top-Celestial-Company-Ltd/DROS-Hackathon-Showcase</a:t>
-            </a:r>
-            <a:br/>
-            <a:r>
-              <a:t>內含多軌互動發射台、REST API 與 6 大賽道對照。</a:t>
-            </a:r>
-          </a:p>
-          <a:p>
-            <a:pPr>
-              <a:defRPr sz="1200" b="1">
-                <a:solidFill>
-                  <a:srgbClr val="F8FAFC"/>
-                </a:solidFill>
-              </a:defRPr>
-            </a:pPr>
-            <a:r>
-              <a:t>• 🛡️ DROS-VEP Lite 核心評測倉</a:t>
-            </a:r>
-          </a:p>
-          <a:p>
-            <a:pPr>
-              <a:defRPr sz="1050">
-                <a:solidFill>
-                  <a:srgbClr val="94A3B8"/>
-                </a:solidFill>
-              </a:defRPr>
-            </a:pPr>
-            <a:r>
-              <a:t>   github.com/Top-Celestial-Company-Ltd/DROS-VEP-lite</a:t>
-            </a:r>
-            <a:br/>
-            <a:r>
-              <a:t>零依賴 TDD 測試套件 (0.001s ALL 5 PASSED)。</a:t>
-            </a:r>
-          </a:p>
-          <a:p>
-            <a:pPr>
-              <a:defRPr sz="1200" b="1">
-                <a:solidFill>
-                  <a:srgbClr val="F8FAFC"/>
-                </a:solidFill>
-              </a:defRPr>
-            </a:pPr>
-            <a:r>
-              <a:t>• 📦 NPM 開源外掛生態</a:t>
-            </a:r>
-          </a:p>
-          <a:p>
-            <a:pPr>
-              <a:defRPr sz="1050">
-                <a:solidFill>
-                  <a:srgbClr val="94A3B8"/>
-                </a:solidFill>
-              </a:defRPr>
-            </a:pPr>
-            <a:r>
-              <a:t>   npm install dsh-plugin-vajraclaw</a:t>
-            </a:r>
-            <a:br/>
-            <a:r>
-              <a:t>為社群開發者提供零依賴 1 微秒硬熔斷外掛。</a:t>
-            </a:r>
-          </a:p>
-          <a:p>
-            <a:pPr>
-              <a:defRPr sz="1200" b="1">
-                <a:solidFill>
-                  <a:srgbClr val="F8FAFC"/>
-                </a:solidFill>
-              </a:defRPr>
-            </a:pPr>
-            <a:r>
-              <a:t>• 🔒 美國臨時專利保護 (Patent Pending)</a:t>
-            </a:r>
-          </a:p>
-          <a:p>
-            <a:pPr>
-              <a:defRPr sz="1050">
-                <a:solidFill>
-                  <a:srgbClr val="94A3B8"/>
-                </a:solidFill>
-              </a:defRPr>
-            </a:pPr>
-            <a:r>
-              <a:t>   U.S. Provisional Patent Application No. 64/111,973</a:t>
-            </a:r>
-            <a:br/>
-            <a:r>
-              <a:t>保護執行期帶內確定性治理與微秒熔斷核心架構。</a:t>
             </a:r>
           </a:p>
         </p:txBody>

</xml_diff>

<commit_message>
feat: add 'Personal Free Easter Egg' (Agent Security is Public Infrastructure for Everyone) with NPM & GitHub links on slide 4
</commit_message>
<xml_diff>
--- a/DROS_DEMO.pptx
+++ b/DROS_DEMO.pptx
@@ -4314,7 +4314,7 @@
               </a:defRPr>
             </a:pPr>
             <a:r>
-              <a:t>技術底座背書：Zenodo 學術三部曲、GitHub 100% 驗證倉與專利佈局</a:t>
+              <a:t>技術底座背書：Zenodo 學術三部曲、GitHub 100% 驗證倉與「全民安全彩蛋」</a:t>
             </a:r>
           </a:p>
         </p:txBody>
@@ -4373,7 +4373,7 @@
           </a:p>
           <a:p>
             <a:pPr>
-              <a:defRPr sz="1200" b="1">
+              <a:defRPr sz="1150" b="1">
                 <a:solidFill>
                   <a:srgbClr val="F8FAFC"/>
                 </a:solidFill>
@@ -4385,7 +4385,7 @@
           </a:p>
           <a:p>
             <a:pPr>
-              <a:defRPr sz="1050">
+              <a:defRPr sz="1000">
                 <a:solidFill>
                   <a:srgbClr val="94A3B8"/>
                 </a:solidFill>
@@ -4401,7 +4401,7 @@
           </a:p>
           <a:p>
             <a:pPr>
-              <a:defRPr sz="1200" b="1">
+              <a:defRPr sz="1150" b="1">
                 <a:solidFill>
                   <a:srgbClr val="F8FAFC"/>
                 </a:solidFill>
@@ -4413,7 +4413,7 @@
           </a:p>
           <a:p>
             <a:pPr>
-              <a:defRPr sz="1050">
+              <a:defRPr sz="1000">
                 <a:solidFill>
                   <a:srgbClr val="94A3B8"/>
                 </a:solidFill>
@@ -4429,7 +4429,7 @@
           </a:p>
           <a:p>
             <a:pPr>
-              <a:defRPr sz="1200" b="1">
+              <a:defRPr sz="1150" b="1">
                 <a:solidFill>
                   <a:srgbClr val="F8FAFC"/>
                 </a:solidFill>
@@ -4441,7 +4441,7 @@
           </a:p>
           <a:p>
             <a:pPr>
-              <a:defRPr sz="1050">
+              <a:defRPr sz="1000">
                 <a:solidFill>
                   <a:srgbClr val="94A3B8"/>
                 </a:solidFill>
@@ -4457,7 +4457,7 @@
           </a:p>
           <a:p>
             <a:pPr>
-              <a:defRPr sz="1200" b="1">
+              <a:defRPr sz="1150" b="1">
                 <a:solidFill>
                   <a:srgbClr val="F8FAFC"/>
                 </a:solidFill>
@@ -4469,7 +4469,7 @@
           </a:p>
           <a:p>
             <a:pPr>
-              <a:defRPr sz="1050">
+              <a:defRPr sz="1000">
                 <a:solidFill>
                   <a:srgbClr val="94A3B8"/>
                 </a:solidFill>
@@ -4527,31 +4527,31 @@
           <a:lstStyle/>
           <a:p>
             <a:pPr algn="ctr">
-              <a:defRPr sz="1500" b="1">
+              <a:defRPr sz="1400" b="1">
                 <a:solidFill>
                   <a:srgbClr val="4ADE80"/>
                 </a:solidFill>
               </a:defRPr>
             </a:pPr>
             <a:r>
-              <a:t>💻 GitHub 100% 驗證開源倉與專利</a:t>
-            </a:r>
-          </a:p>
-          <a:p>
-            <a:pPr>
-              <a:defRPr sz="1200" b="1">
+              <a:t>💻 GitHub 100% 驗證倉 ＆ 🎁 全民安全彩蛋</a:t>
+            </a:r>
+          </a:p>
+          <a:p>
+            <a:pPr>
+              <a:defRPr sz="1100" b="1">
                 <a:solidFill>
                   <a:srgbClr val="F8FAFC"/>
                 </a:solidFill>
               </a:defRPr>
             </a:pPr>
             <a:r>
-              <a:t>• 🌐 Hackathon Showcase 展演倉</a:t>
-            </a:r>
-          </a:p>
-          <a:p>
-            <a:pPr>
-              <a:defRPr sz="1050">
+              <a:t>• 🌐 Hackathon Showcase 展演主倉</a:t>
+            </a:r>
+          </a:p>
+          <a:p>
+            <a:pPr>
+              <a:defRPr sz="950">
                 <a:solidFill>
                   <a:srgbClr val="94A3B8"/>
                 </a:solidFill>
@@ -4562,12 +4562,12 @@
             </a:r>
             <a:br/>
             <a:r>
-              <a:t>內含多軌互動發射台、REST API 與 6 大賽道對照。</a:t>
-            </a:r>
-          </a:p>
-          <a:p>
-            <a:pPr>
-              <a:defRPr sz="1200" b="1">
+              <a:t>多軌互動發射台、REST API 與 6 大賽道對照。</a:t>
+            </a:r>
+          </a:p>
+          <a:p>
+            <a:pPr>
+              <a:defRPr sz="1100" b="1">
                 <a:solidFill>
                   <a:srgbClr val="F8FAFC"/>
                 </a:solidFill>
@@ -4579,7 +4579,7 @@
           </a:p>
           <a:p>
             <a:pPr>
-              <a:defRPr sz="1050">
+              <a:defRPr sz="950">
                 <a:solidFill>
                   <a:srgbClr val="94A3B8"/>
                 </a:solidFill>
@@ -4595,58 +4595,58 @@
           </a:p>
           <a:p>
             <a:pPr>
-              <a:defRPr sz="1200" b="1">
+              <a:defRPr sz="1100" b="1">
+                <a:solidFill>
+                  <a:srgbClr val="FBBF24"/>
+                </a:solidFill>
+              </a:defRPr>
+            </a:pPr>
+            <a:r>
+              <a:t>• 🎁【個人 Free 安全彩蛋】Agent 安全應是全民基建！</a:t>
+            </a:r>
+          </a:p>
+          <a:p>
+            <a:pPr>
+              <a:defRPr sz="950">
                 <a:solidFill>
                   <a:srgbClr val="F8FAFC"/>
                 </a:solidFill>
               </a:defRPr>
             </a:pPr>
             <a:r>
-              <a:t>• 📦 NPM 開源外掛生態</a:t>
-            </a:r>
-          </a:p>
-          <a:p>
-            <a:pPr>
-              <a:defRPr sz="1050">
+              <a:t>   NPM 開源外掛: npm install dsh-plugin-vajraclaw</a:t>
+            </a:r>
+            <a:br/>
+            <a:r>
+              <a:t>GitHub: github.com/Top-Celestial-Company-Ltd/dsh-plugin-vajraclaw</a:t>
+            </a:r>
+            <a:br/>
+            <a:r>
+              <a:t>👉 任何個人開發者在本地執行 Agent，皆可免費獲得 1 微秒帶內硬熔斷保護！</a:t>
+            </a:r>
+          </a:p>
+          <a:p>
+            <a:pPr>
+              <a:defRPr sz="1100" b="1">
+                <a:solidFill>
+                  <a:srgbClr val="F8FAFC"/>
+                </a:solidFill>
+              </a:defRPr>
+            </a:pPr>
+            <a:r>
+              <a:t>• 🔒 美國臨時專利保護 (Patent Pending)</a:t>
+            </a:r>
+          </a:p>
+          <a:p>
+            <a:pPr>
+              <a:defRPr sz="950">
                 <a:solidFill>
                   <a:srgbClr val="94A3B8"/>
                 </a:solidFill>
               </a:defRPr>
             </a:pPr>
             <a:r>
-              <a:t>   npm install dsh-plugin-vajraclaw</a:t>
-            </a:r>
-            <a:br/>
-            <a:r>
-              <a:t>為社群開發者提供零依賴 1 微秒硬熔斷外掛。</a:t>
-            </a:r>
-          </a:p>
-          <a:p>
-            <a:pPr>
-              <a:defRPr sz="1200" b="1">
-                <a:solidFill>
-                  <a:srgbClr val="F8FAFC"/>
-                </a:solidFill>
-              </a:defRPr>
-            </a:pPr>
-            <a:r>
-              <a:t>• 🔒 美國臨時專利保護 (Patent Pending)</a:t>
-            </a:r>
-          </a:p>
-          <a:p>
-            <a:pPr>
-              <a:defRPr sz="1050">
-                <a:solidFill>
-                  <a:srgbClr val="94A3B8"/>
-                </a:solidFill>
-              </a:defRPr>
-            </a:pPr>
-            <a:r>
-              <a:t>   U.S. Provisional Patent Application No. 64/111,973</a:t>
-            </a:r>
-            <a:br/>
-            <a:r>
-              <a:t>保護執行期帶內確定性治理與微秒熔斷核心架構。</a:t>
+              <a:t>   U.S. PPA No. 64/111,973 (保護執行期帶內確定性治理核心)</a:t>
             </a:r>
           </a:p>
         </p:txBody>

</xml_diff>

<commit_message>
fix(deck): calibrate Easter egg wording strictly to 'Free License for Individuals' to protect proprietary IP while empowering community
</commit_message>
<xml_diff>
--- a/DROS_DEMO.pptx
+++ b/DROS_DEMO.pptx
@@ -4314,7 +4314,7 @@
               </a:defRPr>
             </a:pPr>
             <a:r>
-              <a:t>技術底座背書：Zenodo 學術三部曲、GitHub 100% 驗證倉與「全民安全彩蛋」</a:t>
+              <a:t>技術底座背書：Zenodo 學術三部曲、GitHub 100% 驗證倉與「個人免費授權彩蛋」</a:t>
             </a:r>
           </a:p>
         </p:txBody>
@@ -4614,7 +4614,7 @@
               </a:defRPr>
             </a:pPr>
             <a:r>
-              <a:t>   NPM 開源外掛: npm install dsh-plugin-vajraclaw</a:t>
+              <a:t>   NPM 套件: npm install dsh-plugin-vajraclaw</a:t>
             </a:r>
             <a:br/>
             <a:r>
@@ -4622,7 +4622,7 @@
             </a:r>
             <a:br/>
             <a:r>
-              <a:t>👉 任何個人開發者在本地執行 Agent，皆可免費獲得 1 微秒帶內硬熔斷保護！</a:t>
+              <a:t>👉 提供「個人非商業永久免費授權 (Free License)」，讓每位個人開發者在本地執行 Agent 享有 1 微秒帶內硬熔斷保護！</a:t>
             </a:r>
           </a:p>
           <a:p>

</xml_diff>

<commit_message>
feat: rebuild pitch deck with readable 14-16pt font sizes across all cards and dedicated Slide 3 (3 Components) & Slide 4 (Golden Triangle)
</commit_message>
<xml_diff>
--- a/DROS_DEMO.pptx
+++ b/DROS_DEMO.pptx
@@ -13,6 +13,7 @@
     <p:sldId id="261" r:id="rId12"/>
     <p:sldId id="262" r:id="rId13"/>
     <p:sldId id="263" r:id="rId14"/>
+    <p:sldId id="264" r:id="rId15"/>
   </p:sldIdLst>
   <p:sldSz cx="12191695" cy="6858000" type="screen4x3"/>
   <p:notesSz cx="6858000" cy="9144000"/>
@@ -3146,8 +3147,8 @@
         </p:nvSpPr>
         <p:spPr>
           <a:xfrm>
-            <a:off x="731520" y="548640"/>
-            <a:ext cx="10728655" cy="1828800"/>
+            <a:off x="731520" y="457200"/>
+            <a:ext cx="10728655" cy="1645920"/>
           </a:xfrm>
           <a:prstGeom prst="rect">
             <a:avLst/>
@@ -3161,7 +3162,7 @@
           <a:lstStyle/>
           <a:p>
             <a:pPr>
-              <a:defRPr sz="1200" b="1">
+              <a:defRPr sz="1300" b="1">
                 <a:solidFill>
                   <a:srgbClr val="38BDF8"/>
                 </a:solidFill>
@@ -3173,7 +3174,7 @@
           </a:p>
           <a:p>
             <a:pPr>
-              <a:defRPr sz="3000" b="1">
+              <a:defRPr sz="3200" b="1">
                 <a:solidFill>
                   <a:srgbClr val="F8FAFC"/>
                 </a:solidFill>
@@ -3185,9 +3186,9 @@
           </a:p>
           <a:p>
             <a:pPr>
-              <a:defRPr sz="1500">
-                <a:solidFill>
-                  <a:srgbClr val="94A3B8"/>
+              <a:defRPr sz="1600">
+                <a:solidFill>
+                  <a:srgbClr val="CBD5E1"/>
                 </a:solidFill>
               </a:defRPr>
             </a:pPr>
@@ -3205,8 +3206,8 @@
         </p:nvSpPr>
         <p:spPr>
           <a:xfrm>
-            <a:off x="731520" y="2468880"/>
-            <a:ext cx="10728655" cy="3840480"/>
+            <a:off x="731520" y="2286000"/>
+            <a:ext cx="10728655" cy="4114800"/>
           </a:xfrm>
           <a:prstGeom prst="roundRect">
             <a:avLst/>
@@ -3235,11 +3236,11 @@
           </a:fontRef>
         </p:style>
         <p:txBody>
-          <a:bodyPr rtlCol="0" anchor="ctr" wrap="square" lIns="228600" rIns="228600" tIns="182880" bIns="137160"/>
+          <a:bodyPr rtlCol="0" anchor="ctr" wrap="square" lIns="274320" rIns="274320" tIns="228600" bIns="182880"/>
           <a:lstStyle/>
           <a:p>
             <a:pPr algn="ctr">
-              <a:defRPr sz="1600" b="1">
+              <a:defRPr sz="1800" b="1">
                 <a:solidFill>
                   <a:srgbClr val="38BDF8"/>
                 </a:solidFill>
@@ -3251,7 +3252,7 @@
           </a:p>
           <a:p>
             <a:pPr>
-              <a:defRPr sz="1300" b="1">
+              <a:defRPr sz="1500" b="1">
                 <a:solidFill>
                   <a:srgbClr val="4ADE80"/>
                 </a:solidFill>
@@ -3263,7 +3264,7 @@
           </a:p>
           <a:p>
             <a:pPr>
-              <a:defRPr sz="1400" b="1">
+              <a:defRPr sz="1550">
                 <a:solidFill>
                   <a:srgbClr val="F8FAFC"/>
                 </a:solidFill>
@@ -3275,7 +3276,7 @@
           </a:p>
           <a:p>
             <a:pPr>
-              <a:defRPr sz="1300" b="1">
+              <a:defRPr sz="1500" b="1">
                 <a:solidFill>
                   <a:srgbClr val="C084FC"/>
                 </a:solidFill>
@@ -3287,7 +3288,7 @@
           </a:p>
           <a:p>
             <a:pPr>
-              <a:defRPr sz="1400" b="1">
+              <a:defRPr sz="1550">
                 <a:solidFill>
                   <a:srgbClr val="F8FAFC"/>
                 </a:solidFill>
@@ -3383,7 +3384,7 @@
           <a:lstStyle/>
           <a:p>
             <a:pPr>
-              <a:defRPr sz="1100" b="1">
+              <a:defRPr sz="1300" b="1">
                 <a:solidFill>
                   <a:srgbClr val="38BDF8"/>
                 </a:solidFill>
@@ -3395,7 +3396,7 @@
           </a:p>
           <a:p>
             <a:pPr>
-              <a:defRPr sz="2200" b="1">
+              <a:defRPr sz="2400" b="1">
                 <a:solidFill>
                   <a:srgbClr val="F8FAFC"/>
                 </a:solidFill>
@@ -3416,7 +3417,7 @@
         <p:spPr>
           <a:xfrm>
             <a:off x="731520" y="1280160"/>
-            <a:ext cx="3413455" cy="2240280"/>
+            <a:ext cx="3413455" cy="2286000"/>
           </a:xfrm>
           <a:prstGeom prst="roundRect">
             <a:avLst/>
@@ -3445,11 +3446,11 @@
           </a:fontRef>
         </p:style>
         <p:txBody>
-          <a:bodyPr rtlCol="0" anchor="ctr" wrap="square" lIns="228600" rIns="228600" tIns="182880" bIns="137160"/>
+          <a:bodyPr rtlCol="0" anchor="ctr" wrap="square" lIns="274320" rIns="274320" tIns="228600" bIns="182880"/>
           <a:lstStyle/>
           <a:p>
             <a:pPr algn="ctr">
-              <a:defRPr sz="1400" b="1">
+              <a:defRPr sz="1600" b="1">
                 <a:solidFill>
                   <a:srgbClr val="38BDF8"/>
                 </a:solidFill>
@@ -3461,7 +3462,7 @@
           </a:p>
           <a:p>
             <a:pPr>
-              <a:defRPr sz="1150">
+              <a:defRPr sz="1400">
                 <a:solidFill>
                   <a:srgbClr val="F8FAFC"/>
                 </a:solidFill>
@@ -3482,7 +3483,7 @@
         <p:spPr>
           <a:xfrm>
             <a:off x="4389120" y="1280160"/>
-            <a:ext cx="3413455" cy="2240280"/>
+            <a:ext cx="3413455" cy="2286000"/>
           </a:xfrm>
           <a:prstGeom prst="roundRect">
             <a:avLst/>
@@ -3511,11 +3512,11 @@
           </a:fontRef>
         </p:style>
         <p:txBody>
-          <a:bodyPr rtlCol="0" anchor="ctr" wrap="square" lIns="228600" rIns="228600" tIns="182880" bIns="137160"/>
+          <a:bodyPr rtlCol="0" anchor="ctr" wrap="square" lIns="274320" rIns="274320" tIns="228600" bIns="182880"/>
           <a:lstStyle/>
           <a:p>
             <a:pPr algn="ctr">
-              <a:defRPr sz="1400" b="1">
+              <a:defRPr sz="1600" b="1">
                 <a:solidFill>
                   <a:srgbClr val="4ADE80"/>
                 </a:solidFill>
@@ -3527,7 +3528,7 @@
           </a:p>
           <a:p>
             <a:pPr>
-              <a:defRPr sz="1150">
+              <a:defRPr sz="1400">
                 <a:solidFill>
                   <a:srgbClr val="F8FAFC"/>
                 </a:solidFill>
@@ -3548,7 +3549,7 @@
         <p:spPr>
           <a:xfrm>
             <a:off x="8046720" y="1280160"/>
-            <a:ext cx="3413455" cy="2240280"/>
+            <a:ext cx="3413455" cy="2286000"/>
           </a:xfrm>
           <a:prstGeom prst="roundRect">
             <a:avLst/>
@@ -3577,11 +3578,11 @@
           </a:fontRef>
         </p:style>
         <p:txBody>
-          <a:bodyPr rtlCol="0" anchor="ctr" wrap="square" lIns="228600" rIns="228600" tIns="182880" bIns="137160"/>
+          <a:bodyPr rtlCol="0" anchor="ctr" wrap="square" lIns="274320" rIns="274320" tIns="228600" bIns="182880"/>
           <a:lstStyle/>
           <a:p>
             <a:pPr algn="ctr">
-              <a:defRPr sz="1400" b="1">
+              <a:defRPr sz="1600" b="1">
                 <a:solidFill>
                   <a:srgbClr val="F87171"/>
                 </a:solidFill>
@@ -3593,7 +3594,7 @@
           </a:p>
           <a:p>
             <a:pPr>
-              <a:defRPr sz="1150">
+              <a:defRPr sz="1400">
                 <a:solidFill>
                   <a:srgbClr val="F8FAFC"/>
                 </a:solidFill>
@@ -3613,8 +3614,8 @@
         </p:nvSpPr>
         <p:spPr>
           <a:xfrm>
-            <a:off x="731520" y="3749039"/>
-            <a:ext cx="3413455" cy="2240280"/>
+            <a:off x="731520" y="3794760"/>
+            <a:ext cx="3413455" cy="2286000"/>
           </a:xfrm>
           <a:prstGeom prst="roundRect">
             <a:avLst/>
@@ -3643,11 +3644,11 @@
           </a:fontRef>
         </p:style>
         <p:txBody>
-          <a:bodyPr rtlCol="0" anchor="ctr" wrap="square" lIns="228600" rIns="228600" tIns="182880" bIns="137160"/>
+          <a:bodyPr rtlCol="0" anchor="ctr" wrap="square" lIns="274320" rIns="274320" tIns="228600" bIns="182880"/>
           <a:lstStyle/>
           <a:p>
             <a:pPr algn="ctr">
-              <a:defRPr sz="1400" b="1">
+              <a:defRPr sz="1600" b="1">
                 <a:solidFill>
                   <a:srgbClr val="FBBF24"/>
                 </a:solidFill>
@@ -3659,7 +3660,7 @@
           </a:p>
           <a:p>
             <a:pPr>
-              <a:defRPr sz="1150">
+              <a:defRPr sz="1400">
                 <a:solidFill>
                   <a:srgbClr val="F8FAFC"/>
                 </a:solidFill>
@@ -3679,8 +3680,8 @@
         </p:nvSpPr>
         <p:spPr>
           <a:xfrm>
-            <a:off x="4389120" y="3749039"/>
-            <a:ext cx="3413455" cy="2240280"/>
+            <a:off x="4389120" y="3794760"/>
+            <a:ext cx="3413455" cy="2286000"/>
           </a:xfrm>
           <a:prstGeom prst="roundRect">
             <a:avLst/>
@@ -3709,11 +3710,11 @@
           </a:fontRef>
         </p:style>
         <p:txBody>
-          <a:bodyPr rtlCol="0" anchor="ctr" wrap="square" lIns="228600" rIns="228600" tIns="182880" bIns="137160"/>
+          <a:bodyPr rtlCol="0" anchor="ctr" wrap="square" lIns="274320" rIns="274320" tIns="228600" bIns="182880"/>
           <a:lstStyle/>
           <a:p>
             <a:pPr algn="ctr">
-              <a:defRPr sz="1400" b="1">
+              <a:defRPr sz="1600" b="1">
                 <a:solidFill>
                   <a:srgbClr val="C084FC"/>
                 </a:solidFill>
@@ -3725,7 +3726,7 @@
           </a:p>
           <a:p>
             <a:pPr>
-              <a:defRPr sz="1150">
+              <a:defRPr sz="1400">
                 <a:solidFill>
                   <a:srgbClr val="F8FAFC"/>
                 </a:solidFill>
@@ -3745,8 +3746,8 @@
         </p:nvSpPr>
         <p:spPr>
           <a:xfrm>
-            <a:off x="8046720" y="3749039"/>
-            <a:ext cx="3413455" cy="2240280"/>
+            <a:off x="8046720" y="3794760"/>
+            <a:ext cx="3413455" cy="2286000"/>
           </a:xfrm>
           <a:prstGeom prst="roundRect">
             <a:avLst/>
@@ -3775,11 +3776,11 @@
           </a:fontRef>
         </p:style>
         <p:txBody>
-          <a:bodyPr rtlCol="0" anchor="ctr" wrap="square" lIns="228600" rIns="228600" tIns="182880" bIns="137160"/>
+          <a:bodyPr rtlCol="0" anchor="ctr" wrap="square" lIns="274320" rIns="274320" tIns="228600" bIns="182880"/>
           <a:lstStyle/>
           <a:p>
             <a:pPr algn="ctr">
-              <a:defRPr sz="1400" b="1">
+              <a:defRPr sz="1600" b="1">
                 <a:solidFill>
                   <a:srgbClr val="38BDF8"/>
                 </a:solidFill>
@@ -3791,7 +3792,7 @@
           </a:p>
           <a:p>
             <a:pPr>
-              <a:defRPr sz="1150">
+              <a:defRPr sz="1400">
                 <a:solidFill>
                   <a:srgbClr val="F8FAFC"/>
                 </a:solidFill>
@@ -3887,26 +3888,830 @@
           <a:lstStyle/>
           <a:p>
             <a:pPr>
-              <a:defRPr sz="1100" b="1">
+              <a:defRPr sz="1300" b="1">
                 <a:solidFill>
                   <a:srgbClr val="38BDF8"/>
                 </a:solidFill>
               </a:defRPr>
             </a:pPr>
             <a:r>
-              <a:t>● ARCHITECTURE ABSTRACTION</a:t>
-            </a:r>
-          </a:p>
-          <a:p>
-            <a:pPr>
-              <a:defRPr sz="2200" b="1">
+              <a:t>● CORE ARCHITECTURE</a:t>
+            </a:r>
+          </a:p>
+          <a:p>
+            <a:pPr>
+              <a:defRPr sz="2400" b="1">
                 <a:solidFill>
                   <a:srgbClr val="F8FAFC"/>
                 </a:solidFill>
               </a:defRPr>
             </a:pPr>
             <a:r>
-              <a:t>6P 閉環收斂為兩大根本邊界 ➔ 4 大 DROS 核心微內核部件</a:t>
+              <a:t>DROS 架構的 3 個核心組件：身分注入、帶內閘門與密碼學存證</a:t>
+            </a:r>
+          </a:p>
+        </p:txBody>
+      </p:sp>
+      <p:sp>
+        <p:nvSpPr>
+          <p:cNvPr id="4" name="Rounded Rectangle 3"/>
+          <p:cNvSpPr/>
+          <p:nvPr/>
+        </p:nvSpPr>
+        <p:spPr>
+          <a:xfrm>
+            <a:off x="731520" y="1280160"/>
+            <a:ext cx="3413455" cy="5029200"/>
+          </a:xfrm>
+          <a:prstGeom prst="roundRect">
+            <a:avLst/>
+          </a:prstGeom>
+          <a:solidFill>
+            <a:srgbClr val="0F172A"/>
+          </a:solidFill>
+          <a:ln w="19050">
+            <a:solidFill>
+              <a:srgbClr val="38BDF8"/>
+            </a:solidFill>
+          </a:ln>
+        </p:spPr>
+        <p:style>
+          <a:lnRef idx="1">
+            <a:schemeClr val="accent1"/>
+          </a:lnRef>
+          <a:fillRef idx="3">
+            <a:schemeClr val="accent1"/>
+          </a:fillRef>
+          <a:effectRef idx="2">
+            <a:schemeClr val="accent1"/>
+          </a:effectRef>
+          <a:fontRef idx="minor">
+            <a:schemeClr val="lt1"/>
+          </a:fontRef>
+        </p:style>
+        <p:txBody>
+          <a:bodyPr rtlCol="0" anchor="ctr" wrap="square" lIns="274320" rIns="274320" tIns="228600" bIns="182880"/>
+          <a:lstStyle/>
+          <a:p>
+            <a:pPr algn="ctr">
+              <a:defRPr sz="1650" b="1">
+                <a:solidFill>
+                  <a:srgbClr val="38BDF8"/>
+                </a:solidFill>
+              </a:defRPr>
+            </a:pPr>
+            <a:r>
+              <a:t>【組件 A】DIT Token</a:t>
+            </a:r>
+          </a:p>
+          <a:p>
+            <a:pPr>
+              <a:defRPr sz="1300">
+                <a:solidFill>
+                  <a:srgbClr val="CBD5E1"/>
+                </a:solidFill>
+              </a:defRPr>
+            </a:pPr>
+            <a:r>
+              <a:t>身分憑證注入層 (Principal Injection)</a:t>
+            </a:r>
+          </a:p>
+          <a:p>
+            <a:pPr>
+              <a:defRPr sz="1000">
+                <a:solidFill>
+                  <a:srgbClr val="46556E"/>
+                </a:solidFill>
+              </a:defRPr>
+            </a:pPr>
+            <a:r>
+              <a:t>─────────────────────────</a:t>
+            </a:r>
+          </a:p>
+          <a:p>
+            <a:pPr>
+              <a:defRPr sz="1400">
+                <a:solidFill>
+                  <a:srgbClr val="F8FAFC"/>
+                </a:solidFill>
+              </a:defRPr>
+            </a:pPr>
+            <a:r>
+              <a:t>▶ 每個 Agent 啟動時自動注入加密身分憑證。</a:t>
+            </a:r>
+          </a:p>
+          <a:p>
+            <a:pPr>
+              <a:defRPr sz="1400">
+                <a:solidFill>
+                  <a:srgbClr val="F8FAFC"/>
+                </a:solidFill>
+              </a:defRPr>
+            </a:pPr>
+            <a:r>
+              <a:t>▶ 強綁定：「誰 (ID) ＋ 授權做什麼 (Scope) ＋ 到期時間」。</a:t>
+            </a:r>
+          </a:p>
+          <a:p>
+            <a:pPr>
+              <a:defRPr sz="1400">
+                <a:solidFill>
+                  <a:srgbClr val="F8FAFC"/>
+                </a:solidFill>
+              </a:defRPr>
+            </a:pPr>
+            <a:r>
+              <a:t>▶ 無縫整合法人 vLEI 與自然人 MyData 雙軌。</a:t>
+            </a:r>
+          </a:p>
+        </p:txBody>
+      </p:sp>
+      <p:sp>
+        <p:nvSpPr>
+          <p:cNvPr id="5" name="Rounded Rectangle 4"/>
+          <p:cNvSpPr/>
+          <p:nvPr/>
+        </p:nvSpPr>
+        <p:spPr>
+          <a:xfrm>
+            <a:off x="4389120" y="1280160"/>
+            <a:ext cx="3413455" cy="5029200"/>
+          </a:xfrm>
+          <a:prstGeom prst="roundRect">
+            <a:avLst/>
+          </a:prstGeom>
+          <a:solidFill>
+            <a:srgbClr val="0F172A"/>
+          </a:solidFill>
+          <a:ln w="19050">
+            <a:solidFill>
+              <a:srgbClr val="F87171"/>
+            </a:solidFill>
+          </a:ln>
+        </p:spPr>
+        <p:style>
+          <a:lnRef idx="1">
+            <a:schemeClr val="accent1"/>
+          </a:lnRef>
+          <a:fillRef idx="3">
+            <a:schemeClr val="accent1"/>
+          </a:fillRef>
+          <a:effectRef idx="2">
+            <a:schemeClr val="accent1"/>
+          </a:effectRef>
+          <a:fontRef idx="minor">
+            <a:schemeClr val="lt1"/>
+          </a:fontRef>
+        </p:style>
+        <p:txBody>
+          <a:bodyPr rtlCol="0" anchor="ctr" wrap="square" lIns="274320" rIns="274320" tIns="228600" bIns="182880"/>
+          <a:lstStyle/>
+          <a:p>
+            <a:pPr algn="ctr">
+              <a:defRPr sz="1650" b="1">
+                <a:solidFill>
+                  <a:srgbClr val="F87171"/>
+                </a:solidFill>
+              </a:defRPr>
+            </a:pPr>
+            <a:r>
+              <a:t>【組件 B】VEP Policy Gate</a:t>
+            </a:r>
+          </a:p>
+          <a:p>
+            <a:pPr>
+              <a:defRPr sz="1300">
+                <a:solidFill>
+                  <a:srgbClr val="CBD5E1"/>
+                </a:solidFill>
+              </a:defRPr>
+            </a:pPr>
+            <a:r>
+              <a:t>帶內策略閘門層 (In-Band Gate)</a:t>
+            </a:r>
+          </a:p>
+          <a:p>
+            <a:pPr>
+              <a:defRPr sz="1000">
+                <a:solidFill>
+                  <a:srgbClr val="46556E"/>
+                </a:solidFill>
+              </a:defRPr>
+            </a:pPr>
+            <a:r>
+              <a:t>─────────────────────────</a:t>
+            </a:r>
+          </a:p>
+          <a:p>
+            <a:pPr>
+              <a:defRPr sz="1400">
+                <a:solidFill>
+                  <a:srgbClr val="F8FAFC"/>
+                </a:solidFill>
+              </a:defRPr>
+            </a:pPr>
+            <a:r>
+              <a:t>▶ Agent 呼叫 Tool 時物理上必須先過此 C-ABI 閘門。</a:t>
+            </a:r>
+          </a:p>
+          <a:p>
+            <a:pPr>
+              <a:defRPr sz="1400">
+                <a:solidFill>
+                  <a:srgbClr val="F8FAFC"/>
+                </a:solidFill>
+              </a:defRPr>
+            </a:pPr>
+            <a:r>
+              <a:t>▶ 未授權動作在 26.1 μs 內硬性熔斷 (HTTP 403)。</a:t>
+            </a:r>
+          </a:p>
+          <a:p>
+            <a:pPr>
+              <a:defRPr sz="1400">
+                <a:solidFill>
+                  <a:srgbClr val="F8FAFC"/>
+                </a:solidFill>
+              </a:defRPr>
+            </a:pPr>
+            <a:r>
+              <a:t>▶ 高風險動作自動掛起交易，觸發人類雙重簽署 (HITL)。</a:t>
+            </a:r>
+          </a:p>
+        </p:txBody>
+      </p:sp>
+      <p:sp>
+        <p:nvSpPr>
+          <p:cNvPr id="6" name="Rounded Rectangle 5"/>
+          <p:cNvSpPr/>
+          <p:nvPr/>
+        </p:nvSpPr>
+        <p:spPr>
+          <a:xfrm>
+            <a:off x="8046720" y="1280160"/>
+            <a:ext cx="3413455" cy="5029200"/>
+          </a:xfrm>
+          <a:prstGeom prst="roundRect">
+            <a:avLst/>
+          </a:prstGeom>
+          <a:solidFill>
+            <a:srgbClr val="0F172A"/>
+          </a:solidFill>
+          <a:ln w="19050">
+            <a:solidFill>
+              <a:srgbClr val="4ADE80"/>
+            </a:solidFill>
+          </a:ln>
+        </p:spPr>
+        <p:style>
+          <a:lnRef idx="1">
+            <a:schemeClr val="accent1"/>
+          </a:lnRef>
+          <a:fillRef idx="3">
+            <a:schemeClr val="accent1"/>
+          </a:fillRef>
+          <a:effectRef idx="2">
+            <a:schemeClr val="accent1"/>
+          </a:effectRef>
+          <a:fontRef idx="minor">
+            <a:schemeClr val="lt1"/>
+          </a:fontRef>
+        </p:style>
+        <p:txBody>
+          <a:bodyPr rtlCol="0" anchor="ctr" wrap="square" lIns="274320" rIns="274320" tIns="228600" bIns="182880"/>
+          <a:lstStyle/>
+          <a:p>
+            <a:pPr algn="ctr">
+              <a:defRPr sz="1650" b="1">
+                <a:solidFill>
+                  <a:srgbClr val="4ADE80"/>
+                </a:solidFill>
+              </a:defRPr>
+            </a:pPr>
+            <a:r>
+              <a:t>【組件 C】Merkle Audit Chain</a:t>
+            </a:r>
+          </a:p>
+          <a:p>
+            <a:pPr>
+              <a:defRPr sz="1300">
+                <a:solidFill>
+                  <a:srgbClr val="CBD5E1"/>
+                </a:solidFill>
+              </a:defRPr>
+            </a:pPr>
+            <a:r>
+              <a:t>不可竄改稽核層 (Cryptographic Trail)</a:t>
+            </a:r>
+          </a:p>
+          <a:p>
+            <a:pPr>
+              <a:defRPr sz="1000">
+                <a:solidFill>
+                  <a:srgbClr val="46556E"/>
+                </a:solidFill>
+              </a:defRPr>
+            </a:pPr>
+            <a:r>
+              <a:t>─────────────────────────</a:t>
+            </a:r>
+          </a:p>
+          <a:p>
+            <a:pPr>
+              <a:defRPr sz="1400">
+                <a:solidFill>
+                  <a:srgbClr val="F8FAFC"/>
+                </a:solidFill>
+              </a:defRPr>
+            </a:pPr>
+            <a:r>
+              <a:t>▶ 每次放行/熔斷寫入帶 SHA-256 的 Merkle 鏈。</a:t>
+            </a:r>
+          </a:p>
+          <a:p>
+            <a:pPr>
+              <a:defRPr sz="1400">
+                <a:solidFill>
+                  <a:srgbClr val="F8FAFC"/>
+                </a:solidFill>
+              </a:defRPr>
+            </a:pPr>
+            <a:r>
+              <a:t>▶ 前後雜湊鏈結，竄改失效，產出法庭採信收據。</a:t>
+            </a:r>
+          </a:p>
+          <a:p>
+            <a:pPr>
+              <a:defRPr sz="1400">
+                <a:solidFill>
+                  <a:srgbClr val="F8FAFC"/>
+                </a:solidFill>
+              </a:defRPr>
+            </a:pPr>
+            <a:r>
+              <a:t>▶ 支援 O(1) RCU 原子指針秒級動態撤銷與凍結。</a:t>
+            </a:r>
+          </a:p>
+        </p:txBody>
+      </p:sp>
+    </p:spTree>
+  </p:cSld>
+  <p:clrMapOvr>
+    <a:masterClrMapping/>
+  </p:clrMapOvr>
+</p:sld>
+</file>
+
+<file path=ppt/slides/slide4.xml><?xml version="1.0" encoding="utf-8"?>
+<p:sld xmlns:a="http://schemas.openxmlformats.org/drawingml/2006/main" xmlns:p="http://schemas.openxmlformats.org/presentationml/2006/main" xmlns:r="http://schemas.openxmlformats.org/officeDocument/2006/relationships">
+  <p:cSld>
+    <p:spTree>
+      <p:nvGrpSpPr>
+        <p:cNvPr id="1" name=""/>
+        <p:cNvGrpSpPr/>
+        <p:nvPr/>
+      </p:nvGrpSpPr>
+      <p:grpSpPr/>
+      <p:sp>
+        <p:nvSpPr>
+          <p:cNvPr id="2" name="Rectangle 1"/>
+          <p:cNvSpPr/>
+          <p:nvPr/>
+        </p:nvSpPr>
+        <p:spPr>
+          <a:xfrm>
+            <a:off x="0" y="0"/>
+            <a:ext cx="12191695" cy="6858000"/>
+          </a:xfrm>
+          <a:prstGeom prst="rect">
+            <a:avLst/>
+          </a:prstGeom>
+          <a:solidFill>
+            <a:srgbClr val="070A12"/>
+          </a:solidFill>
+          <a:ln>
+            <a:noFill/>
+          </a:ln>
+        </p:spPr>
+        <p:style>
+          <a:lnRef idx="1">
+            <a:schemeClr val="accent1"/>
+          </a:lnRef>
+          <a:fillRef idx="3">
+            <a:schemeClr val="accent1"/>
+          </a:fillRef>
+          <a:effectRef idx="2">
+            <a:schemeClr val="accent1"/>
+          </a:effectRef>
+          <a:fontRef idx="minor">
+            <a:schemeClr val="lt1"/>
+          </a:fontRef>
+        </p:style>
+        <p:txBody>
+          <a:bodyPr rtlCol="0" anchor="ctr"/>
+          <a:lstStyle/>
+          <a:p>
+            <a:pPr algn="ctr"/>
+          </a:p>
+        </p:txBody>
+      </p:sp>
+      <p:sp>
+        <p:nvSpPr>
+          <p:cNvPr id="3" name="TextBox 2"/>
+          <p:cNvSpPr txBox="1"/>
+          <p:nvPr/>
+        </p:nvSpPr>
+        <p:spPr>
+          <a:xfrm>
+            <a:off x="731520" y="365760"/>
+            <a:ext cx="10728655" cy="822960"/>
+          </a:xfrm>
+          <a:prstGeom prst="rect">
+            <a:avLst/>
+          </a:prstGeom>
+          <a:noFill/>
+        </p:spPr>
+        <p:txBody>
+          <a:bodyPr wrap="square" lIns="0" rIns="0" tIns="0" bIns="0">
+            <a:spAutoFit/>
+          </a:bodyPr>
+          <a:lstStyle/>
+          <a:p>
+            <a:pPr>
+              <a:defRPr sz="1300" b="1">
+                <a:solidFill>
+                  <a:srgbClr val="38BDF8"/>
+                </a:solidFill>
+              </a:defRPr>
+            </a:pPr>
+            <a:r>
+              <a:t>● THE GOLDEN TRIANGLE</a:t>
+            </a:r>
+          </a:p>
+          <a:p>
+            <a:pPr>
+              <a:defRPr sz="2400" b="1">
+                <a:solidFill>
+                  <a:srgbClr val="F8FAFC"/>
+                </a:solidFill>
+              </a:defRPr>
+            </a:pPr>
+            <a:r>
+              <a:t>跨產業統一治理核心：DROS「黃金三角形模型」與兩大根本邊界</a:t>
+            </a:r>
+          </a:p>
+        </p:txBody>
+      </p:sp>
+      <p:sp>
+        <p:nvSpPr>
+          <p:cNvPr id="4" name="Rounded Rectangle 3"/>
+          <p:cNvSpPr/>
+          <p:nvPr/>
+        </p:nvSpPr>
+        <p:spPr>
+          <a:xfrm>
+            <a:off x="731520" y="1234440"/>
+            <a:ext cx="10728655" cy="1371600"/>
+          </a:xfrm>
+          <a:prstGeom prst="roundRect">
+            <a:avLst/>
+          </a:prstGeom>
+          <a:solidFill>
+            <a:srgbClr val="0F172A"/>
+          </a:solidFill>
+          <a:ln w="19050">
+            <a:solidFill>
+              <a:srgbClr val="FBBF24"/>
+            </a:solidFill>
+          </a:ln>
+        </p:spPr>
+        <p:style>
+          <a:lnRef idx="1">
+            <a:schemeClr val="accent1"/>
+          </a:lnRef>
+          <a:fillRef idx="3">
+            <a:schemeClr val="accent1"/>
+          </a:fillRef>
+          <a:effectRef idx="2">
+            <a:schemeClr val="accent1"/>
+          </a:effectRef>
+          <a:fontRef idx="minor">
+            <a:schemeClr val="lt1"/>
+          </a:fontRef>
+        </p:style>
+        <p:txBody>
+          <a:bodyPr rtlCol="0" anchor="ctr" wrap="square" lIns="274320" rIns="274320" tIns="228600" bIns="182880"/>
+          <a:lstStyle/>
+          <a:p>
+            <a:pPr algn="ctr">
+              <a:defRPr sz="1500" b="1">
+                <a:solidFill>
+                  <a:srgbClr val="FBBF24"/>
+                </a:solidFill>
+              </a:defRPr>
+            </a:pPr>
+            <a:r>
+              <a:t>🔺 黃金三角形定理：AI 是 Detection/Knowledge 引擎，DROS 則是 Execution Governance 底座</a:t>
+            </a:r>
+          </a:p>
+          <a:p>
+            <a:pPr>
+              <a:defRPr sz="1400">
+                <a:solidFill>
+                  <a:srgbClr val="F8FAFC"/>
+                </a:solidFill>
+              </a:defRPr>
+            </a:pPr>
+            <a:r>
+              <a:t>「不同產業、不同資料、不同任務，可以完全不同；但只要它們最後都能透過同一個治理三角形安全地進入與離開 execution boundary，DROS 才真正開始像一個 OS，而不是另一套 Toolkit。」</a:t>
+            </a:r>
+          </a:p>
+        </p:txBody>
+      </p:sp>
+      <p:sp>
+        <p:nvSpPr>
+          <p:cNvPr id="5" name="Rounded Rectangle 4"/>
+          <p:cNvSpPr/>
+          <p:nvPr/>
+        </p:nvSpPr>
+        <p:spPr>
+          <a:xfrm>
+            <a:off x="731520" y="2743200"/>
+            <a:ext cx="5212080" cy="3749039"/>
+          </a:xfrm>
+          <a:prstGeom prst="roundRect">
+            <a:avLst/>
+          </a:prstGeom>
+          <a:solidFill>
+            <a:srgbClr val="0F172A"/>
+          </a:solidFill>
+          <a:ln w="19050">
+            <a:solidFill>
+              <a:srgbClr val="38BDF8"/>
+            </a:solidFill>
+          </a:ln>
+        </p:spPr>
+        <p:style>
+          <a:lnRef idx="1">
+            <a:schemeClr val="accent1"/>
+          </a:lnRef>
+          <a:fillRef idx="3">
+            <a:schemeClr val="accent1"/>
+          </a:fillRef>
+          <a:effectRef idx="2">
+            <a:schemeClr val="accent1"/>
+          </a:effectRef>
+          <a:fontRef idx="minor">
+            <a:schemeClr val="lt1"/>
+          </a:fontRef>
+        </p:style>
+        <p:txBody>
+          <a:bodyPr rtlCol="0" anchor="ctr" wrap="square" lIns="274320" rIns="274320" tIns="228600" bIns="182880"/>
+          <a:lstStyle/>
+          <a:p>
+            <a:pPr algn="ctr">
+              <a:defRPr sz="1500" b="1">
+                <a:solidFill>
+                  <a:srgbClr val="38BDF8"/>
+                </a:solidFill>
+              </a:defRPr>
+            </a:pPr>
+            <a:r>
+              <a:t>📥 邊界 ①：Ingress（安全特徵輸入 / 資料最小化）</a:t>
+            </a:r>
+          </a:p>
+          <a:p>
+            <a:pPr>
+              <a:defRPr sz="1400">
+                <a:solidFill>
+                  <a:srgbClr val="F8FAFC"/>
+                </a:solidFill>
+              </a:defRPr>
+            </a:pPr>
+            <a:r>
+              <a:t>• 允許進入 (Allowed)：去識別化特徵向量、碳排係數、ICD-10診斷碼、所得級距試算、ZKP 合規證明。</a:t>
+            </a:r>
+          </a:p>
+          <a:p>
+            <a:pPr>
+              <a:defRPr sz="1400">
+                <a:solidFill>
+                  <a:srgbClr val="F87171"/>
+                </a:solidFill>
+              </a:defRPr>
+            </a:pPr>
+            <a:r>
+              <a:t>• 嚴密隔離 (Forbidden)：核心 BOM 成本良率、身分證帳戶明細、18項 PHI 病歷、完整稅籍。</a:t>
+            </a:r>
+          </a:p>
+          <a:p>
+            <a:pPr>
+              <a:defRPr sz="1400" b="1">
+                <a:solidFill>
+                  <a:srgbClr val="FBBF24"/>
+                </a:solidFill>
+              </a:defRPr>
+            </a:pPr>
+            <a:r>
+              <a:t>👉 對應部件：Safe Ingress Redactor ＋ DIT Injector</a:t>
+            </a:r>
+          </a:p>
+        </p:txBody>
+      </p:sp>
+      <p:sp>
+        <p:nvSpPr>
+          <p:cNvPr id="6" name="Rounded Rectangle 5"/>
+          <p:cNvSpPr/>
+          <p:nvPr/>
+        </p:nvSpPr>
+        <p:spPr>
+          <a:xfrm>
+            <a:off x="6248095" y="2743200"/>
+            <a:ext cx="5212080" cy="3749039"/>
+          </a:xfrm>
+          <a:prstGeom prst="roundRect">
+            <a:avLst/>
+          </a:prstGeom>
+          <a:solidFill>
+            <a:srgbClr val="0F172A"/>
+          </a:solidFill>
+          <a:ln w="19050">
+            <a:solidFill>
+              <a:srgbClr val="C084FC"/>
+            </a:solidFill>
+          </a:ln>
+        </p:spPr>
+        <p:style>
+          <a:lnRef idx="1">
+            <a:schemeClr val="accent1"/>
+          </a:lnRef>
+          <a:fillRef idx="3">
+            <a:schemeClr val="accent1"/>
+          </a:fillRef>
+          <a:effectRef idx="2">
+            <a:schemeClr val="accent1"/>
+          </a:effectRef>
+          <a:fontRef idx="minor">
+            <a:schemeClr val="lt1"/>
+          </a:fontRef>
+        </p:style>
+        <p:txBody>
+          <a:bodyPr rtlCol="0" anchor="ctr" wrap="square" lIns="274320" rIns="274320" tIns="228600" bIns="182880"/>
+          <a:lstStyle/>
+          <a:p>
+            <a:pPr algn="ctr">
+              <a:defRPr sz="1500" b="1">
+                <a:solidFill>
+                  <a:srgbClr val="C084FC"/>
+                </a:solidFill>
+              </a:defRPr>
+            </a:pPr>
+            <a:r>
+              <a:t>📤 邊界 ②：Egress（確定性動作輸出 / C-ABI 硬閘門）</a:t>
+            </a:r>
+          </a:p>
+          <a:p>
+            <a:pPr>
+              <a:defRPr sz="1400">
+                <a:solidFill>
+                  <a:srgbClr val="F8FAFC"/>
+                </a:solidFill>
+              </a:defRPr>
+            </a:pPr>
+            <a:r>
+              <a:t>• 帶內二進位門閥：所有 Tool Call 物理必過 C-ABI，未授權動作在 26.1 μs 內硬熔斷 (HTTP 403)。</a:t>
+            </a:r>
+          </a:p>
+          <a:p>
+            <a:pPr>
+              <a:defRPr sz="1400">
+                <a:solidFill>
+                  <a:srgbClr val="4ADE80"/>
+                </a:solidFill>
+              </a:defRPr>
+            </a:pPr>
+            <a:r>
+              <a:t>• 密碼學存證與撤銷：每次動作寫入 SHA-256 Merkle 鏈，支援 O(1) RCU 原子指針秒級撤銷。</a:t>
+            </a:r>
+          </a:p>
+          <a:p>
+            <a:pPr>
+              <a:defRPr sz="1400" b="1">
+                <a:solidFill>
+                  <a:srgbClr val="FBBF24"/>
+                </a:solidFill>
+              </a:defRPr>
+            </a:pPr>
+            <a:r>
+              <a:t>👉 對應部件：C-ABI In-Band Gate ＋ Merkle &amp; RCU</a:t>
+            </a:r>
+          </a:p>
+        </p:txBody>
+      </p:sp>
+    </p:spTree>
+  </p:cSld>
+  <p:clrMapOvr>
+    <a:masterClrMapping/>
+  </p:clrMapOvr>
+</p:sld>
+</file>
+
+<file path=ppt/slides/slide5.xml><?xml version="1.0" encoding="utf-8"?>
+<p:sld xmlns:a="http://schemas.openxmlformats.org/drawingml/2006/main" xmlns:p="http://schemas.openxmlformats.org/presentationml/2006/main" xmlns:r="http://schemas.openxmlformats.org/officeDocument/2006/relationships">
+  <p:cSld>
+    <p:spTree>
+      <p:nvGrpSpPr>
+        <p:cNvPr id="1" name=""/>
+        <p:cNvGrpSpPr/>
+        <p:nvPr/>
+      </p:nvGrpSpPr>
+      <p:grpSpPr/>
+      <p:sp>
+        <p:nvSpPr>
+          <p:cNvPr id="2" name="Rectangle 1"/>
+          <p:cNvSpPr/>
+          <p:nvPr/>
+        </p:nvSpPr>
+        <p:spPr>
+          <a:xfrm>
+            <a:off x="0" y="0"/>
+            <a:ext cx="12191695" cy="6858000"/>
+          </a:xfrm>
+          <a:prstGeom prst="rect">
+            <a:avLst/>
+          </a:prstGeom>
+          <a:solidFill>
+            <a:srgbClr val="070A12"/>
+          </a:solidFill>
+          <a:ln>
+            <a:noFill/>
+          </a:ln>
+        </p:spPr>
+        <p:style>
+          <a:lnRef idx="1">
+            <a:schemeClr val="accent1"/>
+          </a:lnRef>
+          <a:fillRef idx="3">
+            <a:schemeClr val="accent1"/>
+          </a:fillRef>
+          <a:effectRef idx="2">
+            <a:schemeClr val="accent1"/>
+          </a:effectRef>
+          <a:fontRef idx="minor">
+            <a:schemeClr val="lt1"/>
+          </a:fontRef>
+        </p:style>
+        <p:txBody>
+          <a:bodyPr rtlCol="0" anchor="ctr"/>
+          <a:lstStyle/>
+          <a:p>
+            <a:pPr algn="ctr"/>
+          </a:p>
+        </p:txBody>
+      </p:sp>
+      <p:sp>
+        <p:nvSpPr>
+          <p:cNvPr id="3" name="TextBox 2"/>
+          <p:cNvSpPr txBox="1"/>
+          <p:nvPr/>
+        </p:nvSpPr>
+        <p:spPr>
+          <a:xfrm>
+            <a:off x="731520" y="365760"/>
+            <a:ext cx="10728655" cy="822960"/>
+          </a:xfrm>
+          <a:prstGeom prst="rect">
+            <a:avLst/>
+          </a:prstGeom>
+          <a:noFill/>
+        </p:spPr>
+        <p:txBody>
+          <a:bodyPr wrap="square" lIns="0" rIns="0" tIns="0" bIns="0">
+            <a:spAutoFit/>
+          </a:bodyPr>
+          <a:lstStyle/>
+          <a:p>
+            <a:pPr>
+              <a:defRPr sz="1300" b="1">
+                <a:solidFill>
+                  <a:srgbClr val="38BDF8"/>
+                </a:solidFill>
+              </a:defRPr>
+            </a:pPr>
+            <a:r>
+              <a:t>● ACADEMIC &amp; ENGINEERING BASE</a:t>
+            </a:r>
+          </a:p>
+          <a:p>
+            <a:pPr>
+              <a:defRPr sz="2400" b="1">
+                <a:solidFill>
+                  <a:srgbClr val="F8FAFC"/>
+                </a:solidFill>
+              </a:defRPr>
+            </a:pPr>
+            <a:r>
+              <a:t>技術底座背書：Zenodo 學術三部曲、GitHub 100% 驗證倉與「個人免費授權彩蛋」</a:t>
             </a:r>
           </a:p>
         </p:txBody>
@@ -3949,538 +4754,114 @@
           </a:fontRef>
         </p:style>
         <p:txBody>
-          <a:bodyPr rtlCol="0" anchor="ctr" wrap="square" lIns="228600" rIns="228600" tIns="182880" bIns="137160"/>
+          <a:bodyPr rtlCol="0" anchor="ctr" wrap="square" lIns="274320" rIns="274320" tIns="228600" bIns="182880"/>
           <a:lstStyle/>
           <a:p>
             <a:pPr algn="ctr">
-              <a:defRPr sz="1500" b="1">
+              <a:defRPr sz="1600" b="1">
                 <a:solidFill>
                   <a:srgbClr val="38BDF8"/>
                 </a:solidFill>
               </a:defRPr>
             </a:pPr>
             <a:r>
-              <a:t>📥 Ingress（輸入治理邊界）：資料最小化</a:t>
-            </a:r>
-          </a:p>
-          <a:p>
-            <a:pPr>
-              <a:defRPr sz="1200" b="1">
+              <a:t>🏛️ Zenodo 國際權威學術論文三部曲</a:t>
+            </a:r>
+          </a:p>
+          <a:p>
+            <a:pPr>
+              <a:defRPr sz="1450" b="1">
                 <a:solidFill>
                   <a:srgbClr val="F8FAFC"/>
                 </a:solidFill>
               </a:defRPr>
             </a:pPr>
             <a:r>
-              <a:t>• 🧩 部件 ①：Safe Ingress Data Redactor</a:t>
-            </a:r>
-          </a:p>
-          <a:p>
-            <a:pPr>
-              <a:defRPr sz="1100">
-                <a:solidFill>
-                  <a:srgbClr val="94A3B8"/>
-                </a:solidFill>
-              </a:defRPr>
-            </a:pPr>
-            <a:r>
-              <a:t>   動態正則/NER 遮蔽引擎 + ZKP-Lite 零知識證明門閥。</a:t>
-            </a:r>
-          </a:p>
-          <a:p>
-            <a:pPr>
-              <a:defRPr sz="1200" b="1">
+              <a:t>• 📖 學術導讀指南 (Guide Note)</a:t>
+            </a:r>
+          </a:p>
+          <a:p>
+            <a:pPr>
+              <a:defRPr sz="1300">
+                <a:solidFill>
+                  <a:srgbClr val="CBD5E1"/>
+                </a:solidFill>
+              </a:defRPr>
+            </a:pPr>
+            <a:r>
+              <a:t>   DOI: 10.5281/zenodo.22114036 (自主 AI 確定性作業基板)</a:t>
+            </a:r>
+          </a:p>
+          <a:p>
+            <a:pPr>
+              <a:defRPr sz="1450" b="1">
                 <a:solidFill>
                   <a:srgbClr val="F8FAFC"/>
                 </a:solidFill>
               </a:defRPr>
             </a:pPr>
             <a:r>
-              <a:t>• 🛡️ 涵蓋 6P：P4. Policy Gate (隱私與最小化)</a:t>
-            </a:r>
-          </a:p>
-          <a:p>
-            <a:pPr>
-              <a:defRPr sz="1100">
-                <a:solidFill>
-                  <a:srgbClr val="94A3B8"/>
-                </a:solidFill>
-              </a:defRPr>
-            </a:pPr>
-            <a:r>
-              <a:t>   徹底隔離 18 項 PHI、BOM 原料成本、工廠良率與薪資帳密。</a:t>
-            </a:r>
-          </a:p>
-          <a:p>
-            <a:pPr>
-              <a:defRPr sz="1200" b="1">
+              <a:t>• 🏛️ Paper 1: DROS-6P 閉環架構</a:t>
+            </a:r>
+          </a:p>
+          <a:p>
+            <a:pPr>
+              <a:defRPr sz="1300">
+                <a:solidFill>
+                  <a:srgbClr val="CBD5E1"/>
+                </a:solidFill>
+              </a:defRPr>
+            </a:pPr>
+            <a:r>
+              <a:t>   DOI: 10.5281/zenodo.21833970 (六大信任邊界執行期治理)</a:t>
+            </a:r>
+          </a:p>
+          <a:p>
+            <a:pPr>
+              <a:defRPr sz="1450" b="1">
                 <a:solidFill>
                   <a:srgbClr val="F8FAFC"/>
                 </a:solidFill>
               </a:defRPr>
             </a:pPr>
             <a:r>
-              <a:t>• 🧩 部件 ②：DIT Token Principal Injector</a:t>
-            </a:r>
-          </a:p>
-          <a:p>
-            <a:pPr>
-              <a:defRPr sz="1100">
-                <a:solidFill>
-                  <a:srgbClr val="94A3B8"/>
-                </a:solidFill>
-              </a:defRPr>
-            </a:pPr>
-            <a:r>
-              <a:t>   確定性身分憑證注入器，採用 Ed25519 密碼學簽名。</a:t>
-            </a:r>
-          </a:p>
-          <a:p>
-            <a:pPr>
-              <a:defRPr sz="1200" b="1">
+              <a:t>• 🏛️ Paper 2: DROS 四層操作系統</a:t>
+            </a:r>
+          </a:p>
+          <a:p>
+            <a:pPr>
+              <a:defRPr sz="1300">
+                <a:solidFill>
+                  <a:srgbClr val="CBD5E1"/>
+                </a:solidFill>
+              </a:defRPr>
+            </a:pPr>
+            <a:r>
+              <a:t>   DOI: 10.5281/zenodo.22092008 (彌合代理人至執行歸因鴻溝)</a:t>
+            </a:r>
+          </a:p>
+          <a:p>
+            <a:pPr>
+              <a:defRPr sz="1450" b="1">
                 <a:solidFill>
                   <a:srgbClr val="F8FAFC"/>
                 </a:solidFill>
               </a:defRPr>
             </a:pPr>
             <a:r>
-              <a:t>• 🛡️ 涵蓋 6P：P1. Principal + P2. Authorization</a:t>
-            </a:r>
-          </a:p>
-          <a:p>
-            <a:pPr>
-              <a:defRPr sz="1100">
-                <a:solidFill>
-                  <a:srgbClr val="94A3B8"/>
-                </a:solidFill>
-              </a:defRPr>
-            </a:pPr>
-            <a:r>
-              <a:t>   密碼學強綁定法人 vLEI、自然人 MyData 與 1:1:1 移工防偽。</a:t>
-            </a:r>
-          </a:p>
-        </p:txBody>
-      </p:sp>
-      <p:sp>
-        <p:nvSpPr>
-          <p:cNvPr id="5" name="Rounded Rectangle 4"/>
-          <p:cNvSpPr/>
-          <p:nvPr/>
-        </p:nvSpPr>
-        <p:spPr>
-          <a:xfrm>
-            <a:off x="6248095" y="1280160"/>
-            <a:ext cx="5212080" cy="5029200"/>
-          </a:xfrm>
-          <a:prstGeom prst="roundRect">
-            <a:avLst/>
-          </a:prstGeom>
-          <a:solidFill>
-            <a:srgbClr val="0F172A"/>
-          </a:solidFill>
-          <a:ln w="19050">
-            <a:solidFill>
-              <a:srgbClr val="C084FC"/>
-            </a:solidFill>
-          </a:ln>
-        </p:spPr>
-        <p:style>
-          <a:lnRef idx="1">
-            <a:schemeClr val="accent1"/>
-          </a:lnRef>
-          <a:fillRef idx="3">
-            <a:schemeClr val="accent1"/>
-          </a:fillRef>
-          <a:effectRef idx="2">
-            <a:schemeClr val="accent1"/>
-          </a:effectRef>
-          <a:fontRef idx="minor">
-            <a:schemeClr val="lt1"/>
-          </a:fontRef>
-        </p:style>
-        <p:txBody>
-          <a:bodyPr rtlCol="0" anchor="ctr" wrap="square" lIns="228600" rIns="228600" tIns="182880" bIns="137160"/>
-          <a:lstStyle/>
-          <a:p>
-            <a:pPr algn="ctr">
-              <a:defRPr sz="1500" b="1">
-                <a:solidFill>
-                  <a:srgbClr val="C084FC"/>
-                </a:solidFill>
-              </a:defRPr>
-            </a:pPr>
-            <a:r>
-              <a:t>📤 Egress（輸出執行邊界）：確定性門閥</a:t>
-            </a:r>
-          </a:p>
-          <a:p>
-            <a:pPr>
-              <a:defRPr sz="1200" b="1">
-                <a:solidFill>
-                  <a:srgbClr val="F8FAFC"/>
-                </a:solidFill>
-              </a:defRPr>
-            </a:pPr>
-            <a:r>
-              <a:t>• 🧩 部件 ③：C-ABI In-Band Policy Gate</a:t>
-            </a:r>
-          </a:p>
-          <a:p>
-            <a:pPr>
-              <a:defRPr sz="1100">
-                <a:solidFill>
-                  <a:srgbClr val="94A3B8"/>
-                </a:solidFill>
-              </a:defRPr>
-            </a:pPr>
-            <a:r>
-              <a:t>   二進位 C-ABI 帶內閘門，暫存器級 Capability Bitmaps 匹配。</a:t>
-            </a:r>
-          </a:p>
-          <a:p>
-            <a:pPr>
-              <a:defRPr sz="1200" b="1">
-                <a:solidFill>
-                  <a:srgbClr val="F8FAFC"/>
-                </a:solidFill>
-              </a:defRPr>
-            </a:pPr>
-            <a:r>
-              <a:t>• 🛡️ 涵蓋 6P：P2. Scope 授權 + P3. Tool Bound 攔截</a:t>
-            </a:r>
-          </a:p>
-          <a:p>
-            <a:pPr>
-              <a:defRPr sz="1100">
-                <a:solidFill>
-                  <a:srgbClr val="94A3B8"/>
-                </a:solidFill>
-              </a:defRPr>
-            </a:pPr>
-            <a:r>
-              <a:t>   26.1 μs 內硬性熔斷 (HTTP 403)，AI 物理無法繞過。</a:t>
-            </a:r>
-          </a:p>
-          <a:p>
-            <a:pPr>
-              <a:defRPr sz="1200" b="1">
-                <a:solidFill>
-                  <a:srgbClr val="F8FAFC"/>
-                </a:solidFill>
-              </a:defRPr>
-            </a:pPr>
-            <a:r>
-              <a:t>• 🧩 部件 ④：Merkle Chain &amp; RCU Revocation</a:t>
-            </a:r>
-          </a:p>
-          <a:p>
-            <a:pPr>
-              <a:defRPr sz="1100">
-                <a:solidFill>
-                  <a:srgbClr val="94A3B8"/>
-                </a:solidFill>
-              </a:defRPr>
-            </a:pPr>
-            <a:r>
-              <a:t>   SHA-256 密碼學防篡改存證鏈 + O(1) 原子指針秒級撤銷。</a:t>
-            </a:r>
-          </a:p>
-          <a:p>
-            <a:pPr>
-              <a:defRPr sz="1200" b="1">
-                <a:solidFill>
-                  <a:srgbClr val="F8FAFC"/>
-                </a:solidFill>
-              </a:defRPr>
-            </a:pPr>
-            <a:r>
-              <a:t>• 🛡️ 涵蓋 6P：P5. Audit Log + P6. Revocation</a:t>
-            </a:r>
-          </a:p>
-          <a:p>
-            <a:pPr>
-              <a:defRPr sz="1100">
-                <a:solidFill>
-                  <a:srgbClr val="94A3B8"/>
-                </a:solidFill>
-              </a:defRPr>
-            </a:pPr>
-            <a:r>
-              <a:t>   產出法庭採信收據；管理員一鍵凍結權限秒級生效。</a:t>
-            </a:r>
-          </a:p>
-        </p:txBody>
-      </p:sp>
-    </p:spTree>
-  </p:cSld>
-  <p:clrMapOvr>
-    <a:masterClrMapping/>
-  </p:clrMapOvr>
-</p:sld>
-</file>
-
-<file path=ppt/slides/slide4.xml><?xml version="1.0" encoding="utf-8"?>
-<p:sld xmlns:a="http://schemas.openxmlformats.org/drawingml/2006/main" xmlns:p="http://schemas.openxmlformats.org/presentationml/2006/main" xmlns:r="http://schemas.openxmlformats.org/officeDocument/2006/relationships">
-  <p:cSld>
-    <p:spTree>
-      <p:nvGrpSpPr>
-        <p:cNvPr id="1" name=""/>
-        <p:cNvGrpSpPr/>
-        <p:nvPr/>
-      </p:nvGrpSpPr>
-      <p:grpSpPr/>
-      <p:sp>
-        <p:nvSpPr>
-          <p:cNvPr id="2" name="Rectangle 1"/>
-          <p:cNvSpPr/>
-          <p:nvPr/>
-        </p:nvSpPr>
-        <p:spPr>
-          <a:xfrm>
-            <a:off x="0" y="0"/>
-            <a:ext cx="12191695" cy="6858000"/>
-          </a:xfrm>
-          <a:prstGeom prst="rect">
-            <a:avLst/>
-          </a:prstGeom>
-          <a:solidFill>
-            <a:srgbClr val="070A12"/>
-          </a:solidFill>
-          <a:ln>
-            <a:noFill/>
-          </a:ln>
-        </p:spPr>
-        <p:style>
-          <a:lnRef idx="1">
-            <a:schemeClr val="accent1"/>
-          </a:lnRef>
-          <a:fillRef idx="3">
-            <a:schemeClr val="accent1"/>
-          </a:fillRef>
-          <a:effectRef idx="2">
-            <a:schemeClr val="accent1"/>
-          </a:effectRef>
-          <a:fontRef idx="minor">
-            <a:schemeClr val="lt1"/>
-          </a:fontRef>
-        </p:style>
-        <p:txBody>
-          <a:bodyPr rtlCol="0" anchor="ctr"/>
-          <a:lstStyle/>
-          <a:p>
-            <a:pPr algn="ctr"/>
-          </a:p>
-        </p:txBody>
-      </p:sp>
-      <p:sp>
-        <p:nvSpPr>
-          <p:cNvPr id="3" name="TextBox 2"/>
-          <p:cNvSpPr txBox="1"/>
-          <p:nvPr/>
-        </p:nvSpPr>
-        <p:spPr>
-          <a:xfrm>
-            <a:off x="731520" y="365760"/>
-            <a:ext cx="10728655" cy="822960"/>
-          </a:xfrm>
-          <a:prstGeom prst="rect">
-            <a:avLst/>
-          </a:prstGeom>
-          <a:noFill/>
-        </p:spPr>
-        <p:txBody>
-          <a:bodyPr wrap="square" lIns="0" rIns="0" tIns="0" bIns="0">
-            <a:spAutoFit/>
-          </a:bodyPr>
-          <a:lstStyle/>
-          <a:p>
-            <a:pPr>
-              <a:defRPr sz="1100" b="1">
-                <a:solidFill>
-                  <a:srgbClr val="38BDF8"/>
-                </a:solidFill>
-              </a:defRPr>
-            </a:pPr>
-            <a:r>
-              <a:t>● ACADEMIC &amp; ENGINEERING BASE</a:t>
-            </a:r>
-          </a:p>
-          <a:p>
-            <a:pPr>
-              <a:defRPr sz="2200" b="1">
-                <a:solidFill>
-                  <a:srgbClr val="F8FAFC"/>
-                </a:solidFill>
-              </a:defRPr>
-            </a:pPr>
-            <a:r>
-              <a:t>技術底座背書：Zenodo 學術三部曲、GitHub 100% 驗證倉與「個人免費授權彩蛋」</a:t>
-            </a:r>
-          </a:p>
-        </p:txBody>
-      </p:sp>
-      <p:sp>
-        <p:nvSpPr>
-          <p:cNvPr id="4" name="Rounded Rectangle 3"/>
-          <p:cNvSpPr/>
-          <p:nvPr/>
-        </p:nvSpPr>
-        <p:spPr>
-          <a:xfrm>
-            <a:off x="731520" y="1280160"/>
-            <a:ext cx="5212080" cy="5029200"/>
-          </a:xfrm>
-          <a:prstGeom prst="roundRect">
-            <a:avLst/>
-          </a:prstGeom>
-          <a:solidFill>
-            <a:srgbClr val="0F172A"/>
-          </a:solidFill>
-          <a:ln w="19050">
-            <a:solidFill>
-              <a:srgbClr val="38BDF8"/>
-            </a:solidFill>
-          </a:ln>
-        </p:spPr>
-        <p:style>
-          <a:lnRef idx="1">
-            <a:schemeClr val="accent1"/>
-          </a:lnRef>
-          <a:fillRef idx="3">
-            <a:schemeClr val="accent1"/>
-          </a:fillRef>
-          <a:effectRef idx="2">
-            <a:schemeClr val="accent1"/>
-          </a:effectRef>
-          <a:fontRef idx="minor">
-            <a:schemeClr val="lt1"/>
-          </a:fontRef>
-        </p:style>
-        <p:txBody>
-          <a:bodyPr rtlCol="0" anchor="ctr" wrap="square" lIns="228600" rIns="228600" tIns="182880" bIns="137160"/>
-          <a:lstStyle/>
-          <a:p>
-            <a:pPr algn="ctr">
-              <a:defRPr sz="1500" b="1">
-                <a:solidFill>
-                  <a:srgbClr val="38BDF8"/>
-                </a:solidFill>
-              </a:defRPr>
-            </a:pPr>
-            <a:r>
-              <a:t>🏛️ Zenodo 國際權威學術論文三部曲</a:t>
-            </a:r>
-          </a:p>
-          <a:p>
-            <a:pPr>
-              <a:defRPr sz="1150" b="1">
-                <a:solidFill>
-                  <a:srgbClr val="F8FAFC"/>
-                </a:solidFill>
-              </a:defRPr>
-            </a:pPr>
-            <a:r>
-              <a:t>• 📖 學術導讀指南 (Guide Note)</a:t>
-            </a:r>
-          </a:p>
-          <a:p>
-            <a:pPr>
-              <a:defRPr sz="1000">
-                <a:solidFill>
-                  <a:srgbClr val="94A3B8"/>
-                </a:solidFill>
-              </a:defRPr>
-            </a:pPr>
-            <a:r>
-              <a:t>   DOI: 10.5281/zenodo.22114036</a:t>
-            </a:r>
-            <a:br/>
-            <a:r>
-              <a:t>面向自主 AI 工作負載的確定性執行期作業基板。</a:t>
-            </a:r>
-          </a:p>
-          <a:p>
-            <a:pPr>
-              <a:defRPr sz="1150" b="1">
-                <a:solidFill>
-                  <a:srgbClr val="F8FAFC"/>
-                </a:solidFill>
-              </a:defRPr>
-            </a:pPr>
-            <a:r>
-              <a:t>• 🏛️ Paper 1: DROS-6P 閉環架構</a:t>
-            </a:r>
-          </a:p>
-          <a:p>
-            <a:pPr>
-              <a:defRPr sz="1000">
-                <a:solidFill>
-                  <a:srgbClr val="94A3B8"/>
-                </a:solidFill>
-              </a:defRPr>
-            </a:pPr>
-            <a:r>
-              <a:t>   DOI: 10.5281/zenodo.21833970</a:t>
-            </a:r>
-            <a:br/>
-            <a:r>
-              <a:t>企業級 AI Agent 六大信任邊界之確定性治理。</a:t>
-            </a:r>
-          </a:p>
-          <a:p>
-            <a:pPr>
-              <a:defRPr sz="1150" b="1">
-                <a:solidFill>
-                  <a:srgbClr val="F8FAFC"/>
-                </a:solidFill>
-              </a:defRPr>
-            </a:pPr>
-            <a:r>
-              <a:t>• 🏛️ Paper 2: DROS 四層操作系統</a:t>
-            </a:r>
-          </a:p>
-          <a:p>
-            <a:pPr>
-              <a:defRPr sz="1000">
-                <a:solidFill>
-                  <a:srgbClr val="94A3B8"/>
-                </a:solidFill>
-              </a:defRPr>
-            </a:pPr>
-            <a:r>
-              <a:t>   DOI: 10.5281/zenodo.22092008</a:t>
-            </a:r>
-            <a:br/>
-            <a:r>
-              <a:t>彌合代理人至執行歸因鴻溝之四層架構。</a:t>
-            </a:r>
-          </a:p>
-          <a:p>
-            <a:pPr>
-              <a:defRPr sz="1150" b="1">
-                <a:solidFill>
-                  <a:srgbClr val="F8FAFC"/>
-                </a:solidFill>
-              </a:defRPr>
-            </a:pPr>
-            <a:r>
               <a:t>• 🏛️ Paper 3: DROS-PGM 控制平面</a:t>
             </a:r>
           </a:p>
           <a:p>
             <a:pPr>
-              <a:defRPr sz="1000">
-                <a:solidFill>
-                  <a:srgbClr val="94A3B8"/>
-                </a:solidFill>
-              </a:defRPr>
-            </a:pPr>
-            <a:r>
-              <a:t>   DOI: 10.5281/zenodo.21903687</a:t>
-            </a:r>
-            <a:br/>
-            <a:r>
-              <a:t>內核級運行期安全與微秒硬熔斷控制平面。</a:t>
+              <a:defRPr sz="1300">
+                <a:solidFill>
+                  <a:srgbClr val="CBD5E1"/>
+                </a:solidFill>
+              </a:defRPr>
+            </a:pPr>
+            <a:r>
+              <a:t>   DOI: 10.5281/zenodo.21903687 (內核級運行安全與微秒硬熔斷)</a:t>
             </a:r>
           </a:p>
         </p:txBody>
@@ -4523,24 +4904,24 @@
           </a:fontRef>
         </p:style>
         <p:txBody>
-          <a:bodyPr rtlCol="0" anchor="ctr" wrap="square" lIns="228600" rIns="228600" tIns="182880" bIns="137160"/>
+          <a:bodyPr rtlCol="0" anchor="ctr" wrap="square" lIns="274320" rIns="274320" tIns="228600" bIns="182880"/>
           <a:lstStyle/>
           <a:p>
             <a:pPr algn="ctr">
+              <a:defRPr sz="1550" b="1">
+                <a:solidFill>
+                  <a:srgbClr val="4ADE80"/>
+                </a:solidFill>
+              </a:defRPr>
+            </a:pPr>
+            <a:r>
+              <a:t>💻 GitHub 100% 驗證倉 ＆ 🎁 全民安全彩蛋</a:t>
+            </a:r>
+          </a:p>
+          <a:p>
+            <a:pPr>
               <a:defRPr sz="1400" b="1">
                 <a:solidFill>
-                  <a:srgbClr val="4ADE80"/>
-                </a:solidFill>
-              </a:defRPr>
-            </a:pPr>
-            <a:r>
-              <a:t>💻 GitHub 100% 驗證倉 ＆ 🎁 全民安全彩蛋</a:t>
-            </a:r>
-          </a:p>
-          <a:p>
-            <a:pPr>
-              <a:defRPr sz="1100" b="1">
-                <a:solidFill>
                   <a:srgbClr val="F8FAFC"/>
                 </a:solidFill>
               </a:defRPr>
@@ -4551,102 +4932,90 @@
           </a:p>
           <a:p>
             <a:pPr>
-              <a:defRPr sz="950">
-                <a:solidFill>
-                  <a:srgbClr val="94A3B8"/>
+              <a:defRPr sz="1250">
+                <a:solidFill>
+                  <a:srgbClr val="CBD5E1"/>
                 </a:solidFill>
               </a:defRPr>
             </a:pPr>
             <a:r>
               <a:t>   github.com/Top-Celestial-Company-Ltd/DROS-Hackathon-Showcase</a:t>
             </a:r>
+          </a:p>
+          <a:p>
+            <a:pPr>
+              <a:defRPr sz="1400" b="1">
+                <a:solidFill>
+                  <a:srgbClr val="F8FAFC"/>
+                </a:solidFill>
+              </a:defRPr>
+            </a:pPr>
+            <a:r>
+              <a:t>• 🛡️ DROS-VEP Lite 核心評測倉</a:t>
+            </a:r>
+          </a:p>
+          <a:p>
+            <a:pPr>
+              <a:defRPr sz="1250">
+                <a:solidFill>
+                  <a:srgbClr val="CBD5E1"/>
+                </a:solidFill>
+              </a:defRPr>
+            </a:pPr>
+            <a:r>
+              <a:t>   github.com/Top-Celestial-Company-Ltd/DROS-VEP-lite (0.001s PASS)</a:t>
+            </a:r>
+          </a:p>
+          <a:p>
+            <a:pPr>
+              <a:defRPr sz="1400" b="1">
+                <a:solidFill>
+                  <a:srgbClr val="FBBF24"/>
+                </a:solidFill>
+              </a:defRPr>
+            </a:pPr>
+            <a:r>
+              <a:t>• 🎁【個人 Free 安全彩蛋】全民基建！</a:t>
+            </a:r>
+          </a:p>
+          <a:p>
+            <a:pPr>
+              <a:defRPr sz="1250">
+                <a:solidFill>
+                  <a:srgbClr val="F8FAFC"/>
+                </a:solidFill>
+              </a:defRPr>
+            </a:pPr>
+            <a:r>
+              <a:t>   NPM 套件: npm install dsh-plugin-vajraclaw</a:t>
+            </a:r>
             <a:br/>
             <a:r>
-              <a:t>多軌互動發射台、REST API 與 6 大賽道對照。</a:t>
-            </a:r>
-          </a:p>
-          <a:p>
-            <a:pPr>
-              <a:defRPr sz="1100" b="1">
+              <a:t>👉 提供「個人非商業永久免費授權」，享 1 微秒帶內硬熔斷保護！</a:t>
+            </a:r>
+          </a:p>
+          <a:p>
+            <a:pPr>
+              <a:defRPr sz="1400" b="1">
                 <a:solidFill>
                   <a:srgbClr val="F8FAFC"/>
                 </a:solidFill>
               </a:defRPr>
             </a:pPr>
             <a:r>
-              <a:t>• 🛡️ DROS-VEP Lite 核心評測倉</a:t>
-            </a:r>
-          </a:p>
-          <a:p>
-            <a:pPr>
-              <a:defRPr sz="950">
-                <a:solidFill>
-                  <a:srgbClr val="94A3B8"/>
-                </a:solidFill>
-              </a:defRPr>
-            </a:pPr>
-            <a:r>
-              <a:t>   github.com/Top-Celestial-Company-Ltd/DROS-VEP-lite</a:t>
-            </a:r>
-            <a:br/>
-            <a:r>
-              <a:t>零依賴 TDD 測試套件 (0.001s ALL 5 PASSED)。</a:t>
-            </a:r>
-          </a:p>
-          <a:p>
-            <a:pPr>
-              <a:defRPr sz="1100" b="1">
-                <a:solidFill>
-                  <a:srgbClr val="FBBF24"/>
-                </a:solidFill>
-              </a:defRPr>
-            </a:pPr>
-            <a:r>
-              <a:t>• 🎁【個人 Free 安全彩蛋】Agent 安全應是全民基建！</a:t>
-            </a:r>
-          </a:p>
-          <a:p>
-            <a:pPr>
-              <a:defRPr sz="950">
-                <a:solidFill>
-                  <a:srgbClr val="F8FAFC"/>
-                </a:solidFill>
-              </a:defRPr>
-            </a:pPr>
-            <a:r>
-              <a:t>   NPM 套件: npm install dsh-plugin-vajraclaw</a:t>
-            </a:r>
-            <a:br/>
-            <a:r>
-              <a:t>GitHub: github.com/Top-Celestial-Company-Ltd/dsh-plugin-vajraclaw</a:t>
-            </a:r>
-            <a:br/>
-            <a:r>
-              <a:t>👉 提供「個人非商業永久免費授權 (Free License)」，讓每位個人開發者在本地執行 Agent 享有 1 微秒帶內硬熔斷保護！</a:t>
-            </a:r>
-          </a:p>
-          <a:p>
-            <a:pPr>
-              <a:defRPr sz="1100" b="1">
-                <a:solidFill>
-                  <a:srgbClr val="F8FAFC"/>
-                </a:solidFill>
-              </a:defRPr>
-            </a:pPr>
-            <a:r>
               <a:t>• 🔒 美國臨時專利保護 (Patent Pending)</a:t>
             </a:r>
           </a:p>
           <a:p>
             <a:pPr>
-              <a:defRPr sz="950">
-                <a:solidFill>
-                  <a:srgbClr val="94A3B8"/>
-                </a:solidFill>
-              </a:defRPr>
-            </a:pPr>
-            <a:r>
-              <a:t>   U.S. PPA No. 64/111,973 (保護執行期帶內確定性治理核心)</a:t>
+              <a:defRPr sz="1250">
+                <a:solidFill>
+                  <a:srgbClr val="CBD5E1"/>
+                </a:solidFill>
+              </a:defRPr>
+            </a:pPr>
+            <a:r>
+              <a:t>   U.S. Provisional Patent Application No. 64/111,973</a:t>
             </a:r>
           </a:p>
         </p:txBody>
@@ -4659,7 +5028,7 @@
 </p:sld>
 </file>
 
-<file path=ppt/slides/slide5.xml><?xml version="1.0" encoding="utf-8"?>
+<file path=ppt/slides/slide6.xml><?xml version="1.0" encoding="utf-8"?>
 <p:sld xmlns:a="http://schemas.openxmlformats.org/drawingml/2006/main" xmlns:p="http://schemas.openxmlformats.org/presentationml/2006/main" xmlns:r="http://schemas.openxmlformats.org/officeDocument/2006/relationships">
   <p:cSld>
     <p:spTree>
@@ -4735,7 +5104,7 @@
           <a:lstStyle/>
           <a:p>
             <a:pPr>
-              <a:defRPr sz="1100" b="1">
+              <a:defRPr sz="1300" b="1">
                 <a:solidFill>
                   <a:srgbClr val="38BDF8"/>
                 </a:solidFill>
@@ -4747,7 +5116,7 @@
           </a:p>
           <a:p>
             <a:pPr>
-              <a:defRPr sz="2200" b="1">
+              <a:defRPr sz="2400" b="1">
                 <a:solidFill>
                   <a:srgbClr val="F8FAFC"/>
                 </a:solidFill>
@@ -4797,11 +5166,11 @@
           </a:fontRef>
         </p:style>
         <p:txBody>
-          <a:bodyPr rtlCol="0" anchor="ctr" wrap="square" lIns="228600" rIns="228600" tIns="182880" bIns="137160"/>
+          <a:bodyPr rtlCol="0" anchor="ctr" wrap="square" lIns="274320" rIns="274320" tIns="228600" bIns="182880"/>
           <a:lstStyle/>
           <a:p>
             <a:pPr algn="ctr">
-              <a:defRPr sz="1200" b="1">
+              <a:defRPr sz="1300" b="1">
                 <a:solidFill>
                   <a:srgbClr val="38BDF8"/>
                 </a:solidFill>
@@ -4813,7 +5182,7 @@
           </a:p>
           <a:p>
             <a:pPr>
-              <a:defRPr sz="950">
+              <a:defRPr sz="1100">
                 <a:solidFill>
                   <a:srgbClr val="F8FAFC"/>
                 </a:solidFill>
@@ -4825,9 +5194,9 @@
           </a:p>
           <a:p>
             <a:pPr>
-              <a:defRPr sz="950">
-                <a:solidFill>
-                  <a:srgbClr val="94A3B8"/>
+              <a:defRPr sz="1100">
+                <a:solidFill>
+                  <a:srgbClr val="CBD5E1"/>
                 </a:solidFill>
               </a:defRPr>
             </a:pPr>
@@ -4875,11 +5244,11 @@
           </a:fontRef>
         </p:style>
         <p:txBody>
-          <a:bodyPr rtlCol="0" anchor="ctr" wrap="square" lIns="228600" rIns="228600" tIns="182880" bIns="137160"/>
+          <a:bodyPr rtlCol="0" anchor="ctr" wrap="square" lIns="274320" rIns="274320" tIns="228600" bIns="182880"/>
           <a:lstStyle/>
           <a:p>
             <a:pPr algn="ctr">
-              <a:defRPr sz="1200" b="1">
+              <a:defRPr sz="1300" b="1">
                 <a:solidFill>
                   <a:srgbClr val="4ADE80"/>
                 </a:solidFill>
@@ -4891,7 +5260,7 @@
           </a:p>
           <a:p>
             <a:pPr>
-              <a:defRPr sz="950">
+              <a:defRPr sz="1100">
                 <a:solidFill>
                   <a:srgbClr val="F8FAFC"/>
                 </a:solidFill>
@@ -4903,9 +5272,9 @@
           </a:p>
           <a:p>
             <a:pPr>
-              <a:defRPr sz="950">
-                <a:solidFill>
-                  <a:srgbClr val="94A3B8"/>
+              <a:defRPr sz="1100">
+                <a:solidFill>
+                  <a:srgbClr val="CBD5E1"/>
                 </a:solidFill>
               </a:defRPr>
             </a:pPr>
@@ -4953,11 +5322,11 @@
           </a:fontRef>
         </p:style>
         <p:txBody>
-          <a:bodyPr rtlCol="0" anchor="ctr" wrap="square" lIns="228600" rIns="228600" tIns="182880" bIns="137160"/>
+          <a:bodyPr rtlCol="0" anchor="ctr" wrap="square" lIns="274320" rIns="274320" tIns="228600" bIns="182880"/>
           <a:lstStyle/>
           <a:p>
             <a:pPr algn="ctr">
-              <a:defRPr sz="1200" b="1">
+              <a:defRPr sz="1300" b="1">
                 <a:solidFill>
                   <a:srgbClr val="F87171"/>
                 </a:solidFill>
@@ -4969,7 +5338,7 @@
           </a:p>
           <a:p>
             <a:pPr>
-              <a:defRPr sz="950">
+              <a:defRPr sz="1100">
                 <a:solidFill>
                   <a:srgbClr val="F8FAFC"/>
                 </a:solidFill>
@@ -4981,9 +5350,9 @@
           </a:p>
           <a:p>
             <a:pPr>
-              <a:defRPr sz="950">
-                <a:solidFill>
-                  <a:srgbClr val="94A3B8"/>
+              <a:defRPr sz="1100">
+                <a:solidFill>
+                  <a:srgbClr val="CBD5E1"/>
                 </a:solidFill>
               </a:defRPr>
             </a:pPr>
@@ -5031,11 +5400,11 @@
           </a:fontRef>
         </p:style>
         <p:txBody>
-          <a:bodyPr rtlCol="0" anchor="ctr" wrap="square" lIns="228600" rIns="228600" tIns="182880" bIns="137160"/>
+          <a:bodyPr rtlCol="0" anchor="ctr" wrap="square" lIns="274320" rIns="274320" tIns="228600" bIns="182880"/>
           <a:lstStyle/>
           <a:p>
             <a:pPr algn="ctr">
-              <a:defRPr sz="1200" b="1">
+              <a:defRPr sz="1300" b="1">
                 <a:solidFill>
                   <a:srgbClr val="FBBF24"/>
                 </a:solidFill>
@@ -5047,7 +5416,7 @@
           </a:p>
           <a:p>
             <a:pPr>
-              <a:defRPr sz="950">
+              <a:defRPr sz="1100">
                 <a:solidFill>
                   <a:srgbClr val="F8FAFC"/>
                 </a:solidFill>
@@ -5059,9 +5428,9 @@
           </a:p>
           <a:p>
             <a:pPr>
-              <a:defRPr sz="950">
-                <a:solidFill>
-                  <a:srgbClr val="94A3B8"/>
+              <a:defRPr sz="1100">
+                <a:solidFill>
+                  <a:srgbClr val="CBD5E1"/>
                 </a:solidFill>
               </a:defRPr>
             </a:pPr>
@@ -5109,11 +5478,11 @@
           </a:fontRef>
         </p:style>
         <p:txBody>
-          <a:bodyPr rtlCol="0" anchor="ctr" wrap="square" lIns="228600" rIns="228600" tIns="182880" bIns="137160"/>
+          <a:bodyPr rtlCol="0" anchor="ctr" wrap="square" lIns="274320" rIns="274320" tIns="228600" bIns="182880"/>
           <a:lstStyle/>
           <a:p>
             <a:pPr algn="ctr">
-              <a:defRPr sz="1200" b="1">
+              <a:defRPr sz="1300" b="1">
                 <a:solidFill>
                   <a:srgbClr val="C084FC"/>
                 </a:solidFill>
@@ -5125,7 +5494,7 @@
           </a:p>
           <a:p>
             <a:pPr>
-              <a:defRPr sz="950">
+              <a:defRPr sz="1100">
                 <a:solidFill>
                   <a:srgbClr val="F8FAFC"/>
                 </a:solidFill>
@@ -5137,9 +5506,9 @@
           </a:p>
           <a:p>
             <a:pPr>
-              <a:defRPr sz="950">
-                <a:solidFill>
-                  <a:srgbClr val="94A3B8"/>
+              <a:defRPr sz="1100">
+                <a:solidFill>
+                  <a:srgbClr val="CBD5E1"/>
                 </a:solidFill>
               </a:defRPr>
             </a:pPr>
@@ -5187,11 +5556,11 @@
           </a:fontRef>
         </p:style>
         <p:txBody>
-          <a:bodyPr rtlCol="0" anchor="ctr" wrap="square" lIns="228600" rIns="228600" tIns="182880" bIns="137160"/>
+          <a:bodyPr rtlCol="0" anchor="ctr" wrap="square" lIns="274320" rIns="274320" tIns="228600" bIns="182880"/>
           <a:lstStyle/>
           <a:p>
             <a:pPr algn="ctr">
-              <a:defRPr sz="1200" b="1">
+              <a:defRPr sz="1300" b="1">
                 <a:solidFill>
                   <a:srgbClr val="38BDF8"/>
                 </a:solidFill>
@@ -5203,7 +5572,7 @@
           </a:p>
           <a:p>
             <a:pPr>
-              <a:defRPr sz="950">
+              <a:defRPr sz="1100">
                 <a:solidFill>
                   <a:srgbClr val="F8FAFC"/>
                 </a:solidFill>
@@ -5215,9 +5584,9 @@
           </a:p>
           <a:p>
             <a:pPr>
-              <a:defRPr sz="950">
-                <a:solidFill>
-                  <a:srgbClr val="94A3B8"/>
+              <a:defRPr sz="1100">
+                <a:solidFill>
+                  <a:srgbClr val="CBD5E1"/>
                 </a:solidFill>
               </a:defRPr>
             </a:pPr>
@@ -5235,7 +5604,7 @@
 </p:sld>
 </file>
 
-<file path=ppt/slides/slide6.xml><?xml version="1.0" encoding="utf-8"?>
+<file path=ppt/slides/slide7.xml><?xml version="1.0" encoding="utf-8"?>
 <p:sld xmlns:a="http://schemas.openxmlformats.org/drawingml/2006/main" xmlns:p="http://schemas.openxmlformats.org/presentationml/2006/main" xmlns:r="http://schemas.openxmlformats.org/officeDocument/2006/relationships">
   <p:cSld>
     <p:spTree>
@@ -5311,7 +5680,7 @@
           <a:lstStyle/>
           <a:p>
             <a:pPr>
-              <a:defRPr sz="1100" b="1">
+              <a:defRPr sz="1300" b="1">
                 <a:solidFill>
                   <a:srgbClr val="38BDF8"/>
                 </a:solidFill>
@@ -5323,7 +5692,7 @@
           </a:p>
           <a:p>
             <a:pPr>
-              <a:defRPr sz="2200" b="1">
+              <a:defRPr sz="2400" b="1">
                 <a:solidFill>
                   <a:srgbClr val="F8FAFC"/>
                 </a:solidFill>
@@ -5373,11 +5742,11 @@
           </a:fontRef>
         </p:style>
         <p:txBody>
-          <a:bodyPr rtlCol="0" anchor="ctr" wrap="square" lIns="228600" rIns="228600" tIns="182880" bIns="137160"/>
+          <a:bodyPr rtlCol="0" anchor="ctr" wrap="square" lIns="274320" rIns="274320" tIns="228600" bIns="182880"/>
           <a:lstStyle/>
           <a:p>
             <a:pPr algn="ctr">
-              <a:defRPr sz="1400" b="1">
+              <a:defRPr sz="1500" b="1">
                 <a:solidFill>
                   <a:srgbClr val="38BDF8"/>
                 </a:solidFill>
@@ -5389,7 +5758,7 @@
           </a:p>
           <a:p>
             <a:pPr>
-              <a:defRPr sz="1150">
+              <a:defRPr sz="1350">
                 <a:solidFill>
                   <a:srgbClr val="F8FAFC"/>
                 </a:solidFill>
@@ -5447,11 +5816,11 @@
           </a:fontRef>
         </p:style>
         <p:txBody>
-          <a:bodyPr rtlCol="0" anchor="ctr" wrap="square" lIns="228600" rIns="228600" tIns="182880" bIns="137160"/>
+          <a:bodyPr rtlCol="0" anchor="ctr" wrap="square" lIns="274320" rIns="274320" tIns="228600" bIns="182880"/>
           <a:lstStyle/>
           <a:p>
             <a:pPr algn="ctr">
-              <a:defRPr sz="1400" b="1">
+              <a:defRPr sz="1500" b="1">
                 <a:solidFill>
                   <a:srgbClr val="4ADE80"/>
                 </a:solidFill>
@@ -5463,7 +5832,7 @@
           </a:p>
           <a:p>
             <a:pPr>
-              <a:defRPr sz="1200">
+              <a:defRPr sz="1350">
                 <a:solidFill>
                   <a:srgbClr val="F8FAFC"/>
                 </a:solidFill>
@@ -5525,11 +5894,11 @@
           </a:fontRef>
         </p:style>
         <p:txBody>
-          <a:bodyPr rtlCol="0" anchor="ctr" wrap="square" lIns="228600" rIns="228600" tIns="182880" bIns="137160"/>
+          <a:bodyPr rtlCol="0" anchor="ctr" wrap="square" lIns="274320" rIns="274320" tIns="228600" bIns="182880"/>
           <a:lstStyle/>
           <a:p>
             <a:pPr algn="ctr">
-              <a:defRPr sz="1400" b="1">
+              <a:defRPr sz="1500" b="1">
                 <a:solidFill>
                   <a:srgbClr val="FBBF24"/>
                 </a:solidFill>
@@ -5541,7 +5910,7 @@
           </a:p>
           <a:p>
             <a:pPr>
-              <a:defRPr sz="1200">
+              <a:defRPr sz="1350">
                 <a:solidFill>
                   <a:srgbClr val="F8FAFC"/>
                 </a:solidFill>
@@ -5573,7 +5942,7 @@
 </p:sld>
 </file>
 
-<file path=ppt/slides/slide7.xml><?xml version="1.0" encoding="utf-8"?>
+<file path=ppt/slides/slide8.xml><?xml version="1.0" encoding="utf-8"?>
 <p:sld xmlns:a="http://schemas.openxmlformats.org/drawingml/2006/main" xmlns:p="http://schemas.openxmlformats.org/presentationml/2006/main" xmlns:r="http://schemas.openxmlformats.org/officeDocument/2006/relationships">
   <p:cSld>
     <p:spTree>
@@ -5649,7 +6018,7 @@
           <a:lstStyle/>
           <a:p>
             <a:pPr>
-              <a:defRPr sz="1100" b="1">
+              <a:defRPr sz="1300" b="1">
                 <a:solidFill>
                   <a:srgbClr val="38BDF8"/>
                 </a:solidFill>
@@ -5661,7 +6030,7 @@
           </a:p>
           <a:p>
             <a:pPr>
-              <a:defRPr sz="2200" b="1">
+              <a:defRPr sz="2400" b="1">
                 <a:solidFill>
                   <a:srgbClr val="F8FAFC"/>
                 </a:solidFill>
@@ -5711,11 +6080,11 @@
           </a:fontRef>
         </p:style>
         <p:txBody>
-          <a:bodyPr rtlCol="0" anchor="ctr" wrap="square" lIns="228600" rIns="228600" tIns="182880" bIns="137160"/>
+          <a:bodyPr rtlCol="0" anchor="ctr" wrap="square" lIns="274320" rIns="274320" tIns="228600" bIns="182880"/>
           <a:lstStyle/>
           <a:p>
             <a:pPr algn="ctr">
-              <a:defRPr sz="1800" b="1">
+              <a:defRPr sz="1900" b="1">
                 <a:solidFill>
                   <a:srgbClr val="F87171"/>
                 </a:solidFill>
@@ -5727,7 +6096,7 @@
           </a:p>
           <a:p>
             <a:pPr>
-              <a:defRPr sz="1300" b="1">
+              <a:defRPr sz="1400" b="1">
                 <a:solidFill>
                   <a:srgbClr val="F8FAFC"/>
                 </a:solidFill>
@@ -5739,9 +6108,9 @@
           </a:p>
           <a:p>
             <a:pPr>
-              <a:defRPr sz="1150">
-                <a:solidFill>
-                  <a:srgbClr val="94A3B8"/>
+              <a:defRPr sz="1300">
+                <a:solidFill>
+                  <a:srgbClr val="CBD5E1"/>
                 </a:solidFill>
               </a:defRPr>
             </a:pPr>
@@ -5751,7 +6120,7 @@
           </a:p>
           <a:p>
             <a:pPr>
-              <a:defRPr sz="1300" b="1">
+              <a:defRPr sz="1400" b="1">
                 <a:solidFill>
                   <a:srgbClr val="F8FAFC"/>
                 </a:solidFill>
@@ -5763,9 +6132,9 @@
           </a:p>
           <a:p>
             <a:pPr>
-              <a:defRPr sz="1150">
-                <a:solidFill>
-                  <a:srgbClr val="94A3B8"/>
+              <a:defRPr sz="1300">
+                <a:solidFill>
+                  <a:srgbClr val="CBD5E1"/>
                 </a:solidFill>
               </a:defRPr>
             </a:pPr>
@@ -5775,7 +6144,7 @@
           </a:p>
           <a:p>
             <a:pPr>
-              <a:defRPr sz="1300" b="1">
+              <a:defRPr sz="1400" b="1">
                 <a:solidFill>
                   <a:srgbClr val="F8FAFC"/>
                 </a:solidFill>
@@ -5787,9 +6156,9 @@
           </a:p>
           <a:p>
             <a:pPr>
-              <a:defRPr sz="1150">
-                <a:solidFill>
-                  <a:srgbClr val="94A3B8"/>
+              <a:defRPr sz="1300">
+                <a:solidFill>
+                  <a:srgbClr val="CBD5E1"/>
                 </a:solidFill>
               </a:defRPr>
             </a:pPr>
@@ -5799,7 +6168,7 @@
           </a:p>
           <a:p>
             <a:pPr>
-              <a:defRPr sz="1300" b="1">
+              <a:defRPr sz="1400" b="1">
                 <a:solidFill>
                   <a:srgbClr val="F8FAFC"/>
                 </a:solidFill>
@@ -5811,9 +6180,9 @@
           </a:p>
           <a:p>
             <a:pPr>
-              <a:defRPr sz="1150">
-                <a:solidFill>
-                  <a:srgbClr val="94A3B8"/>
+              <a:defRPr sz="1300">
+                <a:solidFill>
+                  <a:srgbClr val="CBD5E1"/>
                 </a:solidFill>
               </a:defRPr>
             </a:pPr>
@@ -5831,7 +6200,7 @@
 </p:sld>
 </file>
 
-<file path=ppt/slides/slide8.xml><?xml version="1.0" encoding="utf-8"?>
+<file path=ppt/slides/slide9.xml><?xml version="1.0" encoding="utf-8"?>
 <p:sld xmlns:a="http://schemas.openxmlformats.org/drawingml/2006/main" xmlns:p="http://schemas.openxmlformats.org/presentationml/2006/main" xmlns:r="http://schemas.openxmlformats.org/officeDocument/2006/relationships">
   <p:cSld>
     <p:spTree>
@@ -5907,7 +6276,7 @@
           <a:lstStyle/>
           <a:p>
             <a:pPr>
-              <a:defRPr sz="1100" b="1">
+              <a:defRPr sz="1300" b="1">
                 <a:solidFill>
                   <a:srgbClr val="38BDF8"/>
                 </a:solidFill>
@@ -5919,7 +6288,7 @@
           </a:p>
           <a:p>
             <a:pPr>
-              <a:defRPr sz="2200" b="1">
+              <a:defRPr sz="2400" b="1">
                 <a:solidFill>
                   <a:srgbClr val="F8FAFC"/>
                 </a:solidFill>
@@ -5969,11 +6338,11 @@
           </a:fontRef>
         </p:style>
         <p:txBody>
-          <a:bodyPr rtlCol="0" anchor="ctr" wrap="square" lIns="228600" rIns="228600" tIns="182880" bIns="137160"/>
+          <a:bodyPr rtlCol="0" anchor="ctr" wrap="square" lIns="274320" rIns="274320" tIns="228600" bIns="182880"/>
           <a:lstStyle/>
           <a:p>
             <a:pPr algn="ctr">
-              <a:defRPr sz="2000" b="1">
+              <a:defRPr sz="2200" b="1">
                 <a:solidFill>
                   <a:srgbClr val="38BDF8"/>
                 </a:solidFill>
@@ -5985,7 +6354,7 @@
           </a:p>
           <a:p>
             <a:pPr>
-              <a:defRPr sz="1500" b="1">
+              <a:defRPr sz="1600" b="1">
                 <a:solidFill>
                   <a:srgbClr val="F8FAFC"/>
                 </a:solidFill>
@@ -5997,7 +6366,7 @@
           </a:p>
           <a:p>
             <a:pPr>
-              <a:defRPr sz="1400" b="0">
+              <a:defRPr sz="1500" b="0">
                 <a:solidFill>
                   <a:srgbClr val="4ADE80"/>
                 </a:solidFill>
@@ -6009,7 +6378,7 @@
           </a:p>
           <a:p>
             <a:pPr>
-              <a:defRPr sz="1400" b="0">
+              <a:defRPr sz="1500" b="0">
                 <a:solidFill>
                   <a:srgbClr val="FBBF24"/>
                 </a:solidFill>
@@ -6021,7 +6390,7 @@
           </a:p>
           <a:p>
             <a:pPr>
-              <a:defRPr sz="1600" b="1">
+              <a:defRPr sz="1700" b="1">
                 <a:solidFill>
                   <a:srgbClr val="F8FAFC"/>
                 </a:solidFill>

</xml_diff>